<commit_message>
Optimize pitch deck for Google Slides (Arial, autofit, speaker notes) + import guide
</commit_message>
<xml_diff>
--- a/pitch/acres_pitch_deck.pptx
+++ b/pitch/acres_pitch_deck.pptx
@@ -118,6 +118,1336 @@
     </a:lvl9pPr>
   </p:defaultTextStyle>
 </p:presentation>
+</file>
+
+<file path=ppt/notesMasters/notesMaster1.xml><?xml version="1.0" encoding="utf-8"?>
+<p:notesMaster xmlns:a="http://schemas.openxmlformats.org/drawingml/2006/main" xmlns:p="http://schemas.openxmlformats.org/presentationml/2006/main" xmlns:r="http://schemas.openxmlformats.org/officeDocument/2006/relationships">
+  <p:cSld>
+    <p:bg>
+      <p:bgRef idx="1001">
+        <a:schemeClr val="bg1"/>
+      </p:bgRef>
+    </p:bg>
+    <p:spTree>
+      <p:nvGrpSpPr>
+        <p:cNvPr id="1" name=""/>
+        <p:cNvGrpSpPr/>
+        <p:nvPr/>
+      </p:nvGrpSpPr>
+      <p:grpSpPr>
+        <a:xfrm>
+          <a:off x="0" y="0"/>
+          <a:ext cx="0" cy="0"/>
+          <a:chOff x="0" y="0"/>
+          <a:chExt cx="0" cy="0"/>
+        </a:xfrm>
+      </p:grpSpPr>
+      <p:sp>
+        <p:nvSpPr>
+          <p:cNvPr id="2" name="Header Placeholder 1"/>
+          <p:cNvSpPr>
+            <a:spLocks noGrp="1"/>
+          </p:cNvSpPr>
+          <p:nvPr>
+            <p:ph type="hdr" sz="quarter"/>
+          </p:nvPr>
+        </p:nvSpPr>
+        <p:spPr>
+          <a:xfrm>
+            <a:off x="0" y="0"/>
+            <a:ext cx="2971800" cy="457200"/>
+          </a:xfrm>
+          <a:prstGeom prst="rect">
+            <a:avLst/>
+          </a:prstGeom>
+        </p:spPr>
+        <p:txBody>
+          <a:bodyPr vert="horz" lIns="91440" tIns="45720" rIns="91440" bIns="45720" rtlCol="0"/>
+          <a:lstStyle>
+            <a:lvl1pPr algn="l">
+              <a:defRPr sz="1200"/>
+            </a:lvl1pPr>
+          </a:lstStyle>
+          <a:p>
+            <a:endParaRPr lang="en-US"/>
+          </a:p>
+        </p:txBody>
+      </p:sp>
+      <p:sp>
+        <p:nvSpPr>
+          <p:cNvPr id="3" name="Date Placeholder 2"/>
+          <p:cNvSpPr>
+            <a:spLocks noGrp="1"/>
+          </p:cNvSpPr>
+          <p:nvPr>
+            <p:ph type="dt" idx="1"/>
+          </p:nvPr>
+        </p:nvSpPr>
+        <p:spPr>
+          <a:xfrm>
+            <a:off x="3884613" y="0"/>
+            <a:ext cx="2971800" cy="457200"/>
+          </a:xfrm>
+          <a:prstGeom prst="rect">
+            <a:avLst/>
+          </a:prstGeom>
+        </p:spPr>
+        <p:txBody>
+          <a:bodyPr vert="horz" lIns="91440" tIns="45720" rIns="91440" bIns="45720" rtlCol="0"/>
+          <a:lstStyle>
+            <a:lvl1pPr algn="r">
+              <a:defRPr sz="1200"/>
+            </a:lvl1pPr>
+          </a:lstStyle>
+          <a:p>
+            <a:fld id="{0F89C1C7-3DCD-1040-A9CF-14679D8B5DDD}" type="datetimeFigureOut">
+              <a:rPr lang="en-US" smtClean="0"/>
+              <a:t>10/17/16</a:t>
+            </a:fld>
+            <a:endParaRPr lang="en-US"/>
+          </a:p>
+        </p:txBody>
+      </p:sp>
+      <p:sp>
+        <p:nvSpPr>
+          <p:cNvPr id="4" name="Slide Image Placeholder 3"/>
+          <p:cNvSpPr>
+            <a:spLocks noGrp="1" noRot="1" noChangeAspect="1"/>
+          </p:cNvSpPr>
+          <p:nvPr>
+            <p:ph type="sldImg" idx="2"/>
+          </p:nvPr>
+        </p:nvSpPr>
+        <p:spPr>
+          <a:xfrm>
+            <a:off x="1143000" y="685800"/>
+            <a:ext cx="4572000" cy="3429000"/>
+          </a:xfrm>
+          <a:prstGeom prst="rect">
+            <a:avLst/>
+          </a:prstGeom>
+          <a:noFill/>
+          <a:ln w="12700">
+            <a:solidFill>
+              <a:prstClr val="black"/>
+            </a:solidFill>
+          </a:ln>
+        </p:spPr>
+        <p:txBody>
+          <a:bodyPr vert="horz" lIns="91440" tIns="45720" rIns="91440" bIns="45720" rtlCol="0" anchor="ctr"/>
+          <a:lstStyle/>
+          <a:p>
+            <a:endParaRPr lang="en-US"/>
+          </a:p>
+        </p:txBody>
+      </p:sp>
+      <p:sp>
+        <p:nvSpPr>
+          <p:cNvPr id="5" name="Notes Placeholder 4"/>
+          <p:cNvSpPr>
+            <a:spLocks noGrp="1"/>
+          </p:cNvSpPr>
+          <p:nvPr>
+            <p:ph type="body" sz="quarter" idx="3"/>
+          </p:nvPr>
+        </p:nvSpPr>
+        <p:spPr>
+          <a:xfrm>
+            <a:off x="685800" y="4343400"/>
+            <a:ext cx="5486400" cy="4114800"/>
+          </a:xfrm>
+          <a:prstGeom prst="rect">
+            <a:avLst/>
+          </a:prstGeom>
+        </p:spPr>
+        <p:txBody>
+          <a:bodyPr vert="horz" lIns="91440" tIns="45720" rIns="91440" bIns="45720" rtlCol="0"/>
+          <a:lstStyle/>
+          <a:p>
+            <a:pPr lvl="0"/>
+            <a:r>
+              <a:rPr lang="en-US" smtClean="0"/>
+              <a:t>Click to edit Master text styles</a:t>
+            </a:r>
+          </a:p>
+          <a:p>
+            <a:pPr lvl="1"/>
+            <a:r>
+              <a:rPr lang="en-US" smtClean="0"/>
+              <a:t>Second level</a:t>
+            </a:r>
+          </a:p>
+          <a:p>
+            <a:pPr lvl="2"/>
+            <a:r>
+              <a:rPr lang="en-US" smtClean="0"/>
+              <a:t>Third level</a:t>
+            </a:r>
+          </a:p>
+          <a:p>
+            <a:pPr lvl="3"/>
+            <a:r>
+              <a:rPr lang="en-US" smtClean="0"/>
+              <a:t>Fourth level</a:t>
+            </a:r>
+          </a:p>
+          <a:p>
+            <a:pPr lvl="4"/>
+            <a:r>
+              <a:rPr lang="en-US" smtClean="0"/>
+              <a:t>Fifth level</a:t>
+            </a:r>
+            <a:endParaRPr lang="en-US"/>
+          </a:p>
+        </p:txBody>
+      </p:sp>
+      <p:sp>
+        <p:nvSpPr>
+          <p:cNvPr id="6" name="Footer Placeholder 5"/>
+          <p:cNvSpPr>
+            <a:spLocks noGrp="1"/>
+          </p:cNvSpPr>
+          <p:nvPr>
+            <p:ph type="ftr" sz="quarter" idx="4"/>
+          </p:nvPr>
+        </p:nvSpPr>
+        <p:spPr>
+          <a:xfrm>
+            <a:off x="0" y="8685213"/>
+            <a:ext cx="2971800" cy="457200"/>
+          </a:xfrm>
+          <a:prstGeom prst="rect">
+            <a:avLst/>
+          </a:prstGeom>
+        </p:spPr>
+        <p:txBody>
+          <a:bodyPr vert="horz" lIns="91440" tIns="45720" rIns="91440" bIns="45720" rtlCol="0" anchor="b"/>
+          <a:lstStyle>
+            <a:lvl1pPr algn="l">
+              <a:defRPr sz="1200"/>
+            </a:lvl1pPr>
+          </a:lstStyle>
+          <a:p>
+            <a:endParaRPr lang="en-US"/>
+          </a:p>
+        </p:txBody>
+      </p:sp>
+      <p:sp>
+        <p:nvSpPr>
+          <p:cNvPr id="7" name="Slide Number Placeholder 6"/>
+          <p:cNvSpPr>
+            <a:spLocks noGrp="1"/>
+          </p:cNvSpPr>
+          <p:nvPr>
+            <p:ph type="sldNum" sz="quarter" idx="5"/>
+          </p:nvPr>
+        </p:nvSpPr>
+        <p:spPr>
+          <a:xfrm>
+            <a:off x="3884613" y="8685213"/>
+            <a:ext cx="2971800" cy="457200"/>
+          </a:xfrm>
+          <a:prstGeom prst="rect">
+            <a:avLst/>
+          </a:prstGeom>
+        </p:spPr>
+        <p:txBody>
+          <a:bodyPr vert="horz" lIns="91440" tIns="45720" rIns="91440" bIns="45720" rtlCol="0" anchor="b"/>
+          <a:lstStyle>
+            <a:lvl1pPr algn="r">
+              <a:defRPr sz="1200"/>
+            </a:lvl1pPr>
+          </a:lstStyle>
+          <a:p>
+            <a:fld id="{BB5E49A5-4136-284D-997B-48E1D791AD67}" type="slidenum">
+              <a:rPr lang="en-US" smtClean="0"/>
+              <a:t>‹#›</a:t>
+            </a:fld>
+            <a:endParaRPr lang="en-US"/>
+          </a:p>
+        </p:txBody>
+      </p:sp>
+    </p:spTree>
+    <p:extLst>
+      <p:ext uri="{BB962C8B-B14F-4D97-AF65-F5344CB8AC3E}">
+        <p14:creationId xmlns:p14="http://schemas.microsoft.com/office/powerpoint/2010/main" val="2623252185"/>
+      </p:ext>
+    </p:extLst>
+  </p:cSld>
+  <p:clrMap bg1="lt1" tx1="dk1" bg2="lt2" tx2="dk2" accent1="accent1" accent2="accent2" accent3="accent3" accent4="accent4" accent5="accent5" accent6="accent6" hlink="hlink" folHlink="folHlink"/>
+  <p:notesStyle>
+    <a:lvl1pPr marL="0" algn="l" defTabSz="457200" rtl="0" eaLnBrk="1" latinLnBrk="0" hangingPunct="1">
+      <a:defRPr sz="1200" kern="1200">
+        <a:solidFill>
+          <a:schemeClr val="tx1"/>
+        </a:solidFill>
+        <a:latin typeface="+mn-lt"/>
+        <a:ea typeface="+mn-ea"/>
+        <a:cs typeface="+mn-cs"/>
+      </a:defRPr>
+    </a:lvl1pPr>
+    <a:lvl2pPr marL="457200" algn="l" defTabSz="457200" rtl="0" eaLnBrk="1" latinLnBrk="0" hangingPunct="1">
+      <a:defRPr sz="1200" kern="1200">
+        <a:solidFill>
+          <a:schemeClr val="tx1"/>
+        </a:solidFill>
+        <a:latin typeface="+mn-lt"/>
+        <a:ea typeface="+mn-ea"/>
+        <a:cs typeface="+mn-cs"/>
+      </a:defRPr>
+    </a:lvl2pPr>
+    <a:lvl3pPr marL="914400" algn="l" defTabSz="457200" rtl="0" eaLnBrk="1" latinLnBrk="0" hangingPunct="1">
+      <a:defRPr sz="1200" kern="1200">
+        <a:solidFill>
+          <a:schemeClr val="tx1"/>
+        </a:solidFill>
+        <a:latin typeface="+mn-lt"/>
+        <a:ea typeface="+mn-ea"/>
+        <a:cs typeface="+mn-cs"/>
+      </a:defRPr>
+    </a:lvl3pPr>
+    <a:lvl4pPr marL="1371600" algn="l" defTabSz="457200" rtl="0" eaLnBrk="1" latinLnBrk="0" hangingPunct="1">
+      <a:defRPr sz="1200" kern="1200">
+        <a:solidFill>
+          <a:schemeClr val="tx1"/>
+        </a:solidFill>
+        <a:latin typeface="+mn-lt"/>
+        <a:ea typeface="+mn-ea"/>
+        <a:cs typeface="+mn-cs"/>
+      </a:defRPr>
+    </a:lvl4pPr>
+    <a:lvl5pPr marL="1828800" algn="l" defTabSz="457200" rtl="0" eaLnBrk="1" latinLnBrk="0" hangingPunct="1">
+      <a:defRPr sz="1200" kern="1200">
+        <a:solidFill>
+          <a:schemeClr val="tx1"/>
+        </a:solidFill>
+        <a:latin typeface="+mn-lt"/>
+        <a:ea typeface="+mn-ea"/>
+        <a:cs typeface="+mn-cs"/>
+      </a:defRPr>
+    </a:lvl5pPr>
+    <a:lvl6pPr marL="2286000" algn="l" defTabSz="457200" rtl="0" eaLnBrk="1" latinLnBrk="0" hangingPunct="1">
+      <a:defRPr sz="1200" kern="1200">
+        <a:solidFill>
+          <a:schemeClr val="tx1"/>
+        </a:solidFill>
+        <a:latin typeface="+mn-lt"/>
+        <a:ea typeface="+mn-ea"/>
+        <a:cs typeface="+mn-cs"/>
+      </a:defRPr>
+    </a:lvl6pPr>
+    <a:lvl7pPr marL="2743200" algn="l" defTabSz="457200" rtl="0" eaLnBrk="1" latinLnBrk="0" hangingPunct="1">
+      <a:defRPr sz="1200" kern="1200">
+        <a:solidFill>
+          <a:schemeClr val="tx1"/>
+        </a:solidFill>
+        <a:latin typeface="+mn-lt"/>
+        <a:ea typeface="+mn-ea"/>
+        <a:cs typeface="+mn-cs"/>
+      </a:defRPr>
+    </a:lvl7pPr>
+    <a:lvl8pPr marL="3200400" algn="l" defTabSz="457200" rtl="0" eaLnBrk="1" latinLnBrk="0" hangingPunct="1">
+      <a:defRPr sz="1200" kern="1200">
+        <a:solidFill>
+          <a:schemeClr val="tx1"/>
+        </a:solidFill>
+        <a:latin typeface="+mn-lt"/>
+        <a:ea typeface="+mn-ea"/>
+        <a:cs typeface="+mn-cs"/>
+      </a:defRPr>
+    </a:lvl8pPr>
+    <a:lvl9pPr marL="3657600" algn="l" defTabSz="457200" rtl="0" eaLnBrk="1" latinLnBrk="0" hangingPunct="1">
+      <a:defRPr sz="1200" kern="1200">
+        <a:solidFill>
+          <a:schemeClr val="tx1"/>
+        </a:solidFill>
+        <a:latin typeface="+mn-lt"/>
+        <a:ea typeface="+mn-ea"/>
+        <a:cs typeface="+mn-cs"/>
+      </a:defRPr>
+    </a:lvl9pPr>
+  </p:notesStyle>
+</p:notesMaster>
+</file>
+
+<file path=ppt/notesSlides/notesSlide1.xml><?xml version="1.0" encoding="utf-8"?>
+<p:notes xmlns:a="http://schemas.openxmlformats.org/drawingml/2006/main" xmlns:p="http://schemas.openxmlformats.org/presentationml/2006/main" xmlns:r="http://schemas.openxmlformats.org/officeDocument/2006/relationships">
+  <p:cSld>
+    <p:spTree>
+      <p:nvGrpSpPr>
+        <p:cNvPr id="1" name=""/>
+        <p:cNvGrpSpPr/>
+        <p:nvPr/>
+      </p:nvGrpSpPr>
+      <p:grpSpPr>
+        <a:xfrm>
+          <a:off x="0" y="0"/>
+          <a:ext cx="0" cy="0"/>
+          <a:chOff x="0" y="0"/>
+          <a:chExt cx="0" cy="0"/>
+        </a:xfrm>
+      </p:grpSpPr>
+      <p:sp>
+        <p:nvSpPr>
+          <p:cNvPr id="2" name="Slide Image Placeholder 1"/>
+          <p:cNvSpPr>
+            <a:spLocks noGrp="1"/>
+          </p:cNvSpPr>
+          <p:nvPr>
+            <p:ph type="sldImg" idx="2"/>
+          </p:nvPr>
+        </p:nvSpPr>
+        <p:spPr/>
+      </p:sp>
+      <p:sp>
+        <p:nvSpPr>
+          <p:cNvPr id="3" name="Notes Placeholder 2"/>
+          <p:cNvSpPr>
+            <a:spLocks noGrp="1"/>
+          </p:cNvSpPr>
+          <p:nvPr>
+            <p:ph type="body" idx="3" sz="quarter"/>
+          </p:nvPr>
+        </p:nvSpPr>
+        <p:spPr/>
+        <p:txBody>
+          <a:bodyPr/>
+          <a:lstStyle/>
+          <a:p>
+            <a:r>
+              <a:t>Today, getting ACRES clearance is a manual, multi-step chase. We built a tool that collapses it into one self-serve flow.</a:t>
+            </a:r>
+          </a:p>
+        </p:txBody>
+      </p:sp>
+      <p:sp>
+        <p:nvSpPr>
+          <p:cNvPr id="4" name="Slide Number Placeholder 3"/>
+          <p:cNvSpPr>
+            <a:spLocks noGrp="1"/>
+          </p:cNvSpPr>
+          <p:nvPr>
+            <p:ph type="sldNum" idx="5" sz="quarter"/>
+          </p:nvPr>
+        </p:nvSpPr>
+        <p:spPr/>
+      </p:sp>
+    </p:spTree>
+  </p:cSld>
+  <p:clrMapOvr>
+    <a:masterClrMapping/>
+  </p:clrMapOvr>
+</p:notes>
+</file>
+
+<file path=ppt/notesSlides/notesSlide10.xml><?xml version="1.0" encoding="utf-8"?>
+<p:notes xmlns:a="http://schemas.openxmlformats.org/drawingml/2006/main" xmlns:p="http://schemas.openxmlformats.org/presentationml/2006/main" xmlns:r="http://schemas.openxmlformats.org/officeDocument/2006/relationships">
+  <p:cSld>
+    <p:spTree>
+      <p:nvGrpSpPr>
+        <p:cNvPr id="1" name=""/>
+        <p:cNvGrpSpPr/>
+        <p:nvPr/>
+      </p:nvGrpSpPr>
+      <p:grpSpPr>
+        <a:xfrm>
+          <a:off x="0" y="0"/>
+          <a:ext cx="0" cy="0"/>
+          <a:chOff x="0" y="0"/>
+          <a:chExt cx="0" cy="0"/>
+        </a:xfrm>
+      </p:grpSpPr>
+      <p:sp>
+        <p:nvSpPr>
+          <p:cNvPr id="2" name="Slide Image Placeholder 1"/>
+          <p:cNvSpPr>
+            <a:spLocks noGrp="1"/>
+          </p:cNvSpPr>
+          <p:nvPr>
+            <p:ph type="sldImg" idx="2"/>
+          </p:nvPr>
+        </p:nvSpPr>
+        <p:spPr/>
+      </p:sp>
+      <p:sp>
+        <p:nvSpPr>
+          <p:cNvPr id="3" name="Notes Placeholder 2"/>
+          <p:cNvSpPr>
+            <a:spLocks noGrp="1"/>
+          </p:cNvSpPr>
+          <p:nvPr>
+            <p:ph type="body" idx="3" sz="quarter"/>
+          </p:nvPr>
+        </p:nvSpPr>
+        <p:spPr/>
+        <p:txBody>
+          <a:bodyPr/>
+          <a:lstStyle/>
+          <a:p>
+            <a:r>
+              <a:t>Faster, more accurate, less admin, safer and scalable across projects.</a:t>
+            </a:r>
+          </a:p>
+        </p:txBody>
+      </p:sp>
+      <p:sp>
+        <p:nvSpPr>
+          <p:cNvPr id="4" name="Slide Number Placeholder 3"/>
+          <p:cNvSpPr>
+            <a:spLocks noGrp="1"/>
+          </p:cNvSpPr>
+          <p:nvPr>
+            <p:ph type="sldNum" idx="5" sz="quarter"/>
+          </p:nvPr>
+        </p:nvSpPr>
+        <p:spPr/>
+      </p:sp>
+    </p:spTree>
+  </p:cSld>
+  <p:clrMapOvr>
+    <a:masterClrMapping/>
+  </p:clrMapOvr>
+</p:notes>
+</file>
+
+<file path=ppt/notesSlides/notesSlide11.xml><?xml version="1.0" encoding="utf-8"?>
+<p:notes xmlns:a="http://schemas.openxmlformats.org/drawingml/2006/main" xmlns:p="http://schemas.openxmlformats.org/presentationml/2006/main" xmlns:r="http://schemas.openxmlformats.org/officeDocument/2006/relationships">
+  <p:cSld>
+    <p:spTree>
+      <p:nvGrpSpPr>
+        <p:cNvPr id="1" name=""/>
+        <p:cNvGrpSpPr/>
+        <p:nvPr/>
+      </p:nvGrpSpPr>
+      <p:grpSpPr>
+        <a:xfrm>
+          <a:off x="0" y="0"/>
+          <a:ext cx="0" cy="0"/>
+          <a:chOff x="0" y="0"/>
+          <a:chExt cx="0" cy="0"/>
+        </a:xfrm>
+      </p:grpSpPr>
+      <p:sp>
+        <p:nvSpPr>
+          <p:cNvPr id="2" name="Slide Image Placeholder 1"/>
+          <p:cNvSpPr>
+            <a:spLocks noGrp="1"/>
+          </p:cNvSpPr>
+          <p:nvPr>
+            <p:ph type="sldImg" idx="2"/>
+          </p:nvPr>
+        </p:nvSpPr>
+        <p:spPr/>
+      </p:sp>
+      <p:sp>
+        <p:nvSpPr>
+          <p:cNvPr id="3" name="Notes Placeholder 2"/>
+          <p:cNvSpPr>
+            <a:spLocks noGrp="1"/>
+          </p:cNvSpPr>
+          <p:nvPr>
+            <p:ph type="body" idx="3" sz="quarter"/>
+          </p:nvPr>
+        </p:nvSpPr>
+        <p:spPr/>
+        <p:txBody>
+          <a:bodyPr/>
+          <a:lstStyle/>
+          <a:p>
+            <a:r>
+              <a:t>This is a working prototype, tested on real scanned clearance documents.</a:t>
+            </a:r>
+          </a:p>
+        </p:txBody>
+      </p:sp>
+      <p:sp>
+        <p:nvSpPr>
+          <p:cNvPr id="4" name="Slide Number Placeholder 3"/>
+          <p:cNvSpPr>
+            <a:spLocks noGrp="1"/>
+          </p:cNvSpPr>
+          <p:nvPr>
+            <p:ph type="sldNum" idx="5" sz="quarter"/>
+          </p:nvPr>
+        </p:nvSpPr>
+        <p:spPr/>
+      </p:sp>
+    </p:spTree>
+  </p:cSld>
+  <p:clrMapOvr>
+    <a:masterClrMapping/>
+  </p:clrMapOvr>
+</p:notes>
+</file>
+
+<file path=ppt/notesSlides/notesSlide12.xml><?xml version="1.0" encoding="utf-8"?>
+<p:notes xmlns:a="http://schemas.openxmlformats.org/drawingml/2006/main" xmlns:p="http://schemas.openxmlformats.org/presentationml/2006/main" xmlns:r="http://schemas.openxmlformats.org/officeDocument/2006/relationships">
+  <p:cSld>
+    <p:spTree>
+      <p:nvGrpSpPr>
+        <p:cNvPr id="1" name=""/>
+        <p:cNvGrpSpPr/>
+        <p:nvPr/>
+      </p:nvGrpSpPr>
+      <p:grpSpPr>
+        <a:xfrm>
+          <a:off x="0" y="0"/>
+          <a:ext cx="0" cy="0"/>
+          <a:chOff x="0" y="0"/>
+          <a:chExt cx="0" cy="0"/>
+        </a:xfrm>
+      </p:grpSpPr>
+      <p:sp>
+        <p:nvSpPr>
+          <p:cNvPr id="2" name="Slide Image Placeholder 1"/>
+          <p:cNvSpPr>
+            <a:spLocks noGrp="1"/>
+          </p:cNvSpPr>
+          <p:nvPr>
+            <p:ph type="sldImg" idx="2"/>
+          </p:nvPr>
+        </p:nvSpPr>
+        <p:spPr/>
+      </p:sp>
+      <p:sp>
+        <p:nvSpPr>
+          <p:cNvPr id="3" name="Notes Placeholder 2"/>
+          <p:cNvSpPr>
+            <a:spLocks noGrp="1"/>
+          </p:cNvSpPr>
+          <p:nvPr>
+            <p:ph type="body" idx="3" sz="quarter"/>
+          </p:nvPr>
+        </p:nvSpPr>
+        <p:spPr/>
+        <p:txBody>
+          <a:bodyPr/>
+          <a:lstStyle/>
+          <a:p>
+            <a:r>
+              <a:t>Next: real email sending, live register + SSO, audit trail and analytics.</a:t>
+            </a:r>
+          </a:p>
+        </p:txBody>
+      </p:sp>
+      <p:sp>
+        <p:nvSpPr>
+          <p:cNvPr id="4" name="Slide Number Placeholder 3"/>
+          <p:cNvSpPr>
+            <a:spLocks noGrp="1"/>
+          </p:cNvSpPr>
+          <p:nvPr>
+            <p:ph type="sldNum" idx="5" sz="quarter"/>
+          </p:nvPr>
+        </p:nvSpPr>
+        <p:spPr/>
+      </p:sp>
+    </p:spTree>
+  </p:cSld>
+  <p:clrMapOvr>
+    <a:masterClrMapping/>
+  </p:clrMapOvr>
+</p:notes>
+</file>
+
+<file path=ppt/notesSlides/notesSlide13.xml><?xml version="1.0" encoding="utf-8"?>
+<p:notes xmlns:a="http://schemas.openxmlformats.org/drawingml/2006/main" xmlns:p="http://schemas.openxmlformats.org/presentationml/2006/main" xmlns:r="http://schemas.openxmlformats.org/officeDocument/2006/relationships">
+  <p:cSld>
+    <p:spTree>
+      <p:nvGrpSpPr>
+        <p:cNvPr id="1" name=""/>
+        <p:cNvGrpSpPr/>
+        <p:nvPr/>
+      </p:nvGrpSpPr>
+      <p:grpSpPr>
+        <a:xfrm>
+          <a:off x="0" y="0"/>
+          <a:ext cx="0" cy="0"/>
+          <a:chOff x="0" y="0"/>
+          <a:chExt cx="0" cy="0"/>
+        </a:xfrm>
+      </p:grpSpPr>
+      <p:sp>
+        <p:nvSpPr>
+          <p:cNvPr id="2" name="Slide Image Placeholder 1"/>
+          <p:cNvSpPr>
+            <a:spLocks noGrp="1"/>
+          </p:cNvSpPr>
+          <p:nvPr>
+            <p:ph type="sldImg" idx="2"/>
+          </p:nvPr>
+        </p:nvSpPr>
+        <p:spPr/>
+      </p:sp>
+      <p:sp>
+        <p:nvSpPr>
+          <p:cNvPr id="3" name="Notes Placeholder 2"/>
+          <p:cNvSpPr>
+            <a:spLocks noGrp="1"/>
+          </p:cNvSpPr>
+          <p:nvPr>
+            <p:ph type="body" idx="3" sz="quarter"/>
+          </p:nvPr>
+        </p:nvSpPr>
+        <p:spPr/>
+        <p:txBody>
+          <a:bodyPr/>
+          <a:lstStyle/>
+          <a:p>
+            <a:r>
+              <a:t>Sensitive data and model accuracy are handled with local AI and deterministic parsing.</a:t>
+            </a:r>
+          </a:p>
+        </p:txBody>
+      </p:sp>
+      <p:sp>
+        <p:nvSpPr>
+          <p:cNvPr id="4" name="Slide Number Placeholder 3"/>
+          <p:cNvSpPr>
+            <a:spLocks noGrp="1"/>
+          </p:cNvSpPr>
+          <p:nvPr>
+            <p:ph type="sldNum" idx="5" sz="quarter"/>
+          </p:nvPr>
+        </p:nvSpPr>
+        <p:spPr/>
+      </p:sp>
+    </p:spTree>
+  </p:cSld>
+  <p:clrMapOvr>
+    <a:masterClrMapping/>
+  </p:clrMapOvr>
+</p:notes>
+</file>
+
+<file path=ppt/notesSlides/notesSlide14.xml><?xml version="1.0" encoding="utf-8"?>
+<p:notes xmlns:a="http://schemas.openxmlformats.org/drawingml/2006/main" xmlns:p="http://schemas.openxmlformats.org/presentationml/2006/main" xmlns:r="http://schemas.openxmlformats.org/officeDocument/2006/relationships">
+  <p:cSld>
+    <p:spTree>
+      <p:nvGrpSpPr>
+        <p:cNvPr id="1" name=""/>
+        <p:cNvGrpSpPr/>
+        <p:nvPr/>
+      </p:nvGrpSpPr>
+      <p:grpSpPr>
+        <a:xfrm>
+          <a:off x="0" y="0"/>
+          <a:ext cx="0" cy="0"/>
+          <a:chOff x="0" y="0"/>
+          <a:chExt cx="0" cy="0"/>
+        </a:xfrm>
+      </p:grpSpPr>
+      <p:sp>
+        <p:nvSpPr>
+          <p:cNvPr id="2" name="Slide Image Placeholder 1"/>
+          <p:cNvSpPr>
+            <a:spLocks noGrp="1"/>
+          </p:cNvSpPr>
+          <p:nvPr>
+            <p:ph type="sldImg" idx="2"/>
+          </p:nvPr>
+        </p:nvSpPr>
+        <p:spPr/>
+      </p:sp>
+      <p:sp>
+        <p:nvSpPr>
+          <p:cNvPr id="3" name="Notes Placeholder 2"/>
+          <p:cNvSpPr>
+            <a:spLocks noGrp="1"/>
+          </p:cNvSpPr>
+          <p:nvPr>
+            <p:ph type="body" idx="3" sz="quarter"/>
+          </p:nvPr>
+        </p:nvSpPr>
+        <p:spPr/>
+        <p:txBody>
+          <a:bodyPr/>
+          <a:lstStyle/>
+          <a:p>
+            <a:r>
+              <a:t>The ask: pilot with one project team and measure the before/after.</a:t>
+            </a:r>
+          </a:p>
+        </p:txBody>
+      </p:sp>
+      <p:sp>
+        <p:nvSpPr>
+          <p:cNvPr id="4" name="Slide Number Placeholder 3"/>
+          <p:cNvSpPr>
+            <a:spLocks noGrp="1"/>
+          </p:cNvSpPr>
+          <p:nvPr>
+            <p:ph type="sldNum" idx="5" sz="quarter"/>
+          </p:nvPr>
+        </p:nvSpPr>
+        <p:spPr/>
+      </p:sp>
+    </p:spTree>
+  </p:cSld>
+  <p:clrMapOvr>
+    <a:masterClrMapping/>
+  </p:clrMapOvr>
+</p:notes>
+</file>
+
+<file path=ppt/notesSlides/notesSlide2.xml><?xml version="1.0" encoding="utf-8"?>
+<p:notes xmlns:a="http://schemas.openxmlformats.org/drawingml/2006/main" xmlns:p="http://schemas.openxmlformats.org/presentationml/2006/main" xmlns:r="http://schemas.openxmlformats.org/officeDocument/2006/relationships">
+  <p:cSld>
+    <p:spTree>
+      <p:nvGrpSpPr>
+        <p:cNvPr id="1" name=""/>
+        <p:cNvGrpSpPr/>
+        <p:nvPr/>
+      </p:nvGrpSpPr>
+      <p:grpSpPr>
+        <a:xfrm>
+          <a:off x="0" y="0"/>
+          <a:ext cx="0" cy="0"/>
+          <a:chOff x="0" y="0"/>
+          <a:chExt cx="0" cy="0"/>
+        </a:xfrm>
+      </p:grpSpPr>
+      <p:sp>
+        <p:nvSpPr>
+          <p:cNvPr id="2" name="Slide Image Placeholder 1"/>
+          <p:cNvSpPr>
+            <a:spLocks noGrp="1"/>
+          </p:cNvSpPr>
+          <p:nvPr>
+            <p:ph type="sldImg" idx="2"/>
+          </p:nvPr>
+        </p:nvSpPr>
+        <p:spPr/>
+      </p:sp>
+      <p:sp>
+        <p:nvSpPr>
+          <p:cNvPr id="3" name="Notes Placeholder 2"/>
+          <p:cNvSpPr>
+            <a:spLocks noGrp="1"/>
+          </p:cNvSpPr>
+          <p:nvPr>
+            <p:ph type="body" idx="3" sz="quarter"/>
+          </p:nvPr>
+        </p:nvSpPr>
+        <p:spPr/>
+        <p:txBody>
+          <a:bodyPr/>
+          <a:lstStyle/>
+          <a:p>
+            <a:r>
+              <a:t>Every hop and every typo adds days. Applicants decode categories and MSD numbers by hand, then chase project details.</a:t>
+            </a:r>
+          </a:p>
+        </p:txBody>
+      </p:sp>
+      <p:sp>
+        <p:nvSpPr>
+          <p:cNvPr id="4" name="Slide Number Placeholder 3"/>
+          <p:cNvSpPr>
+            <a:spLocks noGrp="1"/>
+          </p:cNvSpPr>
+          <p:nvPr>
+            <p:ph type="sldNum" idx="5" sz="quarter"/>
+          </p:nvPr>
+        </p:nvSpPr>
+        <p:spPr/>
+      </p:sp>
+    </p:spTree>
+  </p:cSld>
+  <p:clrMapOvr>
+    <a:masterClrMapping/>
+  </p:clrMapOvr>
+</p:notes>
+</file>
+
+<file path=ppt/notesSlides/notesSlide3.xml><?xml version="1.0" encoding="utf-8"?>
+<p:notes xmlns:a="http://schemas.openxmlformats.org/drawingml/2006/main" xmlns:p="http://schemas.openxmlformats.org/presentationml/2006/main" xmlns:r="http://schemas.openxmlformats.org/officeDocument/2006/relationships">
+  <p:cSld>
+    <p:spTree>
+      <p:nvGrpSpPr>
+        <p:cNvPr id="1" name=""/>
+        <p:cNvGrpSpPr/>
+        <p:nvPr/>
+      </p:nvGrpSpPr>
+      <p:grpSpPr>
+        <a:xfrm>
+          <a:off x="0" y="0"/>
+          <a:ext cx="0" cy="0"/>
+          <a:chOff x="0" y="0"/>
+          <a:chExt cx="0" cy="0"/>
+        </a:xfrm>
+      </p:grpSpPr>
+      <p:sp>
+        <p:nvSpPr>
+          <p:cNvPr id="2" name="Slide Image Placeholder 1"/>
+          <p:cNvSpPr>
+            <a:spLocks noGrp="1"/>
+          </p:cNvSpPr>
+          <p:nvPr>
+            <p:ph type="sldImg" idx="2"/>
+          </p:nvPr>
+        </p:nvSpPr>
+        <p:spPr/>
+      </p:sp>
+      <p:sp>
+        <p:nvSpPr>
+          <p:cNvPr id="3" name="Notes Placeholder 2"/>
+          <p:cNvSpPr>
+            <a:spLocks noGrp="1"/>
+          </p:cNvSpPr>
+          <p:nvPr>
+            <p:ph type="body" idx="3" sz="quarter"/>
+          </p:nvPr>
+        </p:nvSpPr>
+        <p:spPr/>
+        <p:txBody>
+          <a:bodyPr/>
+          <a:lstStyle/>
+          <a:p>
+            <a:r>
+              <a:t>The real cost is time: waiting, rework loops, and risk from scattered sensitive data.</a:t>
+            </a:r>
+          </a:p>
+        </p:txBody>
+      </p:sp>
+      <p:sp>
+        <p:nvSpPr>
+          <p:cNvPr id="4" name="Slide Number Placeholder 3"/>
+          <p:cNvSpPr>
+            <a:spLocks noGrp="1"/>
+          </p:cNvSpPr>
+          <p:nvPr>
+            <p:ph type="sldNum" idx="5" sz="quarter"/>
+          </p:nvPr>
+        </p:nvSpPr>
+        <p:spPr/>
+      </p:sp>
+    </p:spTree>
+  </p:cSld>
+  <p:clrMapOvr>
+    <a:masterClrMapping/>
+  </p:clrMapOvr>
+</p:notes>
+</file>
+
+<file path=ppt/notesSlides/notesSlide4.xml><?xml version="1.0" encoding="utf-8"?>
+<p:notes xmlns:a="http://schemas.openxmlformats.org/drawingml/2006/main" xmlns:p="http://schemas.openxmlformats.org/presentationml/2006/main" xmlns:r="http://schemas.openxmlformats.org/officeDocument/2006/relationships">
+  <p:cSld>
+    <p:spTree>
+      <p:nvGrpSpPr>
+        <p:cNvPr id="1" name=""/>
+        <p:cNvGrpSpPr/>
+        <p:nvPr/>
+      </p:nvGrpSpPr>
+      <p:grpSpPr>
+        <a:xfrm>
+          <a:off x="0" y="0"/>
+          <a:ext cx="0" cy="0"/>
+          <a:chOff x="0" y="0"/>
+          <a:chExt cx="0" cy="0"/>
+        </a:xfrm>
+      </p:grpSpPr>
+      <p:sp>
+        <p:nvSpPr>
+          <p:cNvPr id="2" name="Slide Image Placeholder 1"/>
+          <p:cNvSpPr>
+            <a:spLocks noGrp="1"/>
+          </p:cNvSpPr>
+          <p:nvPr>
+            <p:ph type="sldImg" idx="2"/>
+          </p:nvPr>
+        </p:nvSpPr>
+        <p:spPr/>
+      </p:sp>
+      <p:sp>
+        <p:nvSpPr>
+          <p:cNvPr id="3" name="Notes Placeholder 2"/>
+          <p:cNvSpPr>
+            <a:spLocks noGrp="1"/>
+          </p:cNvSpPr>
+          <p:nvPr>
+            <p:ph type="body" idx="3" sz="quarter"/>
+          </p:nvPr>
+        </p:nvSpPr>
+        <p:spPr/>
+        <p:txBody>
+          <a:bodyPr/>
+          <a:lstStyle/>
+          <a:p>
+            <a:r>
+              <a:t>The middleman disappears — the applicant goes straight to the person who submits for clearance.</a:t>
+            </a:r>
+          </a:p>
+        </p:txBody>
+      </p:sp>
+      <p:sp>
+        <p:nvSpPr>
+          <p:cNvPr id="4" name="Slide Number Placeholder 3"/>
+          <p:cNvSpPr>
+            <a:spLocks noGrp="1"/>
+          </p:cNvSpPr>
+          <p:nvPr>
+            <p:ph type="sldNum" idx="5" sz="quarter"/>
+          </p:nvPr>
+        </p:nvSpPr>
+        <p:spPr/>
+      </p:sp>
+    </p:spTree>
+  </p:cSld>
+  <p:clrMapOvr>
+    <a:masterClrMapping/>
+  </p:clrMapOvr>
+</p:notes>
+</file>
+
+<file path=ppt/notesSlides/notesSlide5.xml><?xml version="1.0" encoding="utf-8"?>
+<p:notes xmlns:a="http://schemas.openxmlformats.org/drawingml/2006/main" xmlns:p="http://schemas.openxmlformats.org/presentationml/2006/main" xmlns:r="http://schemas.openxmlformats.org/officeDocument/2006/relationships">
+  <p:cSld>
+    <p:spTree>
+      <p:nvGrpSpPr>
+        <p:cNvPr id="1" name=""/>
+        <p:cNvGrpSpPr/>
+        <p:nvPr/>
+      </p:nvGrpSpPr>
+      <p:grpSpPr>
+        <a:xfrm>
+          <a:off x="0" y="0"/>
+          <a:ext cx="0" cy="0"/>
+          <a:chOff x="0" y="0"/>
+          <a:chExt cx="0" cy="0"/>
+        </a:xfrm>
+      </p:grpSpPr>
+      <p:sp>
+        <p:nvSpPr>
+          <p:cNvPr id="2" name="Slide Image Placeholder 1"/>
+          <p:cNvSpPr>
+            <a:spLocks noGrp="1"/>
+          </p:cNvSpPr>
+          <p:nvPr>
+            <p:ph type="sldImg" idx="2"/>
+          </p:nvPr>
+        </p:nvSpPr>
+        <p:spPr/>
+      </p:sp>
+      <p:sp>
+        <p:nvSpPr>
+          <p:cNvPr id="3" name="Notes Placeholder 2"/>
+          <p:cNvSpPr>
+            <a:spLocks noGrp="1"/>
+          </p:cNvSpPr>
+          <p:nvPr>
+            <p:ph type="body" idx="3" sz="quarter"/>
+          </p:nvPr>
+        </p:nvSpPr>
+        <p:spPr/>
+        <p:txBody>
+          <a:bodyPr/>
+          <a:lstStyle/>
+          <a:p>
+            <a:r>
+              <a:t>Paste or upload, AI extracts, deterministic code verifies the critical codes, then we assemble and route.</a:t>
+            </a:r>
+          </a:p>
+        </p:txBody>
+      </p:sp>
+      <p:sp>
+        <p:nvSpPr>
+          <p:cNvPr id="4" name="Slide Number Placeholder 3"/>
+          <p:cNvSpPr>
+            <a:spLocks noGrp="1"/>
+          </p:cNvSpPr>
+          <p:nvPr>
+            <p:ph type="sldNum" idx="5" sz="quarter"/>
+          </p:nvPr>
+        </p:nvSpPr>
+        <p:spPr/>
+      </p:sp>
+    </p:spTree>
+  </p:cSld>
+  <p:clrMapOvr>
+    <a:masterClrMapping/>
+  </p:clrMapOvr>
+</p:notes>
+</file>
+
+<file path=ppt/notesSlides/notesSlide6.xml><?xml version="1.0" encoding="utf-8"?>
+<p:notes xmlns:a="http://schemas.openxmlformats.org/drawingml/2006/main" xmlns:p="http://schemas.openxmlformats.org/presentationml/2006/main" xmlns:r="http://schemas.openxmlformats.org/officeDocument/2006/relationships">
+  <p:cSld>
+    <p:spTree>
+      <p:nvGrpSpPr>
+        <p:cNvPr id="1" name=""/>
+        <p:cNvGrpSpPr/>
+        <p:nvPr/>
+      </p:nvGrpSpPr>
+      <p:grpSpPr>
+        <a:xfrm>
+          <a:off x="0" y="0"/>
+          <a:ext cx="0" cy="0"/>
+          <a:chOff x="0" y="0"/>
+          <a:chExt cx="0" cy="0"/>
+        </a:xfrm>
+      </p:grpSpPr>
+      <p:sp>
+        <p:nvSpPr>
+          <p:cNvPr id="2" name="Slide Image Placeholder 1"/>
+          <p:cNvSpPr>
+            <a:spLocks noGrp="1"/>
+          </p:cNvSpPr>
+          <p:nvPr>
+            <p:ph type="sldImg" idx="2"/>
+          </p:nvPr>
+        </p:nvSpPr>
+        <p:spPr/>
+      </p:sp>
+      <p:sp>
+        <p:nvSpPr>
+          <p:cNvPr id="3" name="Notes Placeholder 2"/>
+          <p:cNvSpPr>
+            <a:spLocks noGrp="1"/>
+          </p:cNvSpPr>
+          <p:nvPr>
+            <p:ph type="body" idx="3" sz="quarter"/>
+          </p:nvPr>
+        </p:nvSpPr>
+        <p:spPr/>
+        <p:txBody>
+          <a:bodyPr/>
+          <a:lstStyle/>
+          <a:p>
+            <a:r>
+              <a:t>We deliberately don't trust the model with reference numbers — those are parsed deterministically, so we get AI's flexibility without its hallucinations.</a:t>
+            </a:r>
+          </a:p>
+        </p:txBody>
+      </p:sp>
+      <p:sp>
+        <p:nvSpPr>
+          <p:cNvPr id="4" name="Slide Number Placeholder 3"/>
+          <p:cNvSpPr>
+            <a:spLocks noGrp="1"/>
+          </p:cNvSpPr>
+          <p:nvPr>
+            <p:ph type="sldNum" idx="5" sz="quarter"/>
+          </p:nvPr>
+        </p:nvSpPr>
+        <p:spPr/>
+      </p:sp>
+    </p:spTree>
+  </p:cSld>
+  <p:clrMapOvr>
+    <a:masterClrMapping/>
+  </p:clrMapOvr>
+</p:notes>
+</file>
+
+<file path=ppt/notesSlides/notesSlide7.xml><?xml version="1.0" encoding="utf-8"?>
+<p:notes xmlns:a="http://schemas.openxmlformats.org/drawingml/2006/main" xmlns:p="http://schemas.openxmlformats.org/presentationml/2006/main" xmlns:r="http://schemas.openxmlformats.org/officeDocument/2006/relationships">
+  <p:cSld>
+    <p:spTree>
+      <p:nvGrpSpPr>
+        <p:cNvPr id="1" name=""/>
+        <p:cNvGrpSpPr/>
+        <p:nvPr/>
+      </p:nvGrpSpPr>
+      <p:grpSpPr>
+        <a:xfrm>
+          <a:off x="0" y="0"/>
+          <a:ext cx="0" cy="0"/>
+          <a:chOff x="0" y="0"/>
+          <a:chExt cx="0" cy="0"/>
+        </a:xfrm>
+      </p:grpSpPr>
+      <p:sp>
+        <p:nvSpPr>
+          <p:cNvPr id="2" name="Slide Image Placeholder 1"/>
+          <p:cNvSpPr>
+            <a:spLocks noGrp="1"/>
+          </p:cNvSpPr>
+          <p:nvPr>
+            <p:ph type="sldImg" idx="2"/>
+          </p:nvPr>
+        </p:nvSpPr>
+        <p:spPr/>
+      </p:sp>
+      <p:sp>
+        <p:nvSpPr>
+          <p:cNvPr id="3" name="Notes Placeholder 2"/>
+          <p:cNvSpPr>
+            <a:spLocks noGrp="1"/>
+          </p:cNvSpPr>
+          <p:nvPr>
+            <p:ph type="body" idx="3" sz="quarter"/>
+          </p:nvPr>
+        </p:nvSpPr>
+        <p:spPr/>
+        <p:txBody>
+          <a:bodyPr/>
+          <a:lstStyle/>
+          <a:p>
+            <a:r>
+              <a:t>Everything needed is already built: assistant, OCR, conditionals, validation, auto-fill and routing.</a:t>
+            </a:r>
+          </a:p>
+        </p:txBody>
+      </p:sp>
+      <p:sp>
+        <p:nvSpPr>
+          <p:cNvPr id="4" name="Slide Number Placeholder 3"/>
+          <p:cNvSpPr>
+            <a:spLocks noGrp="1"/>
+          </p:cNvSpPr>
+          <p:nvPr>
+            <p:ph type="sldNum" idx="5" sz="quarter"/>
+          </p:nvPr>
+        </p:nvSpPr>
+        <p:spPr/>
+      </p:sp>
+    </p:spTree>
+  </p:cSld>
+  <p:clrMapOvr>
+    <a:masterClrMapping/>
+  </p:clrMapOvr>
+</p:notes>
+</file>
+
+<file path=ppt/notesSlides/notesSlide8.xml><?xml version="1.0" encoding="utf-8"?>
+<p:notes xmlns:a="http://schemas.openxmlformats.org/drawingml/2006/main" xmlns:p="http://schemas.openxmlformats.org/presentationml/2006/main" xmlns:r="http://schemas.openxmlformats.org/officeDocument/2006/relationships">
+  <p:cSld>
+    <p:spTree>
+      <p:nvGrpSpPr>
+        <p:cNvPr id="1" name=""/>
+        <p:cNvGrpSpPr/>
+        <p:nvPr/>
+      </p:nvGrpSpPr>
+      <p:grpSpPr>
+        <a:xfrm>
+          <a:off x="0" y="0"/>
+          <a:ext cx="0" cy="0"/>
+          <a:chOff x="0" y="0"/>
+          <a:chExt cx="0" cy="0"/>
+        </a:xfrm>
+      </p:grpSpPr>
+      <p:sp>
+        <p:nvSpPr>
+          <p:cNvPr id="2" name="Slide Image Placeholder 1"/>
+          <p:cNvSpPr>
+            <a:spLocks noGrp="1"/>
+          </p:cNvSpPr>
+          <p:nvPr>
+            <p:ph type="sldImg" idx="2"/>
+          </p:nvPr>
+        </p:nvSpPr>
+        <p:spPr/>
+      </p:sp>
+      <p:sp>
+        <p:nvSpPr>
+          <p:cNvPr id="3" name="Notes Placeholder 2"/>
+          <p:cNvSpPr>
+            <a:spLocks noGrp="1"/>
+          </p:cNvSpPr>
+          <p:nvPr>
+            <p:ph type="body" idx="3" sz="quarter"/>
+          </p:nvPr>
+        </p:nvSpPr>
+        <p:spPr/>
+        <p:txBody>
+          <a:bodyPr/>
+          <a:lstStyle/>
+          <a:p>
+            <a:r>
+              <a:t>It doesn't just digitise the form — it removes the middleman and keeps a private, local option.</a:t>
+            </a:r>
+          </a:p>
+        </p:txBody>
+      </p:sp>
+      <p:sp>
+        <p:nvSpPr>
+          <p:cNvPr id="4" name="Slide Number Placeholder 3"/>
+          <p:cNvSpPr>
+            <a:spLocks noGrp="1"/>
+          </p:cNvSpPr>
+          <p:nvPr>
+            <p:ph type="sldNum" idx="5" sz="quarter"/>
+          </p:nvPr>
+        </p:nvSpPr>
+        <p:spPr/>
+      </p:sp>
+    </p:spTree>
+  </p:cSld>
+  <p:clrMapOvr>
+    <a:masterClrMapping/>
+  </p:clrMapOvr>
+</p:notes>
+</file>
+
+<file path=ppt/notesSlides/notesSlide9.xml><?xml version="1.0" encoding="utf-8"?>
+<p:notes xmlns:a="http://schemas.openxmlformats.org/drawingml/2006/main" xmlns:p="http://schemas.openxmlformats.org/presentationml/2006/main" xmlns:r="http://schemas.openxmlformats.org/officeDocument/2006/relationships">
+  <p:cSld>
+    <p:spTree>
+      <p:nvGrpSpPr>
+        <p:cNvPr id="1" name=""/>
+        <p:cNvGrpSpPr/>
+        <p:nvPr/>
+      </p:nvGrpSpPr>
+      <p:grpSpPr>
+        <a:xfrm>
+          <a:off x="0" y="0"/>
+          <a:ext cx="0" cy="0"/>
+          <a:chOff x="0" y="0"/>
+          <a:chExt cx="0" cy="0"/>
+        </a:xfrm>
+      </p:grpSpPr>
+      <p:sp>
+        <p:nvSpPr>
+          <p:cNvPr id="2" name="Slide Image Placeholder 1"/>
+          <p:cNvSpPr>
+            <a:spLocks noGrp="1"/>
+          </p:cNvSpPr>
+          <p:nvPr>
+            <p:ph type="sldImg" idx="2"/>
+          </p:nvPr>
+        </p:nvSpPr>
+        <p:spPr/>
+      </p:sp>
+      <p:sp>
+        <p:nvSpPr>
+          <p:cNvPr id="3" name="Notes Placeholder 2"/>
+          <p:cNvSpPr>
+            <a:spLocks noGrp="1"/>
+          </p:cNvSpPr>
+          <p:nvPr>
+            <p:ph type="body" idx="3" sz="quarter"/>
+          </p:nvPr>
+        </p:nvSpPr>
+        <p:spPr/>
+        <p:txBody>
+          <a:bodyPr/>
+          <a:lstStyle/>
+          <a:p>
+            <a:r>
+              <a:t>Applicants, executives, ops managers and admin teams all benefit.</a:t>
+            </a:r>
+          </a:p>
+        </p:txBody>
+      </p:sp>
+      <p:sp>
+        <p:nvSpPr>
+          <p:cNvPr id="4" name="Slide Number Placeholder 3"/>
+          <p:cNvSpPr>
+            <a:spLocks noGrp="1"/>
+          </p:cNvSpPr>
+          <p:nvPr>
+            <p:ph type="sldNum" idx="5" sz="quarter"/>
+          </p:nvPr>
+        </p:nvSpPr>
+        <p:spPr/>
+      </p:sp>
+    </p:spTree>
+  </p:cSld>
+  <p:clrMapOvr>
+    <a:masterClrMapping/>
+  </p:clrMapOvr>
+</p:notes>
 </file>
 
 <file path=ppt/slideLayouts/slideLayout1.xml><?xml version="1.0" encoding="utf-8"?>
@@ -3163,7 +4493,7 @@
         </p:spPr>
         <p:txBody>
           <a:bodyPr wrap="square" anchor="t">
-            <a:spAutoFit/>
+            <a:normAutofit/>
           </a:bodyPr>
           <a:lstStyle/>
           <a:p>
@@ -3175,7 +4505,7 @@
                 <a:solidFill>
                   <a:srgbClr val="F26522"/>
                 </a:solidFill>
-                <a:latin typeface="Helvetica Neue"/>
+                <a:latin typeface="Arial"/>
               </a:defRPr>
             </a:pPr>
             <a:r>
@@ -3202,7 +4532,7 @@
         </p:spPr>
         <p:txBody>
           <a:bodyPr wrap="square" anchor="t">
-            <a:spAutoFit/>
+            <a:normAutofit/>
           </a:bodyPr>
           <a:lstStyle/>
           <a:p>
@@ -3214,7 +4544,7 @@
                 <a:solidFill>
                   <a:srgbClr val="18418A"/>
                 </a:solidFill>
-                <a:latin typeface="Helvetica Neue"/>
+                <a:latin typeface="Arial"/>
               </a:defRPr>
             </a:pPr>
             <a:r>
@@ -3241,7 +4571,7 @@
         </p:spPr>
         <p:txBody>
           <a:bodyPr wrap="square" anchor="t">
-            <a:spAutoFit/>
+            <a:normAutofit/>
           </a:bodyPr>
           <a:lstStyle/>
           <a:p>
@@ -3253,7 +4583,7 @@
                 <a:solidFill>
                   <a:srgbClr val="2A3442"/>
                 </a:solidFill>
-                <a:latin typeface="Helvetica Neue"/>
+                <a:latin typeface="Arial"/>
               </a:defRPr>
             </a:pPr>
             <a:r>
@@ -3309,7 +4639,7 @@
                 <a:solidFill>
                   <a:srgbClr val="18418A"/>
                 </a:solidFill>
-                <a:latin typeface="Helvetica Neue"/>
+                <a:latin typeface="Arial"/>
               </a:defRPr>
             </a:pPr>
             <a:r>
@@ -3365,7 +4695,7 @@
                 <a:solidFill>
                   <a:srgbClr val="18418A"/>
                 </a:solidFill>
-                <a:latin typeface="Helvetica Neue"/>
+                <a:latin typeface="Arial"/>
               </a:defRPr>
             </a:pPr>
             <a:r>
@@ -3421,7 +4751,7 @@
                 <a:solidFill>
                   <a:srgbClr val="18418A"/>
                 </a:solidFill>
-                <a:latin typeface="Helvetica Neue"/>
+                <a:latin typeface="Arial"/>
               </a:defRPr>
             </a:pPr>
             <a:r>
@@ -3448,7 +4778,7 @@
         </p:spPr>
         <p:txBody>
           <a:bodyPr wrap="square" anchor="t">
-            <a:spAutoFit/>
+            <a:normAutofit/>
           </a:bodyPr>
           <a:lstStyle/>
           <a:p>
@@ -3460,7 +4790,7 @@
                 <a:solidFill>
                   <a:srgbClr val="5A6472"/>
                 </a:solidFill>
-                <a:latin typeface="Helvetica Neue"/>
+                <a:latin typeface="Arial"/>
               </a:defRPr>
             </a:pPr>
             <a:r>
@@ -3549,7 +4879,7 @@
         </p:spPr>
         <p:txBody>
           <a:bodyPr wrap="square" anchor="t">
-            <a:spAutoFit/>
+            <a:normAutofit/>
           </a:bodyPr>
           <a:lstStyle/>
           <a:p>
@@ -3561,7 +4891,7 @@
                 <a:solidFill>
                   <a:srgbClr val="F26522"/>
                 </a:solidFill>
-                <a:latin typeface="Helvetica Neue"/>
+                <a:latin typeface="Arial"/>
               </a:defRPr>
             </a:pPr>
             <a:r>
@@ -3588,7 +4918,7 @@
         </p:spPr>
         <p:txBody>
           <a:bodyPr wrap="square" anchor="t">
-            <a:spAutoFit/>
+            <a:normAutofit/>
           </a:bodyPr>
           <a:lstStyle/>
           <a:p>
@@ -3600,7 +4930,7 @@
                 <a:solidFill>
                   <a:srgbClr val="18418A"/>
                 </a:solidFill>
-                <a:latin typeface="Helvetica Neue"/>
+                <a:latin typeface="Arial"/>
               </a:defRPr>
             </a:pPr>
             <a:r>
@@ -3659,7 +4989,7 @@
                 <a:solidFill>
                   <a:srgbClr val="18418A"/>
                 </a:solidFill>
-                <a:latin typeface="Helvetica Neue"/>
+                <a:latin typeface="Arial"/>
               </a:defRPr>
             </a:pPr>
             <a:r>
@@ -3672,7 +5002,7 @@
                 <a:solidFill>
                   <a:srgbClr val="2A3442"/>
                 </a:solidFill>
-                <a:latin typeface="Helvetica Neue"/>
+                <a:latin typeface="Arial"/>
               </a:defRPr>
             </a:pPr>
             <a:r>
@@ -3775,7 +5105,7 @@
                 <a:solidFill>
                   <a:srgbClr val="18418A"/>
                 </a:solidFill>
-                <a:latin typeface="Helvetica Neue"/>
+                <a:latin typeface="Arial"/>
               </a:defRPr>
             </a:pPr>
             <a:r>
@@ -3788,7 +5118,7 @@
                 <a:solidFill>
                   <a:srgbClr val="2A3442"/>
                 </a:solidFill>
-                <a:latin typeface="Helvetica Neue"/>
+                <a:latin typeface="Arial"/>
               </a:defRPr>
             </a:pPr>
             <a:r>
@@ -3891,7 +5221,7 @@
                 <a:solidFill>
                   <a:srgbClr val="18418A"/>
                 </a:solidFill>
-                <a:latin typeface="Helvetica Neue"/>
+                <a:latin typeface="Arial"/>
               </a:defRPr>
             </a:pPr>
             <a:r>
@@ -3904,7 +5234,7 @@
                 <a:solidFill>
                   <a:srgbClr val="2A3442"/>
                 </a:solidFill>
-                <a:latin typeface="Helvetica Neue"/>
+                <a:latin typeface="Arial"/>
               </a:defRPr>
             </a:pPr>
             <a:r>
@@ -4007,7 +5337,7 @@
                 <a:solidFill>
                   <a:srgbClr val="18418A"/>
                 </a:solidFill>
-                <a:latin typeface="Helvetica Neue"/>
+                <a:latin typeface="Arial"/>
               </a:defRPr>
             </a:pPr>
             <a:r>
@@ -4020,7 +5350,7 @@
                 <a:solidFill>
                   <a:srgbClr val="2A3442"/>
                 </a:solidFill>
-                <a:latin typeface="Helvetica Neue"/>
+                <a:latin typeface="Arial"/>
               </a:defRPr>
             </a:pPr>
             <a:r>
@@ -4091,7 +5421,7 @@
         </p:spPr>
         <p:txBody>
           <a:bodyPr wrap="square" anchor="t">
-            <a:spAutoFit/>
+            <a:normAutofit/>
           </a:bodyPr>
           <a:lstStyle/>
           <a:p>
@@ -4103,7 +5433,7 @@
                 <a:solidFill>
                   <a:srgbClr val="5A6472"/>
                 </a:solidFill>
-                <a:latin typeface="Helvetica Neue"/>
+                <a:latin typeface="Arial"/>
               </a:defRPr>
             </a:pPr>
             <a:r>
@@ -4192,7 +5522,7 @@
         </p:spPr>
         <p:txBody>
           <a:bodyPr wrap="square" anchor="t">
-            <a:spAutoFit/>
+            <a:normAutofit/>
           </a:bodyPr>
           <a:lstStyle/>
           <a:p>
@@ -4204,7 +5534,7 @@
                 <a:solidFill>
                   <a:srgbClr val="F26522"/>
                 </a:solidFill>
-                <a:latin typeface="Helvetica Neue"/>
+                <a:latin typeface="Arial"/>
               </a:defRPr>
             </a:pPr>
             <a:r>
@@ -4231,7 +5561,7 @@
         </p:spPr>
         <p:txBody>
           <a:bodyPr wrap="square" anchor="t">
-            <a:spAutoFit/>
+            <a:normAutofit/>
           </a:bodyPr>
           <a:lstStyle/>
           <a:p>
@@ -4243,7 +5573,7 @@
                 <a:solidFill>
                   <a:srgbClr val="18418A"/>
                 </a:solidFill>
-                <a:latin typeface="Helvetica Neue"/>
+                <a:latin typeface="Arial"/>
               </a:defRPr>
             </a:pPr>
             <a:r>
@@ -4270,7 +5600,7 @@
         </p:spPr>
         <p:txBody>
           <a:bodyPr wrap="square" anchor="t">
-            <a:spAutoFit/>
+            <a:normAutofit/>
           </a:bodyPr>
           <a:lstStyle/>
           <a:p>
@@ -4282,7 +5612,7 @@
                 <a:solidFill>
                   <a:srgbClr val="2A3442"/>
                 </a:solidFill>
-                <a:latin typeface="Helvetica Neue"/>
+                <a:latin typeface="Arial"/>
               </a:defRPr>
             </a:pPr>
             <a:r>
@@ -4298,7 +5628,7 @@
                 <a:solidFill>
                   <a:srgbClr val="2A3442"/>
                 </a:solidFill>
-                <a:latin typeface="Helvetica Neue"/>
+                <a:latin typeface="Arial"/>
               </a:defRPr>
             </a:pPr>
             <a:r>
@@ -4314,7 +5644,7 @@
                 <a:solidFill>
                   <a:srgbClr val="2A3442"/>
                 </a:solidFill>
-                <a:latin typeface="Helvetica Neue"/>
+                <a:latin typeface="Arial"/>
               </a:defRPr>
             </a:pPr>
             <a:r>
@@ -4330,7 +5660,7 @@
                 <a:solidFill>
                   <a:srgbClr val="2A3442"/>
                 </a:solidFill>
-                <a:latin typeface="Helvetica Neue"/>
+                <a:latin typeface="Arial"/>
               </a:defRPr>
             </a:pPr>
             <a:r>
@@ -4357,7 +5687,7 @@
         </p:spPr>
         <p:txBody>
           <a:bodyPr wrap="square" anchor="t">
-            <a:spAutoFit/>
+            <a:normAutofit/>
           </a:bodyPr>
           <a:lstStyle/>
           <a:p>
@@ -4369,7 +5699,7 @@
                 <a:solidFill>
                   <a:srgbClr val="5A6472"/>
                 </a:solidFill>
-                <a:latin typeface="Helvetica Neue"/>
+                <a:latin typeface="Arial"/>
               </a:defRPr>
             </a:pPr>
             <a:r>
@@ -4458,7 +5788,7 @@
         </p:spPr>
         <p:txBody>
           <a:bodyPr wrap="square" anchor="t">
-            <a:spAutoFit/>
+            <a:normAutofit/>
           </a:bodyPr>
           <a:lstStyle/>
           <a:p>
@@ -4470,7 +5800,7 @@
                 <a:solidFill>
                   <a:srgbClr val="F26522"/>
                 </a:solidFill>
-                <a:latin typeface="Helvetica Neue"/>
+                <a:latin typeface="Arial"/>
               </a:defRPr>
             </a:pPr>
             <a:r>
@@ -4497,7 +5827,7 @@
         </p:spPr>
         <p:txBody>
           <a:bodyPr wrap="square" anchor="t">
-            <a:spAutoFit/>
+            <a:normAutofit/>
           </a:bodyPr>
           <a:lstStyle/>
           <a:p>
@@ -4509,7 +5839,7 @@
                 <a:solidFill>
                   <a:srgbClr val="18418A"/>
                 </a:solidFill>
-                <a:latin typeface="Helvetica Neue"/>
+                <a:latin typeface="Arial"/>
               </a:defRPr>
             </a:pPr>
             <a:r>
@@ -4536,7 +5866,7 @@
         </p:spPr>
         <p:txBody>
           <a:bodyPr wrap="square" anchor="t">
-            <a:spAutoFit/>
+            <a:normAutofit/>
           </a:bodyPr>
           <a:lstStyle/>
           <a:p>
@@ -4548,7 +5878,7 @@
                 <a:solidFill>
                   <a:srgbClr val="2A3442"/>
                 </a:solidFill>
-                <a:latin typeface="Helvetica Neue"/>
+                <a:latin typeface="Arial"/>
               </a:defRPr>
             </a:pPr>
             <a:r>
@@ -4564,7 +5894,7 @@
                 <a:solidFill>
                   <a:srgbClr val="2A3442"/>
                 </a:solidFill>
-                <a:latin typeface="Helvetica Neue"/>
+                <a:latin typeface="Arial"/>
               </a:defRPr>
             </a:pPr>
             <a:r>
@@ -4580,7 +5910,7 @@
                 <a:solidFill>
                   <a:srgbClr val="2A3442"/>
                 </a:solidFill>
-                <a:latin typeface="Helvetica Neue"/>
+                <a:latin typeface="Arial"/>
               </a:defRPr>
             </a:pPr>
             <a:r>
@@ -4596,7 +5926,7 @@
                 <a:solidFill>
                   <a:srgbClr val="2A3442"/>
                 </a:solidFill>
-                <a:latin typeface="Helvetica Neue"/>
+                <a:latin typeface="Arial"/>
               </a:defRPr>
             </a:pPr>
             <a:r>
@@ -4612,7 +5942,7 @@
                 <a:solidFill>
                   <a:srgbClr val="2A3442"/>
                 </a:solidFill>
-                <a:latin typeface="Helvetica Neue"/>
+                <a:latin typeface="Arial"/>
               </a:defRPr>
             </a:pPr>
             <a:r>
@@ -4639,7 +5969,7 @@
         </p:spPr>
         <p:txBody>
           <a:bodyPr wrap="square" anchor="t">
-            <a:spAutoFit/>
+            <a:normAutofit/>
           </a:bodyPr>
           <a:lstStyle/>
           <a:p>
@@ -4651,7 +5981,7 @@
                 <a:solidFill>
                   <a:srgbClr val="5A6472"/>
                 </a:solidFill>
-                <a:latin typeface="Helvetica Neue"/>
+                <a:latin typeface="Arial"/>
               </a:defRPr>
             </a:pPr>
             <a:r>
@@ -4740,7 +6070,7 @@
         </p:spPr>
         <p:txBody>
           <a:bodyPr wrap="square" anchor="t">
-            <a:spAutoFit/>
+            <a:normAutofit/>
           </a:bodyPr>
           <a:lstStyle/>
           <a:p>
@@ -4752,7 +6082,7 @@
                 <a:solidFill>
                   <a:srgbClr val="F26522"/>
                 </a:solidFill>
-                <a:latin typeface="Helvetica Neue"/>
+                <a:latin typeface="Arial"/>
               </a:defRPr>
             </a:pPr>
             <a:r>
@@ -4779,7 +6109,7 @@
         </p:spPr>
         <p:txBody>
           <a:bodyPr wrap="square" anchor="t">
-            <a:spAutoFit/>
+            <a:normAutofit/>
           </a:bodyPr>
           <a:lstStyle/>
           <a:p>
@@ -4791,7 +6121,7 @@
                 <a:solidFill>
                   <a:srgbClr val="18418A"/>
                 </a:solidFill>
-                <a:latin typeface="Helvetica Neue"/>
+                <a:latin typeface="Arial"/>
               </a:defRPr>
             </a:pPr>
             <a:r>
@@ -4850,7 +6180,7 @@
                 <a:solidFill>
                   <a:srgbClr val="18418A"/>
                 </a:solidFill>
-                <a:latin typeface="Helvetica Neue"/>
+                <a:latin typeface="Arial"/>
               </a:defRPr>
             </a:pPr>
             <a:r>
@@ -4863,7 +6193,7 @@
                 <a:solidFill>
                   <a:srgbClr val="2A3442"/>
                 </a:solidFill>
-                <a:latin typeface="Helvetica Neue"/>
+                <a:latin typeface="Arial"/>
               </a:defRPr>
             </a:pPr>
             <a:r>
@@ -4966,7 +6296,7 @@
                 <a:solidFill>
                   <a:srgbClr val="18418A"/>
                 </a:solidFill>
-                <a:latin typeface="Helvetica Neue"/>
+                <a:latin typeface="Arial"/>
               </a:defRPr>
             </a:pPr>
             <a:r>
@@ -4979,7 +6309,7 @@
                 <a:solidFill>
                   <a:srgbClr val="2A3442"/>
                 </a:solidFill>
-                <a:latin typeface="Helvetica Neue"/>
+                <a:latin typeface="Arial"/>
               </a:defRPr>
             </a:pPr>
             <a:r>
@@ -5082,7 +6412,7 @@
                 <a:solidFill>
                   <a:srgbClr val="18418A"/>
                 </a:solidFill>
-                <a:latin typeface="Helvetica Neue"/>
+                <a:latin typeface="Arial"/>
               </a:defRPr>
             </a:pPr>
             <a:r>
@@ -5095,7 +6425,7 @@
                 <a:solidFill>
                   <a:srgbClr val="2A3442"/>
                 </a:solidFill>
-                <a:latin typeface="Helvetica Neue"/>
+                <a:latin typeface="Arial"/>
               </a:defRPr>
             </a:pPr>
             <a:r>
@@ -5198,7 +6528,7 @@
                 <a:solidFill>
                   <a:srgbClr val="18418A"/>
                 </a:solidFill>
-                <a:latin typeface="Helvetica Neue"/>
+                <a:latin typeface="Arial"/>
               </a:defRPr>
             </a:pPr>
             <a:r>
@@ -5211,7 +6541,7 @@
                 <a:solidFill>
                   <a:srgbClr val="2A3442"/>
                 </a:solidFill>
-                <a:latin typeface="Helvetica Neue"/>
+                <a:latin typeface="Arial"/>
               </a:defRPr>
             </a:pPr>
             <a:r>
@@ -5282,7 +6612,7 @@
         </p:spPr>
         <p:txBody>
           <a:bodyPr wrap="square" anchor="t">
-            <a:spAutoFit/>
+            <a:normAutofit/>
           </a:bodyPr>
           <a:lstStyle/>
           <a:p>
@@ -5294,7 +6624,7 @@
                 <a:solidFill>
                   <a:srgbClr val="5A6472"/>
                 </a:solidFill>
-                <a:latin typeface="Helvetica Neue"/>
+                <a:latin typeface="Arial"/>
               </a:defRPr>
             </a:pPr>
             <a:r>
@@ -5383,7 +6713,7 @@
         </p:spPr>
         <p:txBody>
           <a:bodyPr wrap="square" anchor="t">
-            <a:spAutoFit/>
+            <a:normAutofit/>
           </a:bodyPr>
           <a:lstStyle/>
           <a:p>
@@ -5395,7 +6725,7 @@
                 <a:solidFill>
                   <a:srgbClr val="F26522"/>
                 </a:solidFill>
-                <a:latin typeface="Helvetica Neue"/>
+                <a:latin typeface="Arial"/>
               </a:defRPr>
             </a:pPr>
             <a:r>
@@ -5422,7 +6752,7 @@
         </p:spPr>
         <p:txBody>
           <a:bodyPr wrap="square" anchor="t">
-            <a:spAutoFit/>
+            <a:normAutofit/>
           </a:bodyPr>
           <a:lstStyle/>
           <a:p>
@@ -5434,7 +6764,7 @@
                 <a:solidFill>
                   <a:srgbClr val="18418A"/>
                 </a:solidFill>
-                <a:latin typeface="Helvetica Neue"/>
+                <a:latin typeface="Arial"/>
               </a:defRPr>
             </a:pPr>
             <a:r>
@@ -5461,7 +6791,7 @@
         </p:spPr>
         <p:txBody>
           <a:bodyPr wrap="square" anchor="t">
-            <a:spAutoFit/>
+            <a:normAutofit/>
           </a:bodyPr>
           <a:lstStyle/>
           <a:p>
@@ -5473,7 +6803,7 @@
                 <a:solidFill>
                   <a:srgbClr val="2A3442"/>
                 </a:solidFill>
-                <a:latin typeface="Helvetica Neue"/>
+                <a:latin typeface="Arial"/>
               </a:defRPr>
             </a:pPr>
             <a:r>
@@ -5489,7 +6819,7 @@
                 <a:solidFill>
                   <a:srgbClr val="2A3442"/>
                 </a:solidFill>
-                <a:latin typeface="Helvetica Neue"/>
+                <a:latin typeface="Arial"/>
               </a:defRPr>
             </a:pPr>
             <a:r>
@@ -5505,7 +6835,7 @@
                 <a:solidFill>
                   <a:srgbClr val="2A3442"/>
                 </a:solidFill>
-                <a:latin typeface="Helvetica Neue"/>
+                <a:latin typeface="Arial"/>
               </a:defRPr>
             </a:pPr>
             <a:r>
@@ -5521,7 +6851,7 @@
                 <a:solidFill>
                   <a:srgbClr val="2A3442"/>
                 </a:solidFill>
-                <a:latin typeface="Helvetica Neue"/>
+                <a:latin typeface="Arial"/>
               </a:defRPr>
             </a:pPr>
             <a:r>
@@ -5548,7 +6878,7 @@
         </p:spPr>
         <p:txBody>
           <a:bodyPr wrap="square" anchor="t">
-            <a:spAutoFit/>
+            <a:normAutofit/>
           </a:bodyPr>
           <a:lstStyle/>
           <a:p>
@@ -5560,7 +6890,7 @@
                 <a:solidFill>
                   <a:srgbClr val="5A6472"/>
                 </a:solidFill>
-                <a:latin typeface="Helvetica Neue"/>
+                <a:latin typeface="Arial"/>
               </a:defRPr>
             </a:pPr>
             <a:r>
@@ -5649,7 +6979,7 @@
         </p:spPr>
         <p:txBody>
           <a:bodyPr wrap="square" anchor="t">
-            <a:spAutoFit/>
+            <a:normAutofit/>
           </a:bodyPr>
           <a:lstStyle/>
           <a:p>
@@ -5661,7 +6991,7 @@
                 <a:solidFill>
                   <a:srgbClr val="F26522"/>
                 </a:solidFill>
-                <a:latin typeface="Helvetica Neue"/>
+                <a:latin typeface="Arial"/>
               </a:defRPr>
             </a:pPr>
             <a:r>
@@ -5688,7 +7018,7 @@
         </p:spPr>
         <p:txBody>
           <a:bodyPr wrap="square" anchor="t">
-            <a:spAutoFit/>
+            <a:normAutofit/>
           </a:bodyPr>
           <a:lstStyle/>
           <a:p>
@@ -5700,7 +7030,7 @@
                 <a:solidFill>
                   <a:srgbClr val="18418A"/>
                 </a:solidFill>
-                <a:latin typeface="Helvetica Neue"/>
+                <a:latin typeface="Arial"/>
               </a:defRPr>
             </a:pPr>
             <a:r>
@@ -5727,7 +7057,7 @@
         </p:spPr>
         <p:txBody>
           <a:bodyPr wrap="square" anchor="t">
-            <a:spAutoFit/>
+            <a:normAutofit/>
           </a:bodyPr>
           <a:lstStyle/>
           <a:p>
@@ -5739,7 +7069,7 @@
                 <a:solidFill>
                   <a:srgbClr val="2A3442"/>
                 </a:solidFill>
-                <a:latin typeface="Helvetica Neue"/>
+                <a:latin typeface="Arial"/>
               </a:defRPr>
             </a:pPr>
             <a:r>
@@ -5755,7 +7085,7 @@
                 <a:solidFill>
                   <a:srgbClr val="2A3442"/>
                 </a:solidFill>
-                <a:latin typeface="Helvetica Neue"/>
+                <a:latin typeface="Arial"/>
               </a:defRPr>
             </a:pPr>
             <a:r>
@@ -5771,7 +7101,7 @@
                 <a:solidFill>
                   <a:srgbClr val="2A3442"/>
                 </a:solidFill>
-                <a:latin typeface="Helvetica Neue"/>
+                <a:latin typeface="Arial"/>
               </a:defRPr>
             </a:pPr>
             <a:r>
@@ -5787,7 +7117,7 @@
                 <a:solidFill>
                   <a:srgbClr val="2A3442"/>
                 </a:solidFill>
-                <a:latin typeface="Helvetica Neue"/>
+                <a:latin typeface="Arial"/>
               </a:defRPr>
             </a:pPr>
             <a:r>
@@ -5803,7 +7133,7 @@
                 <a:solidFill>
                   <a:srgbClr val="2A3442"/>
                 </a:solidFill>
-                <a:latin typeface="Helvetica Neue"/>
+                <a:latin typeface="Arial"/>
               </a:defRPr>
             </a:pPr>
             <a:r>
@@ -5819,7 +7149,7 @@
                 <a:solidFill>
                   <a:srgbClr val="2A3442"/>
                 </a:solidFill>
-                <a:latin typeface="Helvetica Neue"/>
+                <a:latin typeface="Arial"/>
               </a:defRPr>
             </a:pPr>
             <a:r>
@@ -5846,7 +7176,7 @@
         </p:spPr>
         <p:txBody>
           <a:bodyPr wrap="square" anchor="t">
-            <a:spAutoFit/>
+            <a:normAutofit/>
           </a:bodyPr>
           <a:lstStyle/>
           <a:p>
@@ -5858,7 +7188,7 @@
                 <a:solidFill>
                   <a:srgbClr val="5A6472"/>
                 </a:solidFill>
-                <a:latin typeface="Helvetica Neue"/>
+                <a:latin typeface="Arial"/>
               </a:defRPr>
             </a:pPr>
             <a:r>
@@ -5947,7 +7277,7 @@
         </p:spPr>
         <p:txBody>
           <a:bodyPr wrap="square" anchor="t">
-            <a:spAutoFit/>
+            <a:normAutofit/>
           </a:bodyPr>
           <a:lstStyle/>
           <a:p>
@@ -5959,7 +7289,7 @@
                 <a:solidFill>
                   <a:srgbClr val="F26522"/>
                 </a:solidFill>
-                <a:latin typeface="Helvetica Neue"/>
+                <a:latin typeface="Arial"/>
               </a:defRPr>
             </a:pPr>
             <a:r>
@@ -5986,7 +7316,7 @@
         </p:spPr>
         <p:txBody>
           <a:bodyPr wrap="square" anchor="t">
-            <a:spAutoFit/>
+            <a:normAutofit/>
           </a:bodyPr>
           <a:lstStyle/>
           <a:p>
@@ -5998,7 +7328,7 @@
                 <a:solidFill>
                   <a:srgbClr val="18418A"/>
                 </a:solidFill>
-                <a:latin typeface="Helvetica Neue"/>
+                <a:latin typeface="Arial"/>
               </a:defRPr>
             </a:pPr>
             <a:r>
@@ -6057,7 +7387,7 @@
                 <a:solidFill>
                   <a:srgbClr val="18418A"/>
                 </a:solidFill>
-                <a:latin typeface="Helvetica Neue"/>
+                <a:latin typeface="Arial"/>
               </a:defRPr>
             </a:pPr>
             <a:r>
@@ -6070,7 +7400,7 @@
                 <a:solidFill>
                   <a:srgbClr val="2A3442"/>
                 </a:solidFill>
-                <a:latin typeface="Helvetica Neue"/>
+                <a:latin typeface="Arial"/>
               </a:defRPr>
             </a:pPr>
             <a:r>
@@ -6173,7 +7503,7 @@
                 <a:solidFill>
                   <a:srgbClr val="18418A"/>
                 </a:solidFill>
-                <a:latin typeface="Helvetica Neue"/>
+                <a:latin typeface="Arial"/>
               </a:defRPr>
             </a:pPr>
             <a:r>
@@ -6186,7 +7516,7 @@
                 <a:solidFill>
                   <a:srgbClr val="2A3442"/>
                 </a:solidFill>
-                <a:latin typeface="Helvetica Neue"/>
+                <a:latin typeface="Arial"/>
               </a:defRPr>
             </a:pPr>
             <a:r>
@@ -6289,7 +7619,7 @@
                 <a:solidFill>
                   <a:srgbClr val="18418A"/>
                 </a:solidFill>
-                <a:latin typeface="Helvetica Neue"/>
+                <a:latin typeface="Arial"/>
               </a:defRPr>
             </a:pPr>
             <a:r>
@@ -6302,7 +7632,7 @@
                 <a:solidFill>
                   <a:srgbClr val="2A3442"/>
                 </a:solidFill>
-                <a:latin typeface="Helvetica Neue"/>
+                <a:latin typeface="Arial"/>
               </a:defRPr>
             </a:pPr>
             <a:r>
@@ -6405,7 +7735,7 @@
                 <a:solidFill>
                   <a:srgbClr val="18418A"/>
                 </a:solidFill>
-                <a:latin typeface="Helvetica Neue"/>
+                <a:latin typeface="Arial"/>
               </a:defRPr>
             </a:pPr>
             <a:r>
@@ -6418,7 +7748,7 @@
                 <a:solidFill>
                   <a:srgbClr val="2A3442"/>
                 </a:solidFill>
-                <a:latin typeface="Helvetica Neue"/>
+                <a:latin typeface="Arial"/>
               </a:defRPr>
             </a:pPr>
             <a:r>
@@ -6489,7 +7819,7 @@
         </p:spPr>
         <p:txBody>
           <a:bodyPr wrap="square" anchor="t">
-            <a:spAutoFit/>
+            <a:normAutofit/>
           </a:bodyPr>
           <a:lstStyle/>
           <a:p>
@@ -6501,7 +7831,7 @@
                 <a:solidFill>
                   <a:srgbClr val="5A6472"/>
                 </a:solidFill>
-                <a:latin typeface="Helvetica Neue"/>
+                <a:latin typeface="Arial"/>
               </a:defRPr>
             </a:pPr>
             <a:r>
@@ -6590,7 +7920,7 @@
         </p:spPr>
         <p:txBody>
           <a:bodyPr wrap="square" anchor="t">
-            <a:spAutoFit/>
+            <a:normAutofit/>
           </a:bodyPr>
           <a:lstStyle/>
           <a:p>
@@ -6602,7 +7932,7 @@
                 <a:solidFill>
                   <a:srgbClr val="F26522"/>
                 </a:solidFill>
-                <a:latin typeface="Helvetica Neue"/>
+                <a:latin typeface="Arial"/>
               </a:defRPr>
             </a:pPr>
             <a:r>
@@ -6629,7 +7959,7 @@
         </p:spPr>
         <p:txBody>
           <a:bodyPr wrap="square" anchor="t">
-            <a:spAutoFit/>
+            <a:normAutofit/>
           </a:bodyPr>
           <a:lstStyle/>
           <a:p>
@@ -6641,7 +7971,7 @@
                 <a:solidFill>
                   <a:srgbClr val="18418A"/>
                 </a:solidFill>
-                <a:latin typeface="Helvetica Neue"/>
+                <a:latin typeface="Arial"/>
               </a:defRPr>
             </a:pPr>
             <a:r>
@@ -6668,7 +7998,7 @@
         </p:spPr>
         <p:txBody>
           <a:bodyPr wrap="square" anchor="t">
-            <a:spAutoFit/>
+            <a:normAutofit/>
           </a:bodyPr>
           <a:lstStyle/>
           <a:p>
@@ -6680,7 +8010,7 @@
                 <a:solidFill>
                   <a:srgbClr val="2A3442"/>
                 </a:solidFill>
-                <a:latin typeface="Helvetica Neue"/>
+                <a:latin typeface="Arial"/>
               </a:defRPr>
             </a:pPr>
             <a:r>
@@ -6696,7 +8026,7 @@
                 <a:solidFill>
                   <a:srgbClr val="2A3442"/>
                 </a:solidFill>
-                <a:latin typeface="Helvetica Neue"/>
+                <a:latin typeface="Arial"/>
               </a:defRPr>
             </a:pPr>
             <a:r>
@@ -6712,7 +8042,7 @@
                 <a:solidFill>
                   <a:srgbClr val="2A3442"/>
                 </a:solidFill>
-                <a:latin typeface="Helvetica Neue"/>
+                <a:latin typeface="Arial"/>
               </a:defRPr>
             </a:pPr>
             <a:r>
@@ -6728,7 +8058,7 @@
                 <a:solidFill>
                   <a:srgbClr val="2A3442"/>
                 </a:solidFill>
-                <a:latin typeface="Helvetica Neue"/>
+                <a:latin typeface="Arial"/>
               </a:defRPr>
             </a:pPr>
             <a:r>
@@ -6744,7 +8074,7 @@
                 <a:solidFill>
                   <a:srgbClr val="2A3442"/>
                 </a:solidFill>
-                <a:latin typeface="Helvetica Neue"/>
+                <a:latin typeface="Arial"/>
               </a:defRPr>
             </a:pPr>
             <a:r>
@@ -6771,7 +8101,7 @@
         </p:spPr>
         <p:txBody>
           <a:bodyPr wrap="square" anchor="t">
-            <a:spAutoFit/>
+            <a:normAutofit/>
           </a:bodyPr>
           <a:lstStyle/>
           <a:p>
@@ -6783,7 +8113,7 @@
                 <a:solidFill>
                   <a:srgbClr val="5A6472"/>
                 </a:solidFill>
-                <a:latin typeface="Helvetica Neue"/>
+                <a:latin typeface="Arial"/>
               </a:defRPr>
             </a:pPr>
             <a:r>
@@ -6872,7 +8202,7 @@
         </p:spPr>
         <p:txBody>
           <a:bodyPr wrap="square" anchor="t">
-            <a:spAutoFit/>
+            <a:normAutofit/>
           </a:bodyPr>
           <a:lstStyle/>
           <a:p>
@@ -6884,7 +8214,7 @@
                 <a:solidFill>
                   <a:srgbClr val="F26522"/>
                 </a:solidFill>
-                <a:latin typeface="Helvetica Neue"/>
+                <a:latin typeface="Arial"/>
               </a:defRPr>
             </a:pPr>
             <a:r>
@@ -6911,7 +8241,7 @@
         </p:spPr>
         <p:txBody>
           <a:bodyPr wrap="square" anchor="t">
-            <a:spAutoFit/>
+            <a:normAutofit/>
           </a:bodyPr>
           <a:lstStyle/>
           <a:p>
@@ -6923,7 +8253,7 @@
                 <a:solidFill>
                   <a:srgbClr val="18418A"/>
                 </a:solidFill>
-                <a:latin typeface="Helvetica Neue"/>
+                <a:latin typeface="Arial"/>
               </a:defRPr>
             </a:pPr>
             <a:r>
@@ -6982,7 +8312,7 @@
                 <a:solidFill>
                   <a:srgbClr val="18418A"/>
                 </a:solidFill>
-                <a:latin typeface="Helvetica Neue"/>
+                <a:latin typeface="Arial"/>
               </a:defRPr>
             </a:pPr>
             <a:r>
@@ -6995,7 +8325,7 @@
                 <a:solidFill>
                   <a:srgbClr val="2A3442"/>
                 </a:solidFill>
-                <a:latin typeface="Helvetica Neue"/>
+                <a:latin typeface="Arial"/>
               </a:defRPr>
             </a:pPr>
             <a:r>
@@ -7098,7 +8428,7 @@
                 <a:solidFill>
                   <a:srgbClr val="18418A"/>
                 </a:solidFill>
-                <a:latin typeface="Helvetica Neue"/>
+                <a:latin typeface="Arial"/>
               </a:defRPr>
             </a:pPr>
             <a:r>
@@ -7111,7 +8441,7 @@
                 <a:solidFill>
                   <a:srgbClr val="2A3442"/>
                 </a:solidFill>
-                <a:latin typeface="Helvetica Neue"/>
+                <a:latin typeface="Arial"/>
               </a:defRPr>
             </a:pPr>
             <a:r>
@@ -7214,7 +8544,7 @@
                 <a:solidFill>
                   <a:srgbClr val="18418A"/>
                 </a:solidFill>
-                <a:latin typeface="Helvetica Neue"/>
+                <a:latin typeface="Arial"/>
               </a:defRPr>
             </a:pPr>
             <a:r>
@@ -7227,7 +8557,7 @@
                 <a:solidFill>
                   <a:srgbClr val="2A3442"/>
                 </a:solidFill>
-                <a:latin typeface="Helvetica Neue"/>
+                <a:latin typeface="Arial"/>
               </a:defRPr>
             </a:pPr>
             <a:r>
@@ -7330,7 +8660,7 @@
                 <a:solidFill>
                   <a:srgbClr val="18418A"/>
                 </a:solidFill>
-                <a:latin typeface="Helvetica Neue"/>
+                <a:latin typeface="Arial"/>
               </a:defRPr>
             </a:pPr>
             <a:r>
@@ -7343,7 +8673,7 @@
                 <a:solidFill>
                   <a:srgbClr val="2A3442"/>
                 </a:solidFill>
-                <a:latin typeface="Helvetica Neue"/>
+                <a:latin typeface="Arial"/>
               </a:defRPr>
             </a:pPr>
             <a:r>
@@ -7446,7 +8776,7 @@
                 <a:solidFill>
                   <a:srgbClr val="18418A"/>
                 </a:solidFill>
-                <a:latin typeface="Helvetica Neue"/>
+                <a:latin typeface="Arial"/>
               </a:defRPr>
             </a:pPr>
             <a:r>
@@ -7459,7 +8789,7 @@
                 <a:solidFill>
                   <a:srgbClr val="2A3442"/>
                 </a:solidFill>
-                <a:latin typeface="Helvetica Neue"/>
+                <a:latin typeface="Arial"/>
               </a:defRPr>
             </a:pPr>
             <a:r>
@@ -7562,7 +8892,7 @@
                 <a:solidFill>
                   <a:srgbClr val="18418A"/>
                 </a:solidFill>
-                <a:latin typeface="Helvetica Neue"/>
+                <a:latin typeface="Arial"/>
               </a:defRPr>
             </a:pPr>
             <a:r>
@@ -7575,7 +8905,7 @@
                 <a:solidFill>
                   <a:srgbClr val="2A3442"/>
                 </a:solidFill>
-                <a:latin typeface="Helvetica Neue"/>
+                <a:latin typeface="Arial"/>
               </a:defRPr>
             </a:pPr>
             <a:r>
@@ -7646,7 +8976,7 @@
         </p:spPr>
         <p:txBody>
           <a:bodyPr wrap="square" anchor="t">
-            <a:spAutoFit/>
+            <a:normAutofit/>
           </a:bodyPr>
           <a:lstStyle/>
           <a:p>
@@ -7658,7 +8988,7 @@
                 <a:solidFill>
                   <a:srgbClr val="5A6472"/>
                 </a:solidFill>
-                <a:latin typeface="Helvetica Neue"/>
+                <a:latin typeface="Arial"/>
               </a:defRPr>
             </a:pPr>
             <a:r>
@@ -7747,7 +9077,7 @@
         </p:spPr>
         <p:txBody>
           <a:bodyPr wrap="square" anchor="t">
-            <a:spAutoFit/>
+            <a:normAutofit/>
           </a:bodyPr>
           <a:lstStyle/>
           <a:p>
@@ -7759,7 +9089,7 @@
                 <a:solidFill>
                   <a:srgbClr val="F26522"/>
                 </a:solidFill>
-                <a:latin typeface="Helvetica Neue"/>
+                <a:latin typeface="Arial"/>
               </a:defRPr>
             </a:pPr>
             <a:r>
@@ -7786,7 +9116,7 @@
         </p:spPr>
         <p:txBody>
           <a:bodyPr wrap="square" anchor="t">
-            <a:spAutoFit/>
+            <a:normAutofit/>
           </a:bodyPr>
           <a:lstStyle/>
           <a:p>
@@ -7798,7 +9128,7 @@
                 <a:solidFill>
                   <a:srgbClr val="18418A"/>
                 </a:solidFill>
-                <a:latin typeface="Helvetica Neue"/>
+                <a:latin typeface="Arial"/>
               </a:defRPr>
             </a:pPr>
             <a:r>
@@ -7857,7 +9187,7 @@
                 <a:solidFill>
                   <a:srgbClr val="18418A"/>
                 </a:solidFill>
-                <a:latin typeface="Helvetica Neue"/>
+                <a:latin typeface="Arial"/>
               </a:defRPr>
             </a:pPr>
             <a:r>
@@ -7870,7 +9200,7 @@
                 <a:solidFill>
                   <a:srgbClr val="2A3442"/>
                 </a:solidFill>
-                <a:latin typeface="Helvetica Neue"/>
+                <a:latin typeface="Arial"/>
               </a:defRPr>
             </a:pPr>
             <a:r>
@@ -7973,7 +9303,7 @@
                 <a:solidFill>
                   <a:srgbClr val="18418A"/>
                 </a:solidFill>
-                <a:latin typeface="Helvetica Neue"/>
+                <a:latin typeface="Arial"/>
               </a:defRPr>
             </a:pPr>
             <a:r>
@@ -7986,7 +9316,7 @@
                 <a:solidFill>
                   <a:srgbClr val="2A3442"/>
                 </a:solidFill>
-                <a:latin typeface="Helvetica Neue"/>
+                <a:latin typeface="Arial"/>
               </a:defRPr>
             </a:pPr>
             <a:r>
@@ -8089,7 +9419,7 @@
                 <a:solidFill>
                   <a:srgbClr val="18418A"/>
                 </a:solidFill>
-                <a:latin typeface="Helvetica Neue"/>
+                <a:latin typeface="Arial"/>
               </a:defRPr>
             </a:pPr>
             <a:r>
@@ -8102,7 +9432,7 @@
                 <a:solidFill>
                   <a:srgbClr val="2A3442"/>
                 </a:solidFill>
-                <a:latin typeface="Helvetica Neue"/>
+                <a:latin typeface="Arial"/>
               </a:defRPr>
             </a:pPr>
             <a:r>
@@ -8173,7 +9503,7 @@
         </p:spPr>
         <p:txBody>
           <a:bodyPr wrap="square" anchor="t">
-            <a:spAutoFit/>
+            <a:normAutofit/>
           </a:bodyPr>
           <a:lstStyle/>
           <a:p>
@@ -8185,7 +9515,7 @@
                 <a:solidFill>
                   <a:srgbClr val="5A6472"/>
                 </a:solidFill>
-                <a:latin typeface="Helvetica Neue"/>
+                <a:latin typeface="Arial"/>
               </a:defRPr>
             </a:pPr>
             <a:r>
@@ -8274,7 +9604,7 @@
         </p:spPr>
         <p:txBody>
           <a:bodyPr wrap="square" anchor="t">
-            <a:spAutoFit/>
+            <a:normAutofit/>
           </a:bodyPr>
           <a:lstStyle/>
           <a:p>
@@ -8286,7 +9616,7 @@
                 <a:solidFill>
                   <a:srgbClr val="F26522"/>
                 </a:solidFill>
-                <a:latin typeface="Helvetica Neue"/>
+                <a:latin typeface="Arial"/>
               </a:defRPr>
             </a:pPr>
             <a:r>
@@ -8313,7 +9643,7 @@
         </p:spPr>
         <p:txBody>
           <a:bodyPr wrap="square" anchor="t">
-            <a:spAutoFit/>
+            <a:normAutofit/>
           </a:bodyPr>
           <a:lstStyle/>
           <a:p>
@@ -8325,7 +9655,7 @@
                 <a:solidFill>
                   <a:srgbClr val="18418A"/>
                 </a:solidFill>
-                <a:latin typeface="Helvetica Neue"/>
+                <a:latin typeface="Arial"/>
               </a:defRPr>
             </a:pPr>
             <a:r>
@@ -8352,7 +9682,7 @@
         </p:spPr>
         <p:txBody>
           <a:bodyPr wrap="square" anchor="t">
-            <a:spAutoFit/>
+            <a:normAutofit/>
           </a:bodyPr>
           <a:lstStyle/>
           <a:p>
@@ -8364,7 +9694,7 @@
                 <a:solidFill>
                   <a:srgbClr val="2A3442"/>
                 </a:solidFill>
-                <a:latin typeface="Helvetica Neue"/>
+                <a:latin typeface="Arial"/>
               </a:defRPr>
             </a:pPr>
             <a:r>
@@ -8380,7 +9710,7 @@
                 <a:solidFill>
                   <a:srgbClr val="2A3442"/>
                 </a:solidFill>
-                <a:latin typeface="Helvetica Neue"/>
+                <a:latin typeface="Arial"/>
               </a:defRPr>
             </a:pPr>
             <a:r>
@@ -8396,7 +9726,7 @@
                 <a:solidFill>
                   <a:srgbClr val="2A3442"/>
                 </a:solidFill>
-                <a:latin typeface="Helvetica Neue"/>
+                <a:latin typeface="Arial"/>
               </a:defRPr>
             </a:pPr>
             <a:r>
@@ -8412,7 +9742,7 @@
                 <a:solidFill>
                   <a:srgbClr val="2A3442"/>
                 </a:solidFill>
-                <a:latin typeface="Helvetica Neue"/>
+                <a:latin typeface="Arial"/>
               </a:defRPr>
             </a:pPr>
             <a:r>
@@ -8428,7 +9758,7 @@
                 <a:solidFill>
                   <a:srgbClr val="2A3442"/>
                 </a:solidFill>
-                <a:latin typeface="Helvetica Neue"/>
+                <a:latin typeface="Arial"/>
               </a:defRPr>
             </a:pPr>
             <a:r>
@@ -8444,7 +9774,7 @@
                 <a:solidFill>
                   <a:srgbClr val="2A3442"/>
                 </a:solidFill>
-                <a:latin typeface="Helvetica Neue"/>
+                <a:latin typeface="Arial"/>
               </a:defRPr>
             </a:pPr>
             <a:r>
@@ -8460,7 +9790,7 @@
                 <a:solidFill>
                   <a:srgbClr val="2A3442"/>
                 </a:solidFill>
-                <a:latin typeface="Helvetica Neue"/>
+                <a:latin typeface="Arial"/>
               </a:defRPr>
             </a:pPr>
             <a:r>
@@ -8487,7 +9817,7 @@
         </p:spPr>
         <p:txBody>
           <a:bodyPr wrap="square" anchor="t">
-            <a:spAutoFit/>
+            <a:normAutofit/>
           </a:bodyPr>
           <a:lstStyle/>
           <a:p>
@@ -8499,7 +9829,7 @@
                 <a:solidFill>
                   <a:srgbClr val="5A6472"/>
                 </a:solidFill>
-                <a:latin typeface="Helvetica Neue"/>
+                <a:latin typeface="Arial"/>
               </a:defRPr>
             </a:pPr>
             <a:r>
@@ -8588,7 +9918,7 @@
         </p:spPr>
         <p:txBody>
           <a:bodyPr wrap="square" anchor="t">
-            <a:spAutoFit/>
+            <a:normAutofit/>
           </a:bodyPr>
           <a:lstStyle/>
           <a:p>
@@ -8600,7 +9930,7 @@
                 <a:solidFill>
                   <a:srgbClr val="F26522"/>
                 </a:solidFill>
-                <a:latin typeface="Helvetica Neue"/>
+                <a:latin typeface="Arial"/>
               </a:defRPr>
             </a:pPr>
             <a:r>
@@ -8627,7 +9957,7 @@
         </p:spPr>
         <p:txBody>
           <a:bodyPr wrap="square" anchor="t">
-            <a:spAutoFit/>
+            <a:normAutofit/>
           </a:bodyPr>
           <a:lstStyle/>
           <a:p>
@@ -8639,7 +9969,7 @@
                 <a:solidFill>
                   <a:srgbClr val="18418A"/>
                 </a:solidFill>
-                <a:latin typeface="Helvetica Neue"/>
+                <a:latin typeface="Arial"/>
               </a:defRPr>
             </a:pPr>
             <a:r>
@@ -8698,7 +10028,7 @@
                 <a:solidFill>
                   <a:srgbClr val="18418A"/>
                 </a:solidFill>
-                <a:latin typeface="Helvetica Neue"/>
+                <a:latin typeface="Arial"/>
               </a:defRPr>
             </a:pPr>
             <a:r>
@@ -8711,7 +10041,7 @@
                 <a:solidFill>
                   <a:srgbClr val="2A3442"/>
                 </a:solidFill>
-                <a:latin typeface="Helvetica Neue"/>
+                <a:latin typeface="Arial"/>
               </a:defRPr>
             </a:pPr>
             <a:r>
@@ -8814,7 +10144,7 @@
                 <a:solidFill>
                   <a:srgbClr val="18418A"/>
                 </a:solidFill>
-                <a:latin typeface="Helvetica Neue"/>
+                <a:latin typeface="Arial"/>
               </a:defRPr>
             </a:pPr>
             <a:r>
@@ -8827,7 +10157,7 @@
                 <a:solidFill>
                   <a:srgbClr val="2A3442"/>
                 </a:solidFill>
-                <a:latin typeface="Helvetica Neue"/>
+                <a:latin typeface="Arial"/>
               </a:defRPr>
             </a:pPr>
             <a:r>
@@ -8930,7 +10260,7 @@
                 <a:solidFill>
                   <a:srgbClr val="18418A"/>
                 </a:solidFill>
-                <a:latin typeface="Helvetica Neue"/>
+                <a:latin typeface="Arial"/>
               </a:defRPr>
             </a:pPr>
             <a:r>
@@ -8943,7 +10273,7 @@
                 <a:solidFill>
                   <a:srgbClr val="2A3442"/>
                 </a:solidFill>
-                <a:latin typeface="Helvetica Neue"/>
+                <a:latin typeface="Arial"/>
               </a:defRPr>
             </a:pPr>
             <a:r>
@@ -9046,7 +10376,7 @@
                 <a:solidFill>
                   <a:srgbClr val="18418A"/>
                 </a:solidFill>
-                <a:latin typeface="Helvetica Neue"/>
+                <a:latin typeface="Arial"/>
               </a:defRPr>
             </a:pPr>
             <a:r>
@@ -9059,7 +10389,7 @@
                 <a:solidFill>
                   <a:srgbClr val="2A3442"/>
                 </a:solidFill>
-                <a:latin typeface="Helvetica Neue"/>
+                <a:latin typeface="Arial"/>
               </a:defRPr>
             </a:pPr>
             <a:r>
@@ -9130,7 +10460,7 @@
         </p:spPr>
         <p:txBody>
           <a:bodyPr wrap="square" anchor="t">
-            <a:spAutoFit/>
+            <a:normAutofit/>
           </a:bodyPr>
           <a:lstStyle/>
           <a:p>
@@ -9142,7 +10472,7 @@
                 <a:solidFill>
                   <a:srgbClr val="5A6472"/>
                 </a:solidFill>
-                <a:latin typeface="Helvetica Neue"/>
+                <a:latin typeface="Arial"/>
               </a:defRPr>
             </a:pPr>
             <a:r>
@@ -9231,7 +10561,7 @@
         </p:spPr>
         <p:txBody>
           <a:bodyPr wrap="square" anchor="t">
-            <a:spAutoFit/>
+            <a:normAutofit/>
           </a:bodyPr>
           <a:lstStyle/>
           <a:p>
@@ -9243,7 +10573,7 @@
                 <a:solidFill>
                   <a:srgbClr val="F26522"/>
                 </a:solidFill>
-                <a:latin typeface="Helvetica Neue"/>
+                <a:latin typeface="Arial"/>
               </a:defRPr>
             </a:pPr>
             <a:r>
@@ -9270,7 +10600,7 @@
         </p:spPr>
         <p:txBody>
           <a:bodyPr wrap="square" anchor="t">
-            <a:spAutoFit/>
+            <a:normAutofit/>
           </a:bodyPr>
           <a:lstStyle/>
           <a:p>
@@ -9282,7 +10612,7 @@
                 <a:solidFill>
                   <a:srgbClr val="18418A"/>
                 </a:solidFill>
-                <a:latin typeface="Helvetica Neue"/>
+                <a:latin typeface="Arial"/>
               </a:defRPr>
             </a:pPr>
             <a:r>
@@ -9338,7 +10668,7 @@
                 <a:solidFill>
                   <a:srgbClr val="18418A"/>
                 </a:solidFill>
-                <a:latin typeface="Helvetica Neue"/>
+                <a:latin typeface="Arial"/>
               </a:defRPr>
             </a:pPr>
             <a:r>
@@ -9394,7 +10724,7 @@
                 <a:solidFill>
                   <a:srgbClr val="18418A"/>
                 </a:solidFill>
-                <a:latin typeface="Helvetica Neue"/>
+                <a:latin typeface="Arial"/>
               </a:defRPr>
             </a:pPr>
             <a:r>
@@ -9450,7 +10780,7 @@
                 <a:solidFill>
                   <a:srgbClr val="18418A"/>
                 </a:solidFill>
-                <a:latin typeface="Helvetica Neue"/>
+                <a:latin typeface="Arial"/>
               </a:defRPr>
             </a:pPr>
             <a:r>
@@ -9506,7 +10836,7 @@
                 <a:solidFill>
                   <a:srgbClr val="18418A"/>
                 </a:solidFill>
-                <a:latin typeface="Helvetica Neue"/>
+                <a:latin typeface="Arial"/>
               </a:defRPr>
             </a:pPr>
             <a:r>
@@ -9533,7 +10863,7 @@
         </p:spPr>
         <p:txBody>
           <a:bodyPr wrap="square" anchor="t">
-            <a:spAutoFit/>
+            <a:normAutofit/>
           </a:bodyPr>
           <a:lstStyle/>
           <a:p>
@@ -9545,7 +10875,7 @@
                 <a:solidFill>
                   <a:srgbClr val="2A3442"/>
                 </a:solidFill>
-                <a:latin typeface="Helvetica Neue"/>
+                <a:latin typeface="Arial"/>
               </a:defRPr>
             </a:pPr>
             <a:r>
@@ -9572,7 +10902,7 @@
         </p:spPr>
         <p:txBody>
           <a:bodyPr wrap="square" anchor="t">
-            <a:spAutoFit/>
+            <a:normAutofit/>
           </a:bodyPr>
           <a:lstStyle/>
           <a:p>
@@ -9584,7 +10914,7 @@
                 <a:solidFill>
                   <a:srgbClr val="5A6472"/>
                 </a:solidFill>
-                <a:latin typeface="Helvetica Neue"/>
+                <a:latin typeface="Arial"/>
               </a:defRPr>
             </a:pPr>
             <a:r>
@@ -9919,4 +11249,324 @@
   </a:objectDefaults>
   <a:extraClrSchemeLst/>
 </a:theme>
+</file>
+
+<file path=ppt/theme/theme2.xml><?xml version="1.0" encoding="utf-8"?>
+<a:theme xmlns:a="http://schemas.openxmlformats.org/drawingml/2006/main" name="Office Theme">
+  <a:themeElements>
+    <a:clrScheme name="Office">
+      <a:dk1>
+        <a:sysClr val="windowText" lastClr="000000"/>
+      </a:dk1>
+      <a:lt1>
+        <a:sysClr val="window" lastClr="FFFFFF"/>
+      </a:lt1>
+      <a:dk2>
+        <a:srgbClr val="1F497D"/>
+      </a:dk2>
+      <a:lt2>
+        <a:srgbClr val="EEECE1"/>
+      </a:lt2>
+      <a:accent1>
+        <a:srgbClr val="4F81BD"/>
+      </a:accent1>
+      <a:accent2>
+        <a:srgbClr val="C0504D"/>
+      </a:accent2>
+      <a:accent3>
+        <a:srgbClr val="9BBB59"/>
+      </a:accent3>
+      <a:accent4>
+        <a:srgbClr val="8064A2"/>
+      </a:accent4>
+      <a:accent5>
+        <a:srgbClr val="4BACC6"/>
+      </a:accent5>
+      <a:accent6>
+        <a:srgbClr val="F79646"/>
+      </a:accent6>
+      <a:hlink>
+        <a:srgbClr val="0000FF"/>
+      </a:hlink>
+      <a:folHlink>
+        <a:srgbClr val="800080"/>
+      </a:folHlink>
+    </a:clrScheme>
+    <a:fontScheme name="Office">
+      <a:majorFont>
+        <a:latin typeface="Calibri"/>
+        <a:ea typeface=""/>
+        <a:cs typeface=""/>
+        <a:font script="Jpan" typeface="ＭＳ Ｐゴシック"/>
+        <a:font script="Hang" typeface="맑은 고딕"/>
+        <a:font script="Hans" typeface="宋体"/>
+        <a:font script="Hant" typeface="新細明體"/>
+        <a:font script="Arab" typeface="Times New Roman"/>
+        <a:font script="Hebr" typeface="Times New Roman"/>
+        <a:font script="Thai" typeface="Angsana New"/>
+        <a:font script="Ethi" typeface="Nyala"/>
+        <a:font script="Beng" typeface="Vrinda"/>
+        <a:font script="Gujr" typeface="Shruti"/>
+        <a:font script="Khmr" typeface="MoolBoran"/>
+        <a:font script="Knda" typeface="Tunga"/>
+        <a:font script="Guru" typeface="Raavi"/>
+        <a:font script="Cans" typeface="Euphemia"/>
+        <a:font script="Cher" typeface="Plantagenet Cherokee"/>
+        <a:font script="Yiii" typeface="Microsoft Yi Baiti"/>
+        <a:font script="Tibt" typeface="Microsoft Himalaya"/>
+        <a:font script="Thaa" typeface="MV Boli"/>
+        <a:font script="Deva" typeface="Mangal"/>
+        <a:font script="Telu" typeface="Gautami"/>
+        <a:font script="Taml" typeface="Latha"/>
+        <a:font script="Syrc" typeface="Estrangelo Edessa"/>
+        <a:font script="Orya" typeface="Kalinga"/>
+        <a:font script="Mlym" typeface="Kartika"/>
+        <a:font script="Laoo" typeface="DokChampa"/>
+        <a:font script="Sinh" typeface="Iskoola Pota"/>
+        <a:font script="Mong" typeface="Mongolian Baiti"/>
+        <a:font script="Viet" typeface="Times New Roman"/>
+        <a:font script="Uigh" typeface="Microsoft Uighur"/>
+        <a:font script="Geor" typeface="Sylfaen"/>
+      </a:majorFont>
+      <a:minorFont>
+        <a:latin typeface="Calibri"/>
+        <a:ea typeface=""/>
+        <a:cs typeface=""/>
+        <a:font script="Jpan" typeface="ＭＳ Ｐゴシック"/>
+        <a:font script="Hang" typeface="맑은 고딕"/>
+        <a:font script="Hans" typeface="宋体"/>
+        <a:font script="Hant" typeface="新細明體"/>
+        <a:font script="Arab" typeface="Arial"/>
+        <a:font script="Hebr" typeface="Arial"/>
+        <a:font script="Thai" typeface="Cordia New"/>
+        <a:font script="Ethi" typeface="Nyala"/>
+        <a:font script="Beng" typeface="Vrinda"/>
+        <a:font script="Gujr" typeface="Shruti"/>
+        <a:font script="Khmr" typeface="DaunPenh"/>
+        <a:font script="Knda" typeface="Tunga"/>
+        <a:font script="Guru" typeface="Raavi"/>
+        <a:font script="Cans" typeface="Euphemia"/>
+        <a:font script="Cher" typeface="Plantagenet Cherokee"/>
+        <a:font script="Yiii" typeface="Microsoft Yi Baiti"/>
+        <a:font script="Tibt" typeface="Microsoft Himalaya"/>
+        <a:font script="Thaa" typeface="MV Boli"/>
+        <a:font script="Deva" typeface="Mangal"/>
+        <a:font script="Telu" typeface="Gautami"/>
+        <a:font script="Taml" typeface="Latha"/>
+        <a:font script="Syrc" typeface="Estrangelo Edessa"/>
+        <a:font script="Orya" typeface="Kalinga"/>
+        <a:font script="Mlym" typeface="Kartika"/>
+        <a:font script="Laoo" typeface="DokChampa"/>
+        <a:font script="Sinh" typeface="Iskoola Pota"/>
+        <a:font script="Mong" typeface="Mongolian Baiti"/>
+        <a:font script="Viet" typeface="Arial"/>
+        <a:font script="Uigh" typeface="Microsoft Uighur"/>
+        <a:font script="Geor" typeface="Sylfaen"/>
+      </a:minorFont>
+    </a:fontScheme>
+    <a:fmtScheme name="Office">
+      <a:fillStyleLst>
+        <a:solidFill>
+          <a:schemeClr val="phClr"/>
+        </a:solidFill>
+        <a:gradFill rotWithShape="1">
+          <a:gsLst>
+            <a:gs pos="0">
+              <a:schemeClr val="phClr">
+                <a:tint val="50000"/>
+                <a:satMod val="300000"/>
+              </a:schemeClr>
+            </a:gs>
+            <a:gs pos="35000">
+              <a:schemeClr val="phClr">
+                <a:tint val="37000"/>
+                <a:satMod val="300000"/>
+              </a:schemeClr>
+            </a:gs>
+            <a:gs pos="100000">
+              <a:schemeClr val="phClr">
+                <a:tint val="15000"/>
+                <a:satMod val="350000"/>
+              </a:schemeClr>
+            </a:gs>
+          </a:gsLst>
+          <a:lin ang="16200000" scaled="1"/>
+        </a:gradFill>
+        <a:gradFill rotWithShape="1">
+          <a:gsLst>
+            <a:gs pos="0">
+              <a:schemeClr val="phClr">
+                <a:tint val="100000"/>
+                <a:shade val="100000"/>
+                <a:satMod val="130000"/>
+              </a:schemeClr>
+            </a:gs>
+            <a:gs pos="100000">
+              <a:schemeClr val="phClr">
+                <a:tint val="50000"/>
+                <a:shade val="100000"/>
+                <a:satMod val="350000"/>
+              </a:schemeClr>
+            </a:gs>
+          </a:gsLst>
+          <a:lin ang="16200000" scaled="0"/>
+        </a:gradFill>
+      </a:fillStyleLst>
+      <a:lnStyleLst>
+        <a:ln w="9525" cap="flat" cmpd="sng" algn="ctr">
+          <a:solidFill>
+            <a:schemeClr val="phClr">
+              <a:shade val="95000"/>
+              <a:satMod val="105000"/>
+            </a:schemeClr>
+          </a:solidFill>
+          <a:prstDash val="solid"/>
+        </a:ln>
+        <a:ln w="25400" cap="flat" cmpd="sng" algn="ctr">
+          <a:solidFill>
+            <a:schemeClr val="phClr"/>
+          </a:solidFill>
+          <a:prstDash val="solid"/>
+        </a:ln>
+        <a:ln w="38100" cap="flat" cmpd="sng" algn="ctr">
+          <a:solidFill>
+            <a:schemeClr val="phClr"/>
+          </a:solidFill>
+          <a:prstDash val="solid"/>
+        </a:ln>
+      </a:lnStyleLst>
+      <a:effectStyleLst>
+        <a:effectStyle>
+          <a:effectLst>
+            <a:outerShdw blurRad="40000" dist="20000" dir="5400000" rotWithShape="0">
+              <a:srgbClr val="000000">
+                <a:alpha val="38000"/>
+              </a:srgbClr>
+            </a:outerShdw>
+          </a:effectLst>
+        </a:effectStyle>
+        <a:effectStyle>
+          <a:effectLst>
+            <a:outerShdw blurRad="40000" dist="23000" dir="5400000" rotWithShape="0">
+              <a:srgbClr val="000000">
+                <a:alpha val="35000"/>
+              </a:srgbClr>
+            </a:outerShdw>
+          </a:effectLst>
+        </a:effectStyle>
+        <a:effectStyle>
+          <a:effectLst>
+            <a:outerShdw blurRad="40000" dist="23000" dir="5400000" rotWithShape="0">
+              <a:srgbClr val="000000">
+                <a:alpha val="35000"/>
+              </a:srgbClr>
+            </a:outerShdw>
+          </a:effectLst>
+          <a:scene3d>
+            <a:camera prst="orthographicFront">
+              <a:rot lat="0" lon="0" rev="0"/>
+            </a:camera>
+            <a:lightRig rig="threePt" dir="t">
+              <a:rot lat="0" lon="0" rev="1200000"/>
+            </a:lightRig>
+          </a:scene3d>
+          <a:sp3d>
+            <a:bevelT w="63500" h="25400"/>
+          </a:sp3d>
+        </a:effectStyle>
+      </a:effectStyleLst>
+      <a:bgFillStyleLst>
+        <a:solidFill>
+          <a:schemeClr val="phClr"/>
+        </a:solidFill>
+        <a:gradFill rotWithShape="1">
+          <a:gsLst>
+            <a:gs pos="0">
+              <a:schemeClr val="phClr">
+                <a:tint val="40000"/>
+                <a:satMod val="350000"/>
+              </a:schemeClr>
+            </a:gs>
+            <a:gs pos="40000">
+              <a:schemeClr val="phClr">
+                <a:tint val="45000"/>
+                <a:shade val="99000"/>
+                <a:satMod val="350000"/>
+              </a:schemeClr>
+            </a:gs>
+            <a:gs pos="100000">
+              <a:schemeClr val="phClr">
+                <a:shade val="20000"/>
+                <a:satMod val="255000"/>
+              </a:schemeClr>
+            </a:gs>
+          </a:gsLst>
+          <a:path path="circle">
+            <a:fillToRect l="50000" t="-80000" r="50000" b="180000"/>
+          </a:path>
+        </a:gradFill>
+        <a:gradFill rotWithShape="1">
+          <a:gsLst>
+            <a:gs pos="0">
+              <a:schemeClr val="phClr">
+                <a:tint val="80000"/>
+                <a:satMod val="300000"/>
+              </a:schemeClr>
+            </a:gs>
+            <a:gs pos="100000">
+              <a:schemeClr val="phClr">
+                <a:shade val="30000"/>
+                <a:satMod val="200000"/>
+              </a:schemeClr>
+            </a:gs>
+          </a:gsLst>
+          <a:path path="circle">
+            <a:fillToRect l="50000" t="50000" r="50000" b="50000"/>
+          </a:path>
+        </a:gradFill>
+      </a:bgFillStyleLst>
+    </a:fmtScheme>
+  </a:themeElements>
+  <a:objectDefaults>
+    <a:spDef>
+      <a:spPr/>
+      <a:bodyPr/>
+      <a:lstStyle/>
+      <a:style>
+        <a:lnRef idx="1">
+          <a:schemeClr val="accent1"/>
+        </a:lnRef>
+        <a:fillRef idx="3">
+          <a:schemeClr val="accent1"/>
+        </a:fillRef>
+        <a:effectRef idx="2">
+          <a:schemeClr val="accent1"/>
+        </a:effectRef>
+        <a:fontRef idx="minor">
+          <a:schemeClr val="lt1"/>
+        </a:fontRef>
+      </a:style>
+    </a:spDef>
+    <a:lnDef>
+      <a:spPr/>
+      <a:bodyPr/>
+      <a:lstStyle/>
+      <a:style>
+        <a:lnRef idx="2">
+          <a:schemeClr val="accent1"/>
+        </a:lnRef>
+        <a:fillRef idx="0">
+          <a:schemeClr val="accent1"/>
+        </a:fillRef>
+        <a:effectRef idx="1">
+          <a:schemeClr val="accent1"/>
+        </a:effectRef>
+        <a:fontRef idx="minor">
+          <a:schemeClr val="tx1"/>
+        </a:fontRef>
+      </a:style>
+    </a:lnDef>
+  </a:objectDefaults>
+  <a:extraClrSchemeLst/>
+</a:theme>
 </file>
</xml_diff>

<commit_message>
Add enterprise OpenAI placeholders, external temp-code mode (hidden project fields), simulated OTP, fake sample docs, and update pitch deck to 16 slides
</commit_message>
<xml_diff>
--- a/pitch/acres_pitch_deck.pptx
+++ b/pitch/acres_pitch_deck.pptx
@@ -19,6 +19,8 @@
     <p:sldId id="267" r:id="rId18"/>
     <p:sldId id="268" r:id="rId19"/>
     <p:sldId id="269" r:id="rId20"/>
+    <p:sldId id="270" r:id="rId21"/>
+    <p:sldId id="271" r:id="rId22"/>
   </p:sldIdLst>
   <p:sldSz cx="12191695" cy="6858000" type="screen4x3"/>
   <p:notesSz cx="6858000" cy="9144000"/>
@@ -585,7 +587,7 @@
           <a:lstStyle/>
           <a:p>
             <a:r>
-              <a:t>Faster, more accurate, less admin, safer and scalable across projects.</a:t>
+              <a:t>Applicants, executives, ops managers and admin teams all benefit.</a:t>
             </a:r>
           </a:p>
         </p:txBody>
@@ -655,7 +657,7 @@
           <a:lstStyle/>
           <a:p>
             <a:r>
-              <a:t>This is a working prototype, tested on real scanned clearance documents.</a:t>
+              <a:t>Faster, more accurate, less admin, safer and scalable across projects.</a:t>
             </a:r>
           </a:p>
         </p:txBody>
@@ -725,7 +727,7 @@
           <a:lstStyle/>
           <a:p>
             <a:r>
-              <a:t>Next: real email sending, live register + SSO, audit trail and analytics.</a:t>
+              <a:t>This is a working prototype, tested on real scanned clearance documents.</a:t>
             </a:r>
           </a:p>
         </p:txBody>
@@ -795,7 +797,7 @@
           <a:lstStyle/>
           <a:p>
             <a:r>
-              <a:t>Sensitive data and model accuracy are handled with local AI and deterministic parsing.</a:t>
+              <a:t>Demos use obviously fake data, the AI is ready for the enterprise provider, and a mobile code confirms the submission.</a:t>
             </a:r>
           </a:p>
         </p:txBody>
@@ -865,6 +867,146 @@
           <a:lstStyle/>
           <a:p>
             <a:r>
+              <a:t>Next: real email sending, live register + SSO, audit trail and analytics.</a:t>
+            </a:r>
+          </a:p>
+        </p:txBody>
+      </p:sp>
+      <p:sp>
+        <p:nvSpPr>
+          <p:cNvPr id="4" name="Slide Number Placeholder 3"/>
+          <p:cNvSpPr>
+            <a:spLocks noGrp="1"/>
+          </p:cNvSpPr>
+          <p:nvPr>
+            <p:ph type="sldNum" idx="5" sz="quarter"/>
+          </p:nvPr>
+        </p:nvSpPr>
+        <p:spPr/>
+      </p:sp>
+    </p:spTree>
+  </p:cSld>
+  <p:clrMapOvr>
+    <a:masterClrMapping/>
+  </p:clrMapOvr>
+</p:notes>
+</file>
+
+<file path=ppt/notesSlides/notesSlide15.xml><?xml version="1.0" encoding="utf-8"?>
+<p:notes xmlns:a="http://schemas.openxmlformats.org/drawingml/2006/main" xmlns:p="http://schemas.openxmlformats.org/presentationml/2006/main" xmlns:r="http://schemas.openxmlformats.org/officeDocument/2006/relationships">
+  <p:cSld>
+    <p:spTree>
+      <p:nvGrpSpPr>
+        <p:cNvPr id="1" name=""/>
+        <p:cNvGrpSpPr/>
+        <p:nvPr/>
+      </p:nvGrpSpPr>
+      <p:grpSpPr>
+        <a:xfrm>
+          <a:off x="0" y="0"/>
+          <a:ext cx="0" cy="0"/>
+          <a:chOff x="0" y="0"/>
+          <a:chExt cx="0" cy="0"/>
+        </a:xfrm>
+      </p:grpSpPr>
+      <p:sp>
+        <p:nvSpPr>
+          <p:cNvPr id="2" name="Slide Image Placeholder 1"/>
+          <p:cNvSpPr>
+            <a:spLocks noGrp="1"/>
+          </p:cNvSpPr>
+          <p:nvPr>
+            <p:ph type="sldImg" idx="2"/>
+          </p:nvPr>
+        </p:nvSpPr>
+        <p:spPr/>
+      </p:sp>
+      <p:sp>
+        <p:nvSpPr>
+          <p:cNvPr id="3" name="Notes Placeholder 2"/>
+          <p:cNvSpPr>
+            <a:spLocks noGrp="1"/>
+          </p:cNvSpPr>
+          <p:nvPr>
+            <p:ph type="body" idx="3" sz="quarter"/>
+          </p:nvPr>
+        </p:nvSpPr>
+        <p:spPr/>
+        <p:txBody>
+          <a:bodyPr/>
+          <a:lstStyle/>
+          <a:p>
+            <a:r>
+              <a:t>Sensitive data and model accuracy are handled with local AI and deterministic parsing.</a:t>
+            </a:r>
+          </a:p>
+        </p:txBody>
+      </p:sp>
+      <p:sp>
+        <p:nvSpPr>
+          <p:cNvPr id="4" name="Slide Number Placeholder 3"/>
+          <p:cNvSpPr>
+            <a:spLocks noGrp="1"/>
+          </p:cNvSpPr>
+          <p:nvPr>
+            <p:ph type="sldNum" idx="5" sz="quarter"/>
+          </p:nvPr>
+        </p:nvSpPr>
+        <p:spPr/>
+      </p:sp>
+    </p:spTree>
+  </p:cSld>
+  <p:clrMapOvr>
+    <a:masterClrMapping/>
+  </p:clrMapOvr>
+</p:notes>
+</file>
+
+<file path=ppt/notesSlides/notesSlide16.xml><?xml version="1.0" encoding="utf-8"?>
+<p:notes xmlns:a="http://schemas.openxmlformats.org/drawingml/2006/main" xmlns:p="http://schemas.openxmlformats.org/presentationml/2006/main" xmlns:r="http://schemas.openxmlformats.org/officeDocument/2006/relationships">
+  <p:cSld>
+    <p:spTree>
+      <p:nvGrpSpPr>
+        <p:cNvPr id="1" name=""/>
+        <p:cNvGrpSpPr/>
+        <p:nvPr/>
+      </p:nvGrpSpPr>
+      <p:grpSpPr>
+        <a:xfrm>
+          <a:off x="0" y="0"/>
+          <a:ext cx="0" cy="0"/>
+          <a:chOff x="0" y="0"/>
+          <a:chExt cx="0" cy="0"/>
+        </a:xfrm>
+      </p:grpSpPr>
+      <p:sp>
+        <p:nvSpPr>
+          <p:cNvPr id="2" name="Slide Image Placeholder 1"/>
+          <p:cNvSpPr>
+            <a:spLocks noGrp="1"/>
+          </p:cNvSpPr>
+          <p:nvPr>
+            <p:ph type="sldImg" idx="2"/>
+          </p:nvPr>
+        </p:nvSpPr>
+        <p:spPr/>
+      </p:sp>
+      <p:sp>
+        <p:nvSpPr>
+          <p:cNvPr id="3" name="Notes Placeholder 2"/>
+          <p:cNvSpPr>
+            <a:spLocks noGrp="1"/>
+          </p:cNvSpPr>
+          <p:nvPr>
+            <p:ph type="body" idx="3" sz="quarter"/>
+          </p:nvPr>
+        </p:nvSpPr>
+        <p:spPr/>
+        <p:txBody>
+          <a:bodyPr/>
+          <a:lstStyle/>
+          <a:p>
+            <a:r>
               <a:t>The ask: pilot with one project team and measure the before/after.</a:t>
             </a:r>
           </a:p>
@@ -1355,7 +1497,7 @@
           <a:lstStyle/>
           <a:p>
             <a:r>
-              <a:t>It doesn't just digitise the form — it removes the middleman and keeps a private, local option.</a:t>
+              <a:t>External parties often don't know the project. They enter a confidential code; the real project details are attached automatically and never shown to them.</a:t>
             </a:r>
           </a:p>
         </p:txBody>
@@ -1425,7 +1567,7 @@
           <a:lstStyle/>
           <a:p>
             <a:r>
-              <a:t>Applicants, executives, ops managers and admin teams all benefit.</a:t>
+              <a:t>It doesn't just digitise the form — it removes the middleman and keeps a private, local option.</a:t>
             </a:r>
           </a:p>
         </p:txBody>
@@ -4794,7 +4936,7 @@
               </a:defRPr>
             </a:pPr>
             <a:r>
-              <a:t>1 / 14</a:t>
+              <a:t>1 / 16</a:t>
             </a:r>
           </a:p>
         </p:txBody>
@@ -4895,7 +5037,7 @@
               </a:defRPr>
             </a:pPr>
             <a:r>
-              <a:t>IMPACT</a:t>
+              <a:t>WHO IT'S FOR</a:t>
             </a:r>
           </a:p>
         </p:txBody>
@@ -4934,7 +5076,7 @@
               </a:defRPr>
             </a:pPr>
             <a:r>
-              <a:t>Faster, cleaner, safer</a:t>
+              <a:t>Built for everyone in the clearance chain</a:t>
             </a:r>
           </a:p>
         </p:txBody>
@@ -4947,19 +5089,19 @@
         </p:nvSpPr>
         <p:spPr>
           <a:xfrm>
-            <a:off x="868680" y="2651760"/>
-            <a:ext cx="5029200" cy="1371600"/>
+            <a:off x="868680" y="2834640"/>
+            <a:ext cx="3474720" cy="502920"/>
           </a:xfrm>
           <a:prstGeom prst="roundRect">
-            <a:avLst>
-              <a:gd name="adj" fmla="val 6000"/>
-            </a:avLst>
+            <a:avLst/>
           </a:prstGeom>
           <a:solidFill>
             <a:srgbClr val="F4F6F8"/>
           </a:solidFill>
           <a:ln>
-            <a:noFill/>
+            <a:solidFill>
+              <a:srgbClr val="DDE3EA"/>
+            </a:solidFill>
           </a:ln>
           <a:effectLst/>
         </p:spPr>
@@ -4978,14 +5120,11 @@
           </a:fontRef>
         </p:style>
         <p:txBody>
-          <a:bodyPr rtlCol="0" anchor="ctr" wrap="square" lIns="274320" rIns="182880" tIns="137160"/>
+          <a:bodyPr rtlCol="0" anchor="ctr" wrap="none"/>
           <a:lstStyle/>
           <a:p>
             <a:pPr algn="ctr">
-              <a:spcAft>
-                <a:spcPts val="300"/>
-              </a:spcAft>
-              <a:defRPr sz="1500" b="1">
+              <a:defRPr sz="1400" b="1">
                 <a:solidFill>
                   <a:srgbClr val="18418A"/>
                 </a:solidFill>
@@ -4993,43 +5132,32 @@
               </a:defRPr>
             </a:pPr>
             <a:r>
-              <a:t>Faster</a:t>
-            </a:r>
-          </a:p>
-          <a:p>
-            <a:pPr>
-              <a:defRPr sz="1300">
-                <a:solidFill>
-                  <a:srgbClr val="2A3442"/>
-                </a:solidFill>
-                <a:latin typeface="Arial"/>
-              </a:defRPr>
-            </a:pPr>
-            <a:r>
-              <a:t>Minutes instead of days of back-and-forth.</a:t>
-            </a:r>
-          </a:p>
-        </p:txBody>
-      </p:sp>
-      <p:sp>
-        <p:nvSpPr>
-          <p:cNvPr id="6" name="Rectangle 5"/>
+              <a:t>Applicants</a:t>
+            </a:r>
+          </a:p>
+        </p:txBody>
+      </p:sp>
+      <p:sp>
+        <p:nvSpPr>
+          <p:cNvPr id="6" name="Rounded Rectangle 5"/>
           <p:cNvSpPr/>
           <p:nvPr/>
         </p:nvSpPr>
         <p:spPr>
           <a:xfrm>
-            <a:off x="868680" y="2724912"/>
-            <a:ext cx="82296" cy="1225296"/>
-          </a:xfrm>
-          <a:prstGeom prst="rect">
+            <a:off x="4617720" y="2834640"/>
+            <a:ext cx="5815583" cy="502920"/>
+          </a:xfrm>
+          <a:prstGeom prst="roundRect">
             <a:avLst/>
           </a:prstGeom>
           <a:solidFill>
-            <a:srgbClr val="009E73"/>
+            <a:srgbClr val="F4F6F8"/>
           </a:solidFill>
           <a:ln>
-            <a:noFill/>
+            <a:solidFill>
+              <a:srgbClr val="DDE3EA"/>
+            </a:solidFill>
           </a:ln>
           <a:effectLst/>
         </p:spPr>
@@ -5048,10 +5176,20 @@
           </a:fontRef>
         </p:style>
         <p:txBody>
-          <a:bodyPr rtlCol="0" anchor="ctr"/>
-          <a:lstStyle/>
-          <a:p>
-            <a:pPr algn="ctr"/>
+          <a:bodyPr rtlCol="0" anchor="ctr" wrap="none"/>
+          <a:lstStyle/>
+          <a:p>
+            <a:pPr algn="ctr">
+              <a:defRPr sz="1400" b="1">
+                <a:solidFill>
+                  <a:srgbClr val="18418A"/>
+                </a:solidFill>
+                <a:latin typeface="Arial"/>
+              </a:defRPr>
+            </a:pPr>
+            <a:r>
+              <a:t>Project executives</a:t>
+            </a:r>
           </a:p>
         </p:txBody>
       </p:sp>
@@ -5063,19 +5201,19 @@
         </p:nvSpPr>
         <p:spPr>
           <a:xfrm>
-            <a:off x="6355080" y="2651760"/>
-            <a:ext cx="5029200" cy="1371600"/>
+            <a:off x="10707623" y="2834640"/>
+            <a:ext cx="4059935" cy="502920"/>
           </a:xfrm>
           <a:prstGeom prst="roundRect">
-            <a:avLst>
-              <a:gd name="adj" fmla="val 6000"/>
-            </a:avLst>
+            <a:avLst/>
           </a:prstGeom>
           <a:solidFill>
             <a:srgbClr val="F4F6F8"/>
           </a:solidFill>
           <a:ln>
-            <a:noFill/>
+            <a:solidFill>
+              <a:srgbClr val="DDE3EA"/>
+            </a:solidFill>
           </a:ln>
           <a:effectLst/>
         </p:spPr>
@@ -5094,14 +5232,11 @@
           </a:fontRef>
         </p:style>
         <p:txBody>
-          <a:bodyPr rtlCol="0" anchor="ctr" wrap="square" lIns="274320" rIns="182880" tIns="137160"/>
+          <a:bodyPr rtlCol="0" anchor="ctr" wrap="none"/>
           <a:lstStyle/>
           <a:p>
             <a:pPr algn="ctr">
-              <a:spcAft>
-                <a:spcPts val="300"/>
-              </a:spcAft>
-              <a:defRPr sz="1500" b="1">
+              <a:defRPr sz="1400" b="1">
                 <a:solidFill>
                   <a:srgbClr val="18418A"/>
                 </a:solidFill>
@@ -5109,43 +5244,32 @@
               </a:defRPr>
             </a:pPr>
             <a:r>
-              <a:t>More accurate</a:t>
-            </a:r>
-          </a:p>
-          <a:p>
-            <a:pPr>
-              <a:defRPr sz="1300">
-                <a:solidFill>
-                  <a:srgbClr val="2A3442"/>
-                </a:solidFill>
-                <a:latin typeface="Arial"/>
-              </a:defRPr>
-            </a:pPr>
-            <a:r>
-              <a:t>Validated, standardized rows; fewer rework loops.</a:t>
-            </a:r>
-          </a:p>
-        </p:txBody>
-      </p:sp>
-      <p:sp>
-        <p:nvSpPr>
-          <p:cNvPr id="8" name="Rectangle 7"/>
+              <a:t>Ops managers</a:t>
+            </a:r>
+          </a:p>
+        </p:txBody>
+      </p:sp>
+      <p:sp>
+        <p:nvSpPr>
+          <p:cNvPr id="8" name="Rounded Rectangle 7"/>
           <p:cNvSpPr/>
           <p:nvPr/>
         </p:nvSpPr>
         <p:spPr>
           <a:xfrm>
-            <a:off x="6355080" y="2724912"/>
-            <a:ext cx="82296" cy="1225296"/>
-          </a:xfrm>
-          <a:prstGeom prst="rect">
+            <a:off x="15041878" y="2834640"/>
+            <a:ext cx="7571231" cy="502920"/>
+          </a:xfrm>
+          <a:prstGeom prst="roundRect">
             <a:avLst/>
           </a:prstGeom>
           <a:solidFill>
-            <a:srgbClr val="009E73"/>
+            <a:srgbClr val="F4F6F8"/>
           </a:solidFill>
           <a:ln>
-            <a:noFill/>
+            <a:solidFill>
+              <a:srgbClr val="DDE3EA"/>
+            </a:solidFill>
           </a:ln>
           <a:effectLst/>
         </p:spPr>
@@ -5164,60 +5288,11 @@
           </a:fontRef>
         </p:style>
         <p:txBody>
-          <a:bodyPr rtlCol="0" anchor="ctr"/>
-          <a:lstStyle/>
-          <a:p>
-            <a:pPr algn="ctr"/>
-          </a:p>
-        </p:txBody>
-      </p:sp>
-      <p:sp>
-        <p:nvSpPr>
-          <p:cNvPr id="9" name="Rounded Rectangle 8"/>
-          <p:cNvSpPr/>
-          <p:nvPr/>
-        </p:nvSpPr>
-        <p:spPr>
-          <a:xfrm>
-            <a:off x="868680" y="4343400"/>
-            <a:ext cx="5029200" cy="1371600"/>
-          </a:xfrm>
-          <a:prstGeom prst="roundRect">
-            <a:avLst>
-              <a:gd name="adj" fmla="val 6000"/>
-            </a:avLst>
-          </a:prstGeom>
-          <a:solidFill>
-            <a:srgbClr val="F4F6F8"/>
-          </a:solidFill>
-          <a:ln>
-            <a:noFill/>
-          </a:ln>
-          <a:effectLst/>
-        </p:spPr>
-        <p:style>
-          <a:lnRef idx="1">
-            <a:schemeClr val="accent1"/>
-          </a:lnRef>
-          <a:fillRef idx="3">
-            <a:schemeClr val="accent1"/>
-          </a:fillRef>
-          <a:effectRef idx="2">
-            <a:schemeClr val="accent1"/>
-          </a:effectRef>
-          <a:fontRef idx="minor">
-            <a:schemeClr val="lt1"/>
-          </a:fontRef>
-        </p:style>
-        <p:txBody>
-          <a:bodyPr rtlCol="0" anchor="ctr" wrap="square" lIns="274320" rIns="182880" tIns="137160"/>
+          <a:bodyPr rtlCol="0" anchor="ctr" wrap="none"/>
           <a:lstStyle/>
           <a:p>
             <a:pPr algn="ctr">
-              <a:spcAft>
-                <a:spcPts val="300"/>
-              </a:spcAft>
-              <a:defRPr sz="1500" b="1">
+              <a:defRPr sz="1400" b="1">
                 <a:solidFill>
                   <a:srgbClr val="18418A"/>
                 </a:solidFill>
@@ -5225,128 +5300,38 @@
               </a:defRPr>
             </a:pPr>
             <a:r>
-              <a:t>Less admin</a:t>
-            </a:r>
-          </a:p>
-          <a:p>
-            <a:pPr>
-              <a:defRPr sz="1300">
-                <a:solidFill>
-                  <a:srgbClr val="2A3442"/>
-                </a:solidFill>
-                <a:latin typeface="Arial"/>
-              </a:defRPr>
-            </a:pPr>
-            <a:r>
-              <a:t>The middleman step is eliminated.</a:t>
-            </a:r>
-          </a:p>
-        </p:txBody>
-      </p:sp>
-      <p:sp>
-        <p:nvSpPr>
-          <p:cNvPr id="10" name="Rectangle 9"/>
-          <p:cNvSpPr/>
-          <p:nvPr/>
-        </p:nvSpPr>
-        <p:spPr>
-          <a:xfrm>
-            <a:off x="868680" y="4416552"/>
-            <a:ext cx="82296" cy="1225296"/>
+              <a:t>Project / security admin</a:t>
+            </a:r>
+          </a:p>
+        </p:txBody>
+      </p:sp>
+      <p:sp>
+        <p:nvSpPr>
+          <p:cNvPr id="9" name="TextBox 8"/>
+          <p:cNvSpPr txBox="1"/>
+          <p:nvPr/>
+        </p:nvSpPr>
+        <p:spPr>
+          <a:xfrm>
+            <a:off x="868680" y="3931920"/>
+            <a:ext cx="10424160" cy="1280160"/>
           </a:xfrm>
           <a:prstGeom prst="rect">
             <a:avLst/>
           </a:prstGeom>
-          <a:solidFill>
-            <a:srgbClr val="18418A"/>
-          </a:solidFill>
-          <a:ln>
-            <a:noFill/>
-          </a:ln>
-          <a:effectLst/>
-        </p:spPr>
-        <p:style>
-          <a:lnRef idx="1">
-            <a:schemeClr val="accent1"/>
-          </a:lnRef>
-          <a:fillRef idx="3">
-            <a:schemeClr val="accent1"/>
-          </a:fillRef>
-          <a:effectRef idx="2">
-            <a:schemeClr val="accent1"/>
-          </a:effectRef>
-          <a:fontRef idx="minor">
-            <a:schemeClr val="lt1"/>
-          </a:fontRef>
-        </p:style>
-        <p:txBody>
-          <a:bodyPr rtlCol="0" anchor="ctr"/>
-          <a:lstStyle/>
-          <a:p>
-            <a:pPr algn="ctr"/>
-          </a:p>
-        </p:txBody>
-      </p:sp>
-      <p:sp>
-        <p:nvSpPr>
-          <p:cNvPr id="11" name="Rounded Rectangle 10"/>
-          <p:cNvSpPr/>
-          <p:nvPr/>
-        </p:nvSpPr>
-        <p:spPr>
-          <a:xfrm>
-            <a:off x="6355080" y="4343400"/>
-            <a:ext cx="5029200" cy="1371600"/>
-          </a:xfrm>
-          <a:prstGeom prst="roundRect">
-            <a:avLst>
-              <a:gd name="adj" fmla="val 6000"/>
-            </a:avLst>
-          </a:prstGeom>
-          <a:solidFill>
-            <a:srgbClr val="F4F6F8"/>
-          </a:solidFill>
-          <a:ln>
-            <a:noFill/>
-          </a:ln>
-          <a:effectLst/>
-        </p:spPr>
-        <p:style>
-          <a:lnRef idx="1">
-            <a:schemeClr val="accent1"/>
-          </a:lnRef>
-          <a:fillRef idx="3">
-            <a:schemeClr val="accent1"/>
-          </a:fillRef>
-          <a:effectRef idx="2">
-            <a:schemeClr val="accent1"/>
-          </a:effectRef>
-          <a:fontRef idx="minor">
-            <a:schemeClr val="lt1"/>
-          </a:fontRef>
-        </p:style>
-        <p:txBody>
-          <a:bodyPr rtlCol="0" anchor="ctr" wrap="square" lIns="274320" rIns="182880" tIns="137160"/>
-          <a:lstStyle/>
-          <a:p>
-            <a:pPr algn="ctr">
+          <a:noFill/>
+        </p:spPr>
+        <p:txBody>
+          <a:bodyPr wrap="square" anchor="t">
+            <a:normAutofit/>
+          </a:bodyPr>
+          <a:lstStyle/>
+          <a:p>
+            <a:pPr algn="l">
               <a:spcAft>
-                <a:spcPts val="300"/>
+                <a:spcPts val="0"/>
               </a:spcAft>
-              <a:defRPr sz="1500" b="1">
-                <a:solidFill>
-                  <a:srgbClr val="18418A"/>
-                </a:solidFill>
-                <a:latin typeface="Arial"/>
-              </a:defRPr>
-            </a:pPr>
-            <a:r>
-              <a:t>Safer &amp; scalable</a:t>
-            </a:r>
-          </a:p>
-          <a:p>
-            <a:pPr>
-              <a:defRPr sz="1300">
+              <a:defRPr sz="1600" b="0">
                 <a:solidFill>
                   <a:srgbClr val="2A3442"/>
                 </a:solidFill>
@@ -5354,58 +5339,14 @@
               </a:defRPr>
             </a:pPr>
             <a:r>
-              <a:t>Privacy-preserving local AI; one flow for every project.</a:t>
-            </a:r>
-          </a:p>
-        </p:txBody>
-      </p:sp>
-      <p:sp>
-        <p:nvSpPr>
-          <p:cNvPr id="12" name="Rectangle 11"/>
-          <p:cNvSpPr/>
-          <p:nvPr/>
-        </p:nvSpPr>
-        <p:spPr>
-          <a:xfrm>
-            <a:off x="6355080" y="4416552"/>
-            <a:ext cx="82296" cy="1225296"/>
-          </a:xfrm>
-          <a:prstGeom prst="rect">
-            <a:avLst/>
-          </a:prstGeom>
-          <a:solidFill>
-            <a:srgbClr val="18418A"/>
-          </a:solidFill>
-          <a:ln>
-            <a:noFill/>
-          </a:ln>
-          <a:effectLst/>
-        </p:spPr>
-        <p:style>
-          <a:lnRef idx="1">
-            <a:schemeClr val="accent1"/>
-          </a:lnRef>
-          <a:fillRef idx="3">
-            <a:schemeClr val="accent1"/>
-          </a:fillRef>
-          <a:effectRef idx="2">
-            <a:schemeClr val="accent1"/>
-          </a:effectRef>
-          <a:fontRef idx="minor">
-            <a:schemeClr val="lt1"/>
-          </a:fontRef>
-        </p:style>
-        <p:txBody>
-          <a:bodyPr rtlCol="0" anchor="ctr"/>
-          <a:lstStyle/>
-          <a:p>
-            <a:pPr algn="ctr"/>
-          </a:p>
-        </p:txBody>
-      </p:sp>
-      <p:sp>
-        <p:nvSpPr>
-          <p:cNvPr id="13" name="TextBox 12"/>
+              <a:t>Applicants complete the form; executives receive a ready package; ops managers endorse; admin teams get consistency and an audit trail.</a:t>
+            </a:r>
+          </a:p>
+        </p:txBody>
+      </p:sp>
+      <p:sp>
+        <p:nvSpPr>
+          <p:cNvPr id="10" name="TextBox 9"/>
           <p:cNvSpPr txBox="1"/>
           <p:nvPr/>
         </p:nvSpPr>
@@ -5437,7 +5378,7 @@
               </a:defRPr>
             </a:pPr>
             <a:r>
-              <a:t>10 / 14</a:t>
+              <a:t>10 / 16</a:t>
             </a:r>
           </a:p>
         </p:txBody>
@@ -5538,7 +5479,7 @@
               </a:defRPr>
             </a:pPr>
             <a:r>
-              <a:t>STATUS</a:t>
+              <a:t>IMPACT</a:t>
             </a:r>
           </a:p>
         </p:txBody>
@@ -5577,38 +5518,187 @@
               </a:defRPr>
             </a:pPr>
             <a:r>
-              <a:t>A working prototype, not a slide</a:t>
-            </a:r>
-          </a:p>
-        </p:txBody>
-      </p:sp>
-      <p:sp>
-        <p:nvSpPr>
-          <p:cNvPr id="5" name="TextBox 4"/>
-          <p:cNvSpPr txBox="1"/>
+              <a:t>Faster, cleaner, safer</a:t>
+            </a:r>
+          </a:p>
+        </p:txBody>
+      </p:sp>
+      <p:sp>
+        <p:nvSpPr>
+          <p:cNvPr id="5" name="Rounded Rectangle 4"/>
+          <p:cNvSpPr/>
           <p:nvPr/>
         </p:nvSpPr>
         <p:spPr>
           <a:xfrm>
             <a:off x="868680" y="2651760"/>
-            <a:ext cx="10424160" cy="3840480"/>
+            <a:ext cx="5029200" cy="1371600"/>
+          </a:xfrm>
+          <a:prstGeom prst="roundRect">
+            <a:avLst>
+              <a:gd name="adj" fmla="val 6000"/>
+            </a:avLst>
+          </a:prstGeom>
+          <a:solidFill>
+            <a:srgbClr val="F4F6F8"/>
+          </a:solidFill>
+          <a:ln>
+            <a:noFill/>
+          </a:ln>
+          <a:effectLst/>
+        </p:spPr>
+        <p:style>
+          <a:lnRef idx="1">
+            <a:schemeClr val="accent1"/>
+          </a:lnRef>
+          <a:fillRef idx="3">
+            <a:schemeClr val="accent1"/>
+          </a:fillRef>
+          <a:effectRef idx="2">
+            <a:schemeClr val="accent1"/>
+          </a:effectRef>
+          <a:fontRef idx="minor">
+            <a:schemeClr val="lt1"/>
+          </a:fontRef>
+        </p:style>
+        <p:txBody>
+          <a:bodyPr rtlCol="0" anchor="ctr" wrap="square" lIns="274320" rIns="182880" tIns="137160"/>
+          <a:lstStyle/>
+          <a:p>
+            <a:pPr algn="ctr">
+              <a:spcAft>
+                <a:spcPts val="300"/>
+              </a:spcAft>
+              <a:defRPr sz="1500" b="1">
+                <a:solidFill>
+                  <a:srgbClr val="18418A"/>
+                </a:solidFill>
+                <a:latin typeface="Arial"/>
+              </a:defRPr>
+            </a:pPr>
+            <a:r>
+              <a:t>Faster</a:t>
+            </a:r>
+          </a:p>
+          <a:p>
+            <a:pPr>
+              <a:defRPr sz="1300">
+                <a:solidFill>
+                  <a:srgbClr val="2A3442"/>
+                </a:solidFill>
+                <a:latin typeface="Arial"/>
+              </a:defRPr>
+            </a:pPr>
+            <a:r>
+              <a:t>Minutes instead of days of back-and-forth.</a:t>
+            </a:r>
+          </a:p>
+        </p:txBody>
+      </p:sp>
+      <p:sp>
+        <p:nvSpPr>
+          <p:cNvPr id="6" name="Rectangle 5"/>
+          <p:cNvSpPr/>
+          <p:nvPr/>
+        </p:nvSpPr>
+        <p:spPr>
+          <a:xfrm>
+            <a:off x="868680" y="2724912"/>
+            <a:ext cx="82296" cy="1225296"/>
           </a:xfrm>
           <a:prstGeom prst="rect">
             <a:avLst/>
           </a:prstGeom>
-          <a:noFill/>
-        </p:spPr>
-        <p:txBody>
-          <a:bodyPr wrap="square" anchor="t">
-            <a:normAutofit/>
-          </a:bodyPr>
-          <a:lstStyle/>
-          <a:p>
-            <a:pPr algn="l">
+          <a:solidFill>
+            <a:srgbClr val="009E73"/>
+          </a:solidFill>
+          <a:ln>
+            <a:noFill/>
+          </a:ln>
+          <a:effectLst/>
+        </p:spPr>
+        <p:style>
+          <a:lnRef idx="1">
+            <a:schemeClr val="accent1"/>
+          </a:lnRef>
+          <a:fillRef idx="3">
+            <a:schemeClr val="accent1"/>
+          </a:fillRef>
+          <a:effectRef idx="2">
+            <a:schemeClr val="accent1"/>
+          </a:effectRef>
+          <a:fontRef idx="minor">
+            <a:schemeClr val="lt1"/>
+          </a:fontRef>
+        </p:style>
+        <p:txBody>
+          <a:bodyPr rtlCol="0" anchor="ctr"/>
+          <a:lstStyle/>
+          <a:p>
+            <a:pPr algn="ctr"/>
+          </a:p>
+        </p:txBody>
+      </p:sp>
+      <p:sp>
+        <p:nvSpPr>
+          <p:cNvPr id="7" name="Rounded Rectangle 6"/>
+          <p:cNvSpPr/>
+          <p:nvPr/>
+        </p:nvSpPr>
+        <p:spPr>
+          <a:xfrm>
+            <a:off x="6355080" y="2651760"/>
+            <a:ext cx="5029200" cy="1371600"/>
+          </a:xfrm>
+          <a:prstGeom prst="roundRect">
+            <a:avLst>
+              <a:gd name="adj" fmla="val 6000"/>
+            </a:avLst>
+          </a:prstGeom>
+          <a:solidFill>
+            <a:srgbClr val="F4F6F8"/>
+          </a:solidFill>
+          <a:ln>
+            <a:noFill/>
+          </a:ln>
+          <a:effectLst/>
+        </p:spPr>
+        <p:style>
+          <a:lnRef idx="1">
+            <a:schemeClr val="accent1"/>
+          </a:lnRef>
+          <a:fillRef idx="3">
+            <a:schemeClr val="accent1"/>
+          </a:fillRef>
+          <a:effectRef idx="2">
+            <a:schemeClr val="accent1"/>
+          </a:effectRef>
+          <a:fontRef idx="minor">
+            <a:schemeClr val="lt1"/>
+          </a:fontRef>
+        </p:style>
+        <p:txBody>
+          <a:bodyPr rtlCol="0" anchor="ctr" wrap="square" lIns="274320" rIns="182880" tIns="137160"/>
+          <a:lstStyle/>
+          <a:p>
+            <a:pPr algn="ctr">
               <a:spcAft>
-                <a:spcPts val="1000"/>
+                <a:spcPts val="300"/>
               </a:spcAft>
-              <a:defRPr sz="1700" b="0">
+              <a:defRPr sz="1500" b="1">
+                <a:solidFill>
+                  <a:srgbClr val="18418A"/>
+                </a:solidFill>
+                <a:latin typeface="Arial"/>
+              </a:defRPr>
+            </a:pPr>
+            <a:r>
+              <a:t>More accurate</a:t>
+            </a:r>
+          </a:p>
+          <a:p>
+            <a:pPr>
+              <a:defRPr sz="1300">
                 <a:solidFill>
                   <a:srgbClr val="2A3442"/>
                 </a:solidFill>
@@ -5616,15 +5706,115 @@
               </a:defRPr>
             </a:pPr>
             <a:r>
-              <a:t>•   Deployed and iterated with real feedback.</a:t>
-            </a:r>
-          </a:p>
-          <a:p>
-            <a:pPr algn="l">
+              <a:t>Validated, standardized rows; fewer rework loops.</a:t>
+            </a:r>
+          </a:p>
+        </p:txBody>
+      </p:sp>
+      <p:sp>
+        <p:nvSpPr>
+          <p:cNvPr id="8" name="Rectangle 7"/>
+          <p:cNvSpPr/>
+          <p:nvPr/>
+        </p:nvSpPr>
+        <p:spPr>
+          <a:xfrm>
+            <a:off x="6355080" y="2724912"/>
+            <a:ext cx="82296" cy="1225296"/>
+          </a:xfrm>
+          <a:prstGeom prst="rect">
+            <a:avLst/>
+          </a:prstGeom>
+          <a:solidFill>
+            <a:srgbClr val="009E73"/>
+          </a:solidFill>
+          <a:ln>
+            <a:noFill/>
+          </a:ln>
+          <a:effectLst/>
+        </p:spPr>
+        <p:style>
+          <a:lnRef idx="1">
+            <a:schemeClr val="accent1"/>
+          </a:lnRef>
+          <a:fillRef idx="3">
+            <a:schemeClr val="accent1"/>
+          </a:fillRef>
+          <a:effectRef idx="2">
+            <a:schemeClr val="accent1"/>
+          </a:effectRef>
+          <a:fontRef idx="minor">
+            <a:schemeClr val="lt1"/>
+          </a:fontRef>
+        </p:style>
+        <p:txBody>
+          <a:bodyPr rtlCol="0" anchor="ctr"/>
+          <a:lstStyle/>
+          <a:p>
+            <a:pPr algn="ctr"/>
+          </a:p>
+        </p:txBody>
+      </p:sp>
+      <p:sp>
+        <p:nvSpPr>
+          <p:cNvPr id="9" name="Rounded Rectangle 8"/>
+          <p:cNvSpPr/>
+          <p:nvPr/>
+        </p:nvSpPr>
+        <p:spPr>
+          <a:xfrm>
+            <a:off x="868680" y="4343400"/>
+            <a:ext cx="5029200" cy="1371600"/>
+          </a:xfrm>
+          <a:prstGeom prst="roundRect">
+            <a:avLst>
+              <a:gd name="adj" fmla="val 6000"/>
+            </a:avLst>
+          </a:prstGeom>
+          <a:solidFill>
+            <a:srgbClr val="F4F6F8"/>
+          </a:solidFill>
+          <a:ln>
+            <a:noFill/>
+          </a:ln>
+          <a:effectLst/>
+        </p:spPr>
+        <p:style>
+          <a:lnRef idx="1">
+            <a:schemeClr val="accent1"/>
+          </a:lnRef>
+          <a:fillRef idx="3">
+            <a:schemeClr val="accent1"/>
+          </a:fillRef>
+          <a:effectRef idx="2">
+            <a:schemeClr val="accent1"/>
+          </a:effectRef>
+          <a:fontRef idx="minor">
+            <a:schemeClr val="lt1"/>
+          </a:fontRef>
+        </p:style>
+        <p:txBody>
+          <a:bodyPr rtlCol="0" anchor="ctr" wrap="square" lIns="274320" rIns="182880" tIns="137160"/>
+          <a:lstStyle/>
+          <a:p>
+            <a:pPr algn="ctr">
               <a:spcAft>
-                <a:spcPts val="1000"/>
+                <a:spcPts val="300"/>
               </a:spcAft>
-              <a:defRPr sz="1700" b="0">
+              <a:defRPr sz="1500" b="1">
+                <a:solidFill>
+                  <a:srgbClr val="18418A"/>
+                </a:solidFill>
+                <a:latin typeface="Arial"/>
+              </a:defRPr>
+            </a:pPr>
+            <a:r>
+              <a:t>Less admin</a:t>
+            </a:r>
+          </a:p>
+          <a:p>
+            <a:pPr>
+              <a:defRPr sz="1300">
                 <a:solidFill>
                   <a:srgbClr val="2A3442"/>
                 </a:solidFill>
@@ -5632,15 +5822,115 @@
               </a:defRPr>
             </a:pPr>
             <a:r>
-              <a:t>•   Reads real scanned clearance documents (OCR + AI).</a:t>
-            </a:r>
-          </a:p>
-          <a:p>
-            <a:pPr algn="l">
+              <a:t>The middleman step is eliminated.</a:t>
+            </a:r>
+          </a:p>
+        </p:txBody>
+      </p:sp>
+      <p:sp>
+        <p:nvSpPr>
+          <p:cNvPr id="10" name="Rectangle 9"/>
+          <p:cNvSpPr/>
+          <p:nvPr/>
+        </p:nvSpPr>
+        <p:spPr>
+          <a:xfrm>
+            <a:off x="868680" y="4416552"/>
+            <a:ext cx="82296" cy="1225296"/>
+          </a:xfrm>
+          <a:prstGeom prst="rect">
+            <a:avLst/>
+          </a:prstGeom>
+          <a:solidFill>
+            <a:srgbClr val="18418A"/>
+          </a:solidFill>
+          <a:ln>
+            <a:noFill/>
+          </a:ln>
+          <a:effectLst/>
+        </p:spPr>
+        <p:style>
+          <a:lnRef idx="1">
+            <a:schemeClr val="accent1"/>
+          </a:lnRef>
+          <a:fillRef idx="3">
+            <a:schemeClr val="accent1"/>
+          </a:fillRef>
+          <a:effectRef idx="2">
+            <a:schemeClr val="accent1"/>
+          </a:effectRef>
+          <a:fontRef idx="minor">
+            <a:schemeClr val="lt1"/>
+          </a:fontRef>
+        </p:style>
+        <p:txBody>
+          <a:bodyPr rtlCol="0" anchor="ctr"/>
+          <a:lstStyle/>
+          <a:p>
+            <a:pPr algn="ctr"/>
+          </a:p>
+        </p:txBody>
+      </p:sp>
+      <p:sp>
+        <p:nvSpPr>
+          <p:cNvPr id="11" name="Rounded Rectangle 10"/>
+          <p:cNvSpPr/>
+          <p:nvPr/>
+        </p:nvSpPr>
+        <p:spPr>
+          <a:xfrm>
+            <a:off x="6355080" y="4343400"/>
+            <a:ext cx="5029200" cy="1371600"/>
+          </a:xfrm>
+          <a:prstGeom prst="roundRect">
+            <a:avLst>
+              <a:gd name="adj" fmla="val 6000"/>
+            </a:avLst>
+          </a:prstGeom>
+          <a:solidFill>
+            <a:srgbClr val="F4F6F8"/>
+          </a:solidFill>
+          <a:ln>
+            <a:noFill/>
+          </a:ln>
+          <a:effectLst/>
+        </p:spPr>
+        <p:style>
+          <a:lnRef idx="1">
+            <a:schemeClr val="accent1"/>
+          </a:lnRef>
+          <a:fillRef idx="3">
+            <a:schemeClr val="accent1"/>
+          </a:fillRef>
+          <a:effectRef idx="2">
+            <a:schemeClr val="accent1"/>
+          </a:effectRef>
+          <a:fontRef idx="minor">
+            <a:schemeClr val="lt1"/>
+          </a:fontRef>
+        </p:style>
+        <p:txBody>
+          <a:bodyPr rtlCol="0" anchor="ctr" wrap="square" lIns="274320" rIns="182880" tIns="137160"/>
+          <a:lstStyle/>
+          <a:p>
+            <a:pPr algn="ctr">
               <a:spcAft>
-                <a:spcPts val="1000"/>
+                <a:spcPts val="300"/>
               </a:spcAft>
-              <a:defRPr sz="1700" b="0">
+              <a:defRPr sz="1500" b="1">
+                <a:solidFill>
+                  <a:srgbClr val="18418A"/>
+                </a:solidFill>
+                <a:latin typeface="Arial"/>
+              </a:defRPr>
+            </a:pPr>
+            <a:r>
+              <a:t>Safer &amp; scalable</a:t>
+            </a:r>
+          </a:p>
+          <a:p>
+            <a:pPr>
+              <a:defRPr sz="1300">
                 <a:solidFill>
                   <a:srgbClr val="2A3442"/>
                 </a:solidFill>
@@ -5648,30 +5938,58 @@
               </a:defRPr>
             </a:pPr>
             <a:r>
-              <a:t>•   Handles the full ACRES field set and per-project routing.</a:t>
-            </a:r>
-          </a:p>
-          <a:p>
-            <a:pPr algn="l">
-              <a:spcAft>
-                <a:spcPts val="1000"/>
-              </a:spcAft>
-              <a:defRPr sz="1700" b="0">
-                <a:solidFill>
-                  <a:srgbClr val="2A3442"/>
-                </a:solidFill>
-                <a:latin typeface="Arial"/>
-              </a:defRPr>
-            </a:pPr>
-            <a:r>
-              <a:t>•   AI backend options integrated: local Ollama, Gemini free tier, OpenCode Go, any OpenAI-compatible provider.</a:t>
-            </a:r>
-          </a:p>
-        </p:txBody>
-      </p:sp>
-      <p:sp>
-        <p:nvSpPr>
-          <p:cNvPr id="6" name="TextBox 5"/>
+              <a:t>Privacy-preserving local AI; one flow for every project.</a:t>
+            </a:r>
+          </a:p>
+        </p:txBody>
+      </p:sp>
+      <p:sp>
+        <p:nvSpPr>
+          <p:cNvPr id="12" name="Rectangle 11"/>
+          <p:cNvSpPr/>
+          <p:nvPr/>
+        </p:nvSpPr>
+        <p:spPr>
+          <a:xfrm>
+            <a:off x="6355080" y="4416552"/>
+            <a:ext cx="82296" cy="1225296"/>
+          </a:xfrm>
+          <a:prstGeom prst="rect">
+            <a:avLst/>
+          </a:prstGeom>
+          <a:solidFill>
+            <a:srgbClr val="18418A"/>
+          </a:solidFill>
+          <a:ln>
+            <a:noFill/>
+          </a:ln>
+          <a:effectLst/>
+        </p:spPr>
+        <p:style>
+          <a:lnRef idx="1">
+            <a:schemeClr val="accent1"/>
+          </a:lnRef>
+          <a:fillRef idx="3">
+            <a:schemeClr val="accent1"/>
+          </a:fillRef>
+          <a:effectRef idx="2">
+            <a:schemeClr val="accent1"/>
+          </a:effectRef>
+          <a:fontRef idx="minor">
+            <a:schemeClr val="lt1"/>
+          </a:fontRef>
+        </p:style>
+        <p:txBody>
+          <a:bodyPr rtlCol="0" anchor="ctr"/>
+          <a:lstStyle/>
+          <a:p>
+            <a:pPr algn="ctr"/>
+          </a:p>
+        </p:txBody>
+      </p:sp>
+      <p:sp>
+        <p:nvSpPr>
+          <p:cNvPr id="13" name="TextBox 12"/>
           <p:cNvSpPr txBox="1"/>
           <p:nvPr/>
         </p:nvSpPr>
@@ -5703,7 +6021,7 @@
               </a:defRPr>
             </a:pPr>
             <a:r>
-              <a:t>11 / 14</a:t>
+              <a:t>11 / 16</a:t>
             </a:r>
           </a:p>
         </p:txBody>
@@ -5804,7 +6122,7 @@
               </a:defRPr>
             </a:pPr>
             <a:r>
-              <a:t>ROADMAP</a:t>
+              <a:t>STATUS</a:t>
             </a:r>
           </a:p>
         </p:txBody>
@@ -5843,7 +6161,7 @@
               </a:defRPr>
             </a:pPr>
             <a:r>
-              <a:t>From prototype to production</a:t>
+              <a:t>A working prototype, not a slide</a:t>
             </a:r>
           </a:p>
         </p:txBody>
@@ -5874,7 +6192,7 @@
               <a:spcAft>
                 <a:spcPts val="1000"/>
               </a:spcAft>
-              <a:defRPr sz="1800" b="0">
+              <a:defRPr sz="1700" b="0">
                 <a:solidFill>
                   <a:srgbClr val="2A3442"/>
                 </a:solidFill>
@@ -5882,7 +6200,7 @@
               </a:defRPr>
             </a:pPr>
             <a:r>
-              <a:t>•   Real email sending (SMTP/API) with delivery receipts.</a:t>
+              <a:t>•   Deployed and iterated with real feedback.</a:t>
             </a:r>
           </a:p>
           <a:p>
@@ -5890,7 +6208,7 @@
               <a:spcAft>
                 <a:spcPts val="1000"/>
               </a:spcAft>
-              <a:defRPr sz="1800" b="0">
+              <a:defRPr sz="1700" b="0">
                 <a:solidFill>
                   <a:srgbClr val="2A3442"/>
                 </a:solidFill>
@@ -5898,7 +6216,7 @@
               </a:defRPr>
             </a:pPr>
             <a:r>
-              <a:t>•   Live project-register integration and SSO / role-based access.</a:t>
+              <a:t>•   Reads real scanned clearance documents (OCR + AI).</a:t>
             </a:r>
           </a:p>
           <a:p>
@@ -5906,7 +6224,7 @@
               <a:spcAft>
                 <a:spcPts val="1000"/>
               </a:spcAft>
-              <a:defRPr sz="1800" b="0">
+              <a:defRPr sz="1700" b="0">
                 <a:solidFill>
                   <a:srgbClr val="2A3442"/>
                 </a:solidFill>
@@ -5914,7 +6232,7 @@
               </a:defRPr>
             </a:pPr>
             <a:r>
-              <a:t>•   Audit trail and submission tracking.</a:t>
+              <a:t>•   Handles the full ACRES field set and per-project routing.</a:t>
             </a:r>
           </a:p>
           <a:p>
@@ -5922,7 +6240,7 @@
               <a:spcAft>
                 <a:spcPts val="1000"/>
               </a:spcAft>
-              <a:defRPr sz="1800" b="0">
+              <a:defRPr sz="1700" b="0">
                 <a:solidFill>
                   <a:srgbClr val="2A3442"/>
                 </a:solidFill>
@@ -5930,23 +6248,7 @@
               </a:defRPr>
             </a:pPr>
             <a:r>
-              <a:t>•   Multiple clearance rows per applicant; category-aware routing.</a:t>
-            </a:r>
-          </a:p>
-          <a:p>
-            <a:pPr algn="l">
-              <a:spcAft>
-                <a:spcPts val="1000"/>
-              </a:spcAft>
-              <a:defRPr sz="1800" b="0">
-                <a:solidFill>
-                  <a:srgbClr val="2A3442"/>
-                </a:solidFill>
-                <a:latin typeface="Arial"/>
-              </a:defRPr>
-            </a:pPr>
-            <a:r>
-              <a:t>•   Analytics: time-to-clearance, error rates, bottlenecks.</a:t>
+              <a:t>•   AI backend options integrated: local Ollama, Gemini free tier, OpenCode Go, any OpenAI-compatible provider.</a:t>
             </a:r>
           </a:p>
         </p:txBody>
@@ -5985,7 +6287,7 @@
               </a:defRPr>
             </a:pPr>
             <a:r>
-              <a:t>12 / 14</a:t>
+              <a:t>12 / 16</a:t>
             </a:r>
           </a:p>
         </p:txBody>
@@ -6086,7 +6388,7 @@
               </a:defRPr>
             </a:pPr>
             <a:r>
-              <a:t>RISKS &amp; MITIGATIONS</a:t>
+              <a:t>SAFE TO DEMO, READY FOR ENTERPRISE</a:t>
             </a:r>
           </a:p>
         </p:txBody>
@@ -6125,7 +6427,7 @@
               </a:defRPr>
             </a:pPr>
             <a:r>
-              <a:t>Handled deliberately</a:t>
+              <a:t>No real data, no lock-in</a:t>
             </a:r>
           </a:p>
         </p:txBody>
@@ -6184,7 +6486,7 @@
               </a:defRPr>
             </a:pPr>
             <a:r>
-              <a:t>Sensitive data</a:t>
+              <a:t>Fake demo data</a:t>
             </a:r>
           </a:p>
           <a:p>
@@ -6197,7 +6499,7 @@
               </a:defRPr>
             </a:pPr>
             <a:r>
-              <a:t>Local model option; access codes; minimal retention.</a:t>
+              <a:t>A one-click sample document (Republic of Pineapple) — demos never touch real data.</a:t>
             </a:r>
           </a:p>
         </p:txBody>
@@ -6300,7 +6602,7 @@
               </a:defRPr>
             </a:pPr>
             <a:r>
-              <a:t>Model accuracy</a:t>
+              <a:t>Enterprise AI</a:t>
             </a:r>
           </a:p>
           <a:p>
@@ -6313,7 +6615,7 @@
               </a:defRPr>
             </a:pPr>
             <a:r>
-              <a:t>Schema constraints + deterministic parsing + human review.</a:t>
+              <a:t>Ready for the OpenAI API Platform; lock the app to one approved provider.</a:t>
             </a:r>
           </a:p>
         </p:txBody>
@@ -6333,7 +6635,7 @@
             <a:avLst/>
           </a:prstGeom>
           <a:solidFill>
-            <a:srgbClr val="F26522"/>
+            <a:srgbClr val="18418A"/>
           </a:solidFill>
           <a:ln>
             <a:noFill/>
@@ -6416,7 +6718,7 @@
               </a:defRPr>
             </a:pPr>
             <a:r>
-              <a:t>Adoption</a:t>
+              <a:t>Mobile verification</a:t>
             </a:r>
           </a:p>
           <a:p>
@@ -6429,7 +6731,7 @@
               </a:defRPr>
             </a:pPr>
             <a:r>
-              <a:t>Works alongside the existing Excel template; low training.</a:t>
+              <a:t>A verification code confirms the submission (simulated for now).</a:t>
             </a:r>
           </a:p>
         </p:txBody>
@@ -6449,7 +6751,7 @@
             <a:avLst/>
           </a:prstGeom>
           <a:solidFill>
-            <a:srgbClr val="18418A"/>
+            <a:srgbClr val="009E73"/>
           </a:solidFill>
           <a:ln>
             <a:noFill/>
@@ -6532,7 +6834,7 @@
               </a:defRPr>
             </a:pPr>
             <a:r>
-              <a:t>Process variation</a:t>
+              <a:t>Privacy first</a:t>
             </a:r>
           </a:p>
           <a:p>
@@ -6545,7 +6847,7 @@
               </a:defRPr>
             </a:pPr>
             <a:r>
-              <a:t>Routing is configurable per project.</a:t>
+              <a:t>Can run fully local; project details stay confidential from external parties.</a:t>
             </a:r>
           </a:p>
         </p:txBody>
@@ -6565,7 +6867,7 @@
             <a:avLst/>
           </a:prstGeom>
           <a:solidFill>
-            <a:srgbClr val="18418A"/>
+            <a:srgbClr val="009E73"/>
           </a:solidFill>
           <a:ln>
             <a:noFill/>
@@ -6628,7 +6930,7 @@
               </a:defRPr>
             </a:pPr>
             <a:r>
-              <a:t>13 / 14</a:t>
+              <a:t>13 / 16</a:t>
             </a:r>
           </a:p>
         </p:txBody>
@@ -6729,6 +7031,931 @@
               </a:defRPr>
             </a:pPr>
             <a:r>
+              <a:t>ROADMAP</a:t>
+            </a:r>
+          </a:p>
+        </p:txBody>
+      </p:sp>
+      <p:sp>
+        <p:nvSpPr>
+          <p:cNvPr id="4" name="TextBox 3"/>
+          <p:cNvSpPr txBox="1"/>
+          <p:nvPr/>
+        </p:nvSpPr>
+        <p:spPr>
+          <a:xfrm>
+            <a:off x="822960" y="1051560"/>
+            <a:ext cx="10607040" cy="1280160"/>
+          </a:xfrm>
+          <a:prstGeom prst="rect">
+            <a:avLst/>
+          </a:prstGeom>
+          <a:noFill/>
+        </p:spPr>
+        <p:txBody>
+          <a:bodyPr wrap="square" anchor="t">
+            <a:normAutofit/>
+          </a:bodyPr>
+          <a:lstStyle/>
+          <a:p>
+            <a:pPr algn="l">
+              <a:spcAft>
+                <a:spcPts val="0"/>
+              </a:spcAft>
+              <a:defRPr sz="3400" b="1">
+                <a:solidFill>
+                  <a:srgbClr val="18418A"/>
+                </a:solidFill>
+                <a:latin typeface="Arial"/>
+              </a:defRPr>
+            </a:pPr>
+            <a:r>
+              <a:t>From prototype to production</a:t>
+            </a:r>
+          </a:p>
+        </p:txBody>
+      </p:sp>
+      <p:sp>
+        <p:nvSpPr>
+          <p:cNvPr id="5" name="TextBox 4"/>
+          <p:cNvSpPr txBox="1"/>
+          <p:nvPr/>
+        </p:nvSpPr>
+        <p:spPr>
+          <a:xfrm>
+            <a:off x="868680" y="2651760"/>
+            <a:ext cx="10424160" cy="3840480"/>
+          </a:xfrm>
+          <a:prstGeom prst="rect">
+            <a:avLst/>
+          </a:prstGeom>
+          <a:noFill/>
+        </p:spPr>
+        <p:txBody>
+          <a:bodyPr wrap="square" anchor="t">
+            <a:normAutofit/>
+          </a:bodyPr>
+          <a:lstStyle/>
+          <a:p>
+            <a:pPr algn="l">
+              <a:spcAft>
+                <a:spcPts val="1000"/>
+              </a:spcAft>
+              <a:defRPr sz="1800" b="0">
+                <a:solidFill>
+                  <a:srgbClr val="2A3442"/>
+                </a:solidFill>
+                <a:latin typeface="Arial"/>
+              </a:defRPr>
+            </a:pPr>
+            <a:r>
+              <a:t>•   Real email sending (SMTP/API) with delivery receipts.</a:t>
+            </a:r>
+          </a:p>
+          <a:p>
+            <a:pPr algn="l">
+              <a:spcAft>
+                <a:spcPts val="1000"/>
+              </a:spcAft>
+              <a:defRPr sz="1800" b="0">
+                <a:solidFill>
+                  <a:srgbClr val="2A3442"/>
+                </a:solidFill>
+                <a:latin typeface="Arial"/>
+              </a:defRPr>
+            </a:pPr>
+            <a:r>
+              <a:t>•   Live project-register integration and SSO / role-based access.</a:t>
+            </a:r>
+          </a:p>
+          <a:p>
+            <a:pPr algn="l">
+              <a:spcAft>
+                <a:spcPts val="1000"/>
+              </a:spcAft>
+              <a:defRPr sz="1800" b="0">
+                <a:solidFill>
+                  <a:srgbClr val="2A3442"/>
+                </a:solidFill>
+                <a:latin typeface="Arial"/>
+              </a:defRPr>
+            </a:pPr>
+            <a:r>
+              <a:t>•   Audit trail and submission tracking.</a:t>
+            </a:r>
+          </a:p>
+          <a:p>
+            <a:pPr algn="l">
+              <a:spcAft>
+                <a:spcPts val="1000"/>
+              </a:spcAft>
+              <a:defRPr sz="1800" b="0">
+                <a:solidFill>
+                  <a:srgbClr val="2A3442"/>
+                </a:solidFill>
+                <a:latin typeface="Arial"/>
+              </a:defRPr>
+            </a:pPr>
+            <a:r>
+              <a:t>•   Multiple clearance rows per applicant; category-aware routing.</a:t>
+            </a:r>
+          </a:p>
+          <a:p>
+            <a:pPr algn="l">
+              <a:spcAft>
+                <a:spcPts val="1000"/>
+              </a:spcAft>
+              <a:defRPr sz="1800" b="0">
+                <a:solidFill>
+                  <a:srgbClr val="2A3442"/>
+                </a:solidFill>
+                <a:latin typeface="Arial"/>
+              </a:defRPr>
+            </a:pPr>
+            <a:r>
+              <a:t>•   Analytics: time-to-clearance, error rates, bottlenecks.</a:t>
+            </a:r>
+          </a:p>
+        </p:txBody>
+      </p:sp>
+      <p:sp>
+        <p:nvSpPr>
+          <p:cNvPr id="6" name="TextBox 5"/>
+          <p:cNvSpPr txBox="1"/>
+          <p:nvPr/>
+        </p:nvSpPr>
+        <p:spPr>
+          <a:xfrm>
+            <a:off x="10607040" y="6355080"/>
+            <a:ext cx="1188720" cy="365760"/>
+          </a:xfrm>
+          <a:prstGeom prst="rect">
+            <a:avLst/>
+          </a:prstGeom>
+          <a:noFill/>
+        </p:spPr>
+        <p:txBody>
+          <a:bodyPr wrap="square" anchor="t">
+            <a:normAutofit/>
+          </a:bodyPr>
+          <a:lstStyle/>
+          <a:p>
+            <a:pPr algn="r">
+              <a:spcAft>
+                <a:spcPts val="0"/>
+              </a:spcAft>
+              <a:defRPr sz="1000" b="0">
+                <a:solidFill>
+                  <a:srgbClr val="5A6472"/>
+                </a:solidFill>
+                <a:latin typeface="Arial"/>
+              </a:defRPr>
+            </a:pPr>
+            <a:r>
+              <a:t>14 / 16</a:t>
+            </a:r>
+          </a:p>
+        </p:txBody>
+      </p:sp>
+    </p:spTree>
+  </p:cSld>
+  <p:clrMapOvr>
+    <a:masterClrMapping/>
+  </p:clrMapOvr>
+</p:sld>
+</file>
+
+<file path=ppt/slides/slide15.xml><?xml version="1.0" encoding="utf-8"?>
+<p:sld xmlns:a="http://schemas.openxmlformats.org/drawingml/2006/main" xmlns:p="http://schemas.openxmlformats.org/presentationml/2006/main" xmlns:r="http://schemas.openxmlformats.org/officeDocument/2006/relationships">
+  <p:cSld>
+    <p:spTree>
+      <p:nvGrpSpPr>
+        <p:cNvPr id="1" name=""/>
+        <p:cNvGrpSpPr/>
+        <p:nvPr/>
+      </p:nvGrpSpPr>
+      <p:grpSpPr/>
+      <p:sp>
+        <p:nvSpPr>
+          <p:cNvPr id="2" name="Rectangle 1"/>
+          <p:cNvSpPr/>
+          <p:nvPr/>
+        </p:nvSpPr>
+        <p:spPr>
+          <a:xfrm>
+            <a:off x="0" y="0"/>
+            <a:ext cx="164592" cy="6858000"/>
+          </a:xfrm>
+          <a:prstGeom prst="rect">
+            <a:avLst/>
+          </a:prstGeom>
+          <a:solidFill>
+            <a:srgbClr val="18418A"/>
+          </a:solidFill>
+          <a:ln>
+            <a:noFill/>
+          </a:ln>
+          <a:effectLst/>
+        </p:spPr>
+        <p:style>
+          <a:lnRef idx="1">
+            <a:schemeClr val="accent1"/>
+          </a:lnRef>
+          <a:fillRef idx="3">
+            <a:schemeClr val="accent1"/>
+          </a:fillRef>
+          <a:effectRef idx="2">
+            <a:schemeClr val="accent1"/>
+          </a:effectRef>
+          <a:fontRef idx="minor">
+            <a:schemeClr val="lt1"/>
+          </a:fontRef>
+        </p:style>
+        <p:txBody>
+          <a:bodyPr rtlCol="0" anchor="ctr"/>
+          <a:lstStyle/>
+          <a:p>
+            <a:pPr algn="ctr"/>
+          </a:p>
+        </p:txBody>
+      </p:sp>
+      <p:sp>
+        <p:nvSpPr>
+          <p:cNvPr id="3" name="TextBox 2"/>
+          <p:cNvSpPr txBox="1"/>
+          <p:nvPr/>
+        </p:nvSpPr>
+        <p:spPr>
+          <a:xfrm>
+            <a:off x="822960" y="640080"/>
+            <a:ext cx="10515600" cy="457200"/>
+          </a:xfrm>
+          <a:prstGeom prst="rect">
+            <a:avLst/>
+          </a:prstGeom>
+          <a:noFill/>
+        </p:spPr>
+        <p:txBody>
+          <a:bodyPr wrap="square" anchor="t">
+            <a:normAutofit/>
+          </a:bodyPr>
+          <a:lstStyle/>
+          <a:p>
+            <a:pPr algn="l">
+              <a:spcAft>
+                <a:spcPts val="0"/>
+              </a:spcAft>
+              <a:defRPr sz="1400" b="1">
+                <a:solidFill>
+                  <a:srgbClr val="F26522"/>
+                </a:solidFill>
+                <a:latin typeface="Arial"/>
+              </a:defRPr>
+            </a:pPr>
+            <a:r>
+              <a:t>RISKS &amp; MITIGATIONS</a:t>
+            </a:r>
+          </a:p>
+        </p:txBody>
+      </p:sp>
+      <p:sp>
+        <p:nvSpPr>
+          <p:cNvPr id="4" name="TextBox 3"/>
+          <p:cNvSpPr txBox="1"/>
+          <p:nvPr/>
+        </p:nvSpPr>
+        <p:spPr>
+          <a:xfrm>
+            <a:off x="822960" y="1051560"/>
+            <a:ext cx="10607040" cy="1280160"/>
+          </a:xfrm>
+          <a:prstGeom prst="rect">
+            <a:avLst/>
+          </a:prstGeom>
+          <a:noFill/>
+        </p:spPr>
+        <p:txBody>
+          <a:bodyPr wrap="square" anchor="t">
+            <a:normAutofit/>
+          </a:bodyPr>
+          <a:lstStyle/>
+          <a:p>
+            <a:pPr algn="l">
+              <a:spcAft>
+                <a:spcPts val="0"/>
+              </a:spcAft>
+              <a:defRPr sz="3400" b="1">
+                <a:solidFill>
+                  <a:srgbClr val="18418A"/>
+                </a:solidFill>
+                <a:latin typeface="Arial"/>
+              </a:defRPr>
+            </a:pPr>
+            <a:r>
+              <a:t>Handled deliberately</a:t>
+            </a:r>
+          </a:p>
+        </p:txBody>
+      </p:sp>
+      <p:sp>
+        <p:nvSpPr>
+          <p:cNvPr id="5" name="Rounded Rectangle 4"/>
+          <p:cNvSpPr/>
+          <p:nvPr/>
+        </p:nvSpPr>
+        <p:spPr>
+          <a:xfrm>
+            <a:off x="868680" y="2651760"/>
+            <a:ext cx="5029200" cy="1371600"/>
+          </a:xfrm>
+          <a:prstGeom prst="roundRect">
+            <a:avLst>
+              <a:gd name="adj" fmla="val 6000"/>
+            </a:avLst>
+          </a:prstGeom>
+          <a:solidFill>
+            <a:srgbClr val="F4F6F8"/>
+          </a:solidFill>
+          <a:ln>
+            <a:noFill/>
+          </a:ln>
+          <a:effectLst/>
+        </p:spPr>
+        <p:style>
+          <a:lnRef idx="1">
+            <a:schemeClr val="accent1"/>
+          </a:lnRef>
+          <a:fillRef idx="3">
+            <a:schemeClr val="accent1"/>
+          </a:fillRef>
+          <a:effectRef idx="2">
+            <a:schemeClr val="accent1"/>
+          </a:effectRef>
+          <a:fontRef idx="minor">
+            <a:schemeClr val="lt1"/>
+          </a:fontRef>
+        </p:style>
+        <p:txBody>
+          <a:bodyPr rtlCol="0" anchor="ctr" wrap="square" lIns="274320" rIns="182880" tIns="137160"/>
+          <a:lstStyle/>
+          <a:p>
+            <a:pPr algn="ctr">
+              <a:spcAft>
+                <a:spcPts val="300"/>
+              </a:spcAft>
+              <a:defRPr sz="1500" b="1">
+                <a:solidFill>
+                  <a:srgbClr val="18418A"/>
+                </a:solidFill>
+                <a:latin typeface="Arial"/>
+              </a:defRPr>
+            </a:pPr>
+            <a:r>
+              <a:t>Sensitive data</a:t>
+            </a:r>
+          </a:p>
+          <a:p>
+            <a:pPr>
+              <a:defRPr sz="1300">
+                <a:solidFill>
+                  <a:srgbClr val="2A3442"/>
+                </a:solidFill>
+                <a:latin typeface="Arial"/>
+              </a:defRPr>
+            </a:pPr>
+            <a:r>
+              <a:t>Local model option; access codes; minimal retention.</a:t>
+            </a:r>
+          </a:p>
+        </p:txBody>
+      </p:sp>
+      <p:sp>
+        <p:nvSpPr>
+          <p:cNvPr id="6" name="Rectangle 5"/>
+          <p:cNvSpPr/>
+          <p:nvPr/>
+        </p:nvSpPr>
+        <p:spPr>
+          <a:xfrm>
+            <a:off x="868680" y="2724912"/>
+            <a:ext cx="82296" cy="1225296"/>
+          </a:xfrm>
+          <a:prstGeom prst="rect">
+            <a:avLst/>
+          </a:prstGeom>
+          <a:solidFill>
+            <a:srgbClr val="F26522"/>
+          </a:solidFill>
+          <a:ln>
+            <a:noFill/>
+          </a:ln>
+          <a:effectLst/>
+        </p:spPr>
+        <p:style>
+          <a:lnRef idx="1">
+            <a:schemeClr val="accent1"/>
+          </a:lnRef>
+          <a:fillRef idx="3">
+            <a:schemeClr val="accent1"/>
+          </a:fillRef>
+          <a:effectRef idx="2">
+            <a:schemeClr val="accent1"/>
+          </a:effectRef>
+          <a:fontRef idx="minor">
+            <a:schemeClr val="lt1"/>
+          </a:fontRef>
+        </p:style>
+        <p:txBody>
+          <a:bodyPr rtlCol="0" anchor="ctr"/>
+          <a:lstStyle/>
+          <a:p>
+            <a:pPr algn="ctr"/>
+          </a:p>
+        </p:txBody>
+      </p:sp>
+      <p:sp>
+        <p:nvSpPr>
+          <p:cNvPr id="7" name="Rounded Rectangle 6"/>
+          <p:cNvSpPr/>
+          <p:nvPr/>
+        </p:nvSpPr>
+        <p:spPr>
+          <a:xfrm>
+            <a:off x="6355080" y="2651760"/>
+            <a:ext cx="5029200" cy="1371600"/>
+          </a:xfrm>
+          <a:prstGeom prst="roundRect">
+            <a:avLst>
+              <a:gd name="adj" fmla="val 6000"/>
+            </a:avLst>
+          </a:prstGeom>
+          <a:solidFill>
+            <a:srgbClr val="F4F6F8"/>
+          </a:solidFill>
+          <a:ln>
+            <a:noFill/>
+          </a:ln>
+          <a:effectLst/>
+        </p:spPr>
+        <p:style>
+          <a:lnRef idx="1">
+            <a:schemeClr val="accent1"/>
+          </a:lnRef>
+          <a:fillRef idx="3">
+            <a:schemeClr val="accent1"/>
+          </a:fillRef>
+          <a:effectRef idx="2">
+            <a:schemeClr val="accent1"/>
+          </a:effectRef>
+          <a:fontRef idx="minor">
+            <a:schemeClr val="lt1"/>
+          </a:fontRef>
+        </p:style>
+        <p:txBody>
+          <a:bodyPr rtlCol="0" anchor="ctr" wrap="square" lIns="274320" rIns="182880" tIns="137160"/>
+          <a:lstStyle/>
+          <a:p>
+            <a:pPr algn="ctr">
+              <a:spcAft>
+                <a:spcPts val="300"/>
+              </a:spcAft>
+              <a:defRPr sz="1500" b="1">
+                <a:solidFill>
+                  <a:srgbClr val="18418A"/>
+                </a:solidFill>
+                <a:latin typeface="Arial"/>
+              </a:defRPr>
+            </a:pPr>
+            <a:r>
+              <a:t>Model accuracy</a:t>
+            </a:r>
+          </a:p>
+          <a:p>
+            <a:pPr>
+              <a:defRPr sz="1300">
+                <a:solidFill>
+                  <a:srgbClr val="2A3442"/>
+                </a:solidFill>
+                <a:latin typeface="Arial"/>
+              </a:defRPr>
+            </a:pPr>
+            <a:r>
+              <a:t>Schema constraints + deterministic parsing + human review.</a:t>
+            </a:r>
+          </a:p>
+        </p:txBody>
+      </p:sp>
+      <p:sp>
+        <p:nvSpPr>
+          <p:cNvPr id="8" name="Rectangle 7"/>
+          <p:cNvSpPr/>
+          <p:nvPr/>
+        </p:nvSpPr>
+        <p:spPr>
+          <a:xfrm>
+            <a:off x="6355080" y="2724912"/>
+            <a:ext cx="82296" cy="1225296"/>
+          </a:xfrm>
+          <a:prstGeom prst="rect">
+            <a:avLst/>
+          </a:prstGeom>
+          <a:solidFill>
+            <a:srgbClr val="F26522"/>
+          </a:solidFill>
+          <a:ln>
+            <a:noFill/>
+          </a:ln>
+          <a:effectLst/>
+        </p:spPr>
+        <p:style>
+          <a:lnRef idx="1">
+            <a:schemeClr val="accent1"/>
+          </a:lnRef>
+          <a:fillRef idx="3">
+            <a:schemeClr val="accent1"/>
+          </a:fillRef>
+          <a:effectRef idx="2">
+            <a:schemeClr val="accent1"/>
+          </a:effectRef>
+          <a:fontRef idx="minor">
+            <a:schemeClr val="lt1"/>
+          </a:fontRef>
+        </p:style>
+        <p:txBody>
+          <a:bodyPr rtlCol="0" anchor="ctr"/>
+          <a:lstStyle/>
+          <a:p>
+            <a:pPr algn="ctr"/>
+          </a:p>
+        </p:txBody>
+      </p:sp>
+      <p:sp>
+        <p:nvSpPr>
+          <p:cNvPr id="9" name="Rounded Rectangle 8"/>
+          <p:cNvSpPr/>
+          <p:nvPr/>
+        </p:nvSpPr>
+        <p:spPr>
+          <a:xfrm>
+            <a:off x="868680" y="4343400"/>
+            <a:ext cx="5029200" cy="1371600"/>
+          </a:xfrm>
+          <a:prstGeom prst="roundRect">
+            <a:avLst>
+              <a:gd name="adj" fmla="val 6000"/>
+            </a:avLst>
+          </a:prstGeom>
+          <a:solidFill>
+            <a:srgbClr val="F4F6F8"/>
+          </a:solidFill>
+          <a:ln>
+            <a:noFill/>
+          </a:ln>
+          <a:effectLst/>
+        </p:spPr>
+        <p:style>
+          <a:lnRef idx="1">
+            <a:schemeClr val="accent1"/>
+          </a:lnRef>
+          <a:fillRef idx="3">
+            <a:schemeClr val="accent1"/>
+          </a:fillRef>
+          <a:effectRef idx="2">
+            <a:schemeClr val="accent1"/>
+          </a:effectRef>
+          <a:fontRef idx="minor">
+            <a:schemeClr val="lt1"/>
+          </a:fontRef>
+        </p:style>
+        <p:txBody>
+          <a:bodyPr rtlCol="0" anchor="ctr" wrap="square" lIns="274320" rIns="182880" tIns="137160"/>
+          <a:lstStyle/>
+          <a:p>
+            <a:pPr algn="ctr">
+              <a:spcAft>
+                <a:spcPts val="300"/>
+              </a:spcAft>
+              <a:defRPr sz="1500" b="1">
+                <a:solidFill>
+                  <a:srgbClr val="18418A"/>
+                </a:solidFill>
+                <a:latin typeface="Arial"/>
+              </a:defRPr>
+            </a:pPr>
+            <a:r>
+              <a:t>Adoption</a:t>
+            </a:r>
+          </a:p>
+          <a:p>
+            <a:pPr>
+              <a:defRPr sz="1300">
+                <a:solidFill>
+                  <a:srgbClr val="2A3442"/>
+                </a:solidFill>
+                <a:latin typeface="Arial"/>
+              </a:defRPr>
+            </a:pPr>
+            <a:r>
+              <a:t>Works alongside the existing Excel template; low training.</a:t>
+            </a:r>
+          </a:p>
+        </p:txBody>
+      </p:sp>
+      <p:sp>
+        <p:nvSpPr>
+          <p:cNvPr id="10" name="Rectangle 9"/>
+          <p:cNvSpPr/>
+          <p:nvPr/>
+        </p:nvSpPr>
+        <p:spPr>
+          <a:xfrm>
+            <a:off x="868680" y="4416552"/>
+            <a:ext cx="82296" cy="1225296"/>
+          </a:xfrm>
+          <a:prstGeom prst="rect">
+            <a:avLst/>
+          </a:prstGeom>
+          <a:solidFill>
+            <a:srgbClr val="18418A"/>
+          </a:solidFill>
+          <a:ln>
+            <a:noFill/>
+          </a:ln>
+          <a:effectLst/>
+        </p:spPr>
+        <p:style>
+          <a:lnRef idx="1">
+            <a:schemeClr val="accent1"/>
+          </a:lnRef>
+          <a:fillRef idx="3">
+            <a:schemeClr val="accent1"/>
+          </a:fillRef>
+          <a:effectRef idx="2">
+            <a:schemeClr val="accent1"/>
+          </a:effectRef>
+          <a:fontRef idx="minor">
+            <a:schemeClr val="lt1"/>
+          </a:fontRef>
+        </p:style>
+        <p:txBody>
+          <a:bodyPr rtlCol="0" anchor="ctr"/>
+          <a:lstStyle/>
+          <a:p>
+            <a:pPr algn="ctr"/>
+          </a:p>
+        </p:txBody>
+      </p:sp>
+      <p:sp>
+        <p:nvSpPr>
+          <p:cNvPr id="11" name="Rounded Rectangle 10"/>
+          <p:cNvSpPr/>
+          <p:nvPr/>
+        </p:nvSpPr>
+        <p:spPr>
+          <a:xfrm>
+            <a:off x="6355080" y="4343400"/>
+            <a:ext cx="5029200" cy="1371600"/>
+          </a:xfrm>
+          <a:prstGeom prst="roundRect">
+            <a:avLst>
+              <a:gd name="adj" fmla="val 6000"/>
+            </a:avLst>
+          </a:prstGeom>
+          <a:solidFill>
+            <a:srgbClr val="F4F6F8"/>
+          </a:solidFill>
+          <a:ln>
+            <a:noFill/>
+          </a:ln>
+          <a:effectLst/>
+        </p:spPr>
+        <p:style>
+          <a:lnRef idx="1">
+            <a:schemeClr val="accent1"/>
+          </a:lnRef>
+          <a:fillRef idx="3">
+            <a:schemeClr val="accent1"/>
+          </a:fillRef>
+          <a:effectRef idx="2">
+            <a:schemeClr val="accent1"/>
+          </a:effectRef>
+          <a:fontRef idx="minor">
+            <a:schemeClr val="lt1"/>
+          </a:fontRef>
+        </p:style>
+        <p:txBody>
+          <a:bodyPr rtlCol="0" anchor="ctr" wrap="square" lIns="274320" rIns="182880" tIns="137160"/>
+          <a:lstStyle/>
+          <a:p>
+            <a:pPr algn="ctr">
+              <a:spcAft>
+                <a:spcPts val="300"/>
+              </a:spcAft>
+              <a:defRPr sz="1500" b="1">
+                <a:solidFill>
+                  <a:srgbClr val="18418A"/>
+                </a:solidFill>
+                <a:latin typeface="Arial"/>
+              </a:defRPr>
+            </a:pPr>
+            <a:r>
+              <a:t>Process variation</a:t>
+            </a:r>
+          </a:p>
+          <a:p>
+            <a:pPr>
+              <a:defRPr sz="1300">
+                <a:solidFill>
+                  <a:srgbClr val="2A3442"/>
+                </a:solidFill>
+                <a:latin typeface="Arial"/>
+              </a:defRPr>
+            </a:pPr>
+            <a:r>
+              <a:t>Routing is configurable per project.</a:t>
+            </a:r>
+          </a:p>
+        </p:txBody>
+      </p:sp>
+      <p:sp>
+        <p:nvSpPr>
+          <p:cNvPr id="12" name="Rectangle 11"/>
+          <p:cNvSpPr/>
+          <p:nvPr/>
+        </p:nvSpPr>
+        <p:spPr>
+          <a:xfrm>
+            <a:off x="6355080" y="4416552"/>
+            <a:ext cx="82296" cy="1225296"/>
+          </a:xfrm>
+          <a:prstGeom prst="rect">
+            <a:avLst/>
+          </a:prstGeom>
+          <a:solidFill>
+            <a:srgbClr val="18418A"/>
+          </a:solidFill>
+          <a:ln>
+            <a:noFill/>
+          </a:ln>
+          <a:effectLst/>
+        </p:spPr>
+        <p:style>
+          <a:lnRef idx="1">
+            <a:schemeClr val="accent1"/>
+          </a:lnRef>
+          <a:fillRef idx="3">
+            <a:schemeClr val="accent1"/>
+          </a:fillRef>
+          <a:effectRef idx="2">
+            <a:schemeClr val="accent1"/>
+          </a:effectRef>
+          <a:fontRef idx="minor">
+            <a:schemeClr val="lt1"/>
+          </a:fontRef>
+        </p:style>
+        <p:txBody>
+          <a:bodyPr rtlCol="0" anchor="ctr"/>
+          <a:lstStyle/>
+          <a:p>
+            <a:pPr algn="ctr"/>
+          </a:p>
+        </p:txBody>
+      </p:sp>
+      <p:sp>
+        <p:nvSpPr>
+          <p:cNvPr id="13" name="TextBox 12"/>
+          <p:cNvSpPr txBox="1"/>
+          <p:nvPr/>
+        </p:nvSpPr>
+        <p:spPr>
+          <a:xfrm>
+            <a:off x="10607040" y="6355080"/>
+            <a:ext cx="1188720" cy="365760"/>
+          </a:xfrm>
+          <a:prstGeom prst="rect">
+            <a:avLst/>
+          </a:prstGeom>
+          <a:noFill/>
+        </p:spPr>
+        <p:txBody>
+          <a:bodyPr wrap="square" anchor="t">
+            <a:normAutofit/>
+          </a:bodyPr>
+          <a:lstStyle/>
+          <a:p>
+            <a:pPr algn="r">
+              <a:spcAft>
+                <a:spcPts val="0"/>
+              </a:spcAft>
+              <a:defRPr sz="1000" b="0">
+                <a:solidFill>
+                  <a:srgbClr val="5A6472"/>
+                </a:solidFill>
+                <a:latin typeface="Arial"/>
+              </a:defRPr>
+            </a:pPr>
+            <a:r>
+              <a:t>15 / 16</a:t>
+            </a:r>
+          </a:p>
+        </p:txBody>
+      </p:sp>
+    </p:spTree>
+  </p:cSld>
+  <p:clrMapOvr>
+    <a:masterClrMapping/>
+  </p:clrMapOvr>
+</p:sld>
+</file>
+
+<file path=ppt/slides/slide16.xml><?xml version="1.0" encoding="utf-8"?>
+<p:sld xmlns:a="http://schemas.openxmlformats.org/drawingml/2006/main" xmlns:p="http://schemas.openxmlformats.org/presentationml/2006/main" xmlns:r="http://schemas.openxmlformats.org/officeDocument/2006/relationships">
+  <p:cSld>
+    <p:spTree>
+      <p:nvGrpSpPr>
+        <p:cNvPr id="1" name=""/>
+        <p:cNvGrpSpPr/>
+        <p:nvPr/>
+      </p:nvGrpSpPr>
+      <p:grpSpPr/>
+      <p:sp>
+        <p:nvSpPr>
+          <p:cNvPr id="2" name="Rectangle 1"/>
+          <p:cNvSpPr/>
+          <p:nvPr/>
+        </p:nvSpPr>
+        <p:spPr>
+          <a:xfrm>
+            <a:off x="0" y="0"/>
+            <a:ext cx="164592" cy="6858000"/>
+          </a:xfrm>
+          <a:prstGeom prst="rect">
+            <a:avLst/>
+          </a:prstGeom>
+          <a:solidFill>
+            <a:srgbClr val="18418A"/>
+          </a:solidFill>
+          <a:ln>
+            <a:noFill/>
+          </a:ln>
+          <a:effectLst/>
+        </p:spPr>
+        <p:style>
+          <a:lnRef idx="1">
+            <a:schemeClr val="accent1"/>
+          </a:lnRef>
+          <a:fillRef idx="3">
+            <a:schemeClr val="accent1"/>
+          </a:fillRef>
+          <a:effectRef idx="2">
+            <a:schemeClr val="accent1"/>
+          </a:effectRef>
+          <a:fontRef idx="minor">
+            <a:schemeClr val="lt1"/>
+          </a:fontRef>
+        </p:style>
+        <p:txBody>
+          <a:bodyPr rtlCol="0" anchor="ctr"/>
+          <a:lstStyle/>
+          <a:p>
+            <a:pPr algn="ctr"/>
+          </a:p>
+        </p:txBody>
+      </p:sp>
+      <p:sp>
+        <p:nvSpPr>
+          <p:cNvPr id="3" name="TextBox 2"/>
+          <p:cNvSpPr txBox="1"/>
+          <p:nvPr/>
+        </p:nvSpPr>
+        <p:spPr>
+          <a:xfrm>
+            <a:off x="822960" y="640080"/>
+            <a:ext cx="10515600" cy="457200"/>
+          </a:xfrm>
+          <a:prstGeom prst="rect">
+            <a:avLst/>
+          </a:prstGeom>
+          <a:noFill/>
+        </p:spPr>
+        <p:txBody>
+          <a:bodyPr wrap="square" anchor="t">
+            <a:normAutofit/>
+          </a:bodyPr>
+          <a:lstStyle/>
+          <a:p>
+            <a:pPr algn="l">
+              <a:spcAft>
+                <a:spcPts val="0"/>
+              </a:spcAft>
+              <a:defRPr sz="1400" b="1">
+                <a:solidFill>
+                  <a:srgbClr val="F26522"/>
+                </a:solidFill>
+                <a:latin typeface="Arial"/>
+              </a:defRPr>
+            </a:pPr>
+            <a:r>
               <a:t>THE ASK</a:t>
             </a:r>
           </a:p>
@@ -6894,7 +8121,7 @@
               </a:defRPr>
             </a:pPr>
             <a:r>
-              <a:t>14 / 14</a:t>
+              <a:t>16 / 16</a:t>
             </a:r>
           </a:p>
         </p:txBody>
@@ -7192,7 +8419,7 @@
               </a:defRPr>
             </a:pPr>
             <a:r>
-              <a:t>2 / 14</a:t>
+              <a:t>2 / 16</a:t>
             </a:r>
           </a:p>
         </p:txBody>
@@ -7835,7 +9062,7 @@
               </a:defRPr>
             </a:pPr>
             <a:r>
-              <a:t>3 / 14</a:t>
+              <a:t>3 / 16</a:t>
             </a:r>
           </a:p>
         </p:txBody>
@@ -8117,7 +9344,7 @@
               </a:defRPr>
             </a:pPr>
             <a:r>
-              <a:t>4 / 14</a:t>
+              <a:t>4 / 16</a:t>
             </a:r>
           </a:p>
         </p:txBody>
@@ -8992,7 +10219,7 @@
               </a:defRPr>
             </a:pPr>
             <a:r>
-              <a:t>5 / 14</a:t>
+              <a:t>5 / 16</a:t>
             </a:r>
           </a:p>
         </p:txBody>
@@ -9519,7 +10746,7 @@
               </a:defRPr>
             </a:pPr>
             <a:r>
-              <a:t>6 / 14</a:t>
+              <a:t>6 / 16</a:t>
             </a:r>
           </a:p>
         </p:txBody>
@@ -9833,7 +11060,7 @@
               </a:defRPr>
             </a:pPr>
             <a:r>
-              <a:t>7 / 14</a:t>
+              <a:t>7 / 16</a:t>
             </a:r>
           </a:p>
         </p:txBody>
@@ -9934,7 +11161,7 @@
               </a:defRPr>
             </a:pPr>
             <a:r>
-              <a:t>WHY IT'S DIFFERENT</a:t>
+              <a:t>BUILT FOR INTERNAL AND EXTERNAL PARTIES</a:t>
             </a:r>
           </a:p>
         </p:txBody>
@@ -9973,7 +11200,7 @@
               </a:defRPr>
             </a:pPr>
             <a:r>
-              <a:t>It removes the middleman — not just digitises the form</a:t>
+              <a:t>External parties never see the real project details</a:t>
             </a:r>
           </a:p>
         </p:txBody>
@@ -10032,7 +11259,7 @@
               </a:defRPr>
             </a:pPr>
             <a:r>
-              <a:t>Hybrid intelligence</a:t>
+              <a:t>Internal</a:t>
             </a:r>
           </a:p>
           <a:p>
@@ -10045,7 +11272,7 @@
               </a:defRPr>
             </a:pPr>
             <a:r>
-              <a:t>LLM for language; deterministic code for critical values.</a:t>
+              <a:t>Knows the project; selects it and sees all project fields.</a:t>
             </a:r>
           </a:p>
         </p:txBody>
@@ -10148,7 +11375,7 @@
               </a:defRPr>
             </a:pPr>
             <a:r>
-              <a:t>Privacy options</a:t>
+              <a:t>External</a:t>
             </a:r>
           </a:p>
           <a:p>
@@ -10161,7 +11388,7 @@
               </a:defRPr>
             </a:pPr>
             <a:r>
-              <a:t>Can run fully local — clearance data never leaves the machine.</a:t>
+              <a:t>Enters a confidential project code (e.g. ALPHA-7X3K).</a:t>
             </a:r>
           </a:p>
         </p:txBody>
@@ -10175,6 +11402,122 @@
         <p:spPr>
           <a:xfrm>
             <a:off x="6355080" y="2724912"/>
+            <a:ext cx="82296" cy="1225296"/>
+          </a:xfrm>
+          <a:prstGeom prst="rect">
+            <a:avLst/>
+          </a:prstGeom>
+          <a:solidFill>
+            <a:srgbClr val="F26522"/>
+          </a:solidFill>
+          <a:ln>
+            <a:noFill/>
+          </a:ln>
+          <a:effectLst/>
+        </p:spPr>
+        <p:style>
+          <a:lnRef idx="1">
+            <a:schemeClr val="accent1"/>
+          </a:lnRef>
+          <a:fillRef idx="3">
+            <a:schemeClr val="accent1"/>
+          </a:fillRef>
+          <a:effectRef idx="2">
+            <a:schemeClr val="accent1"/>
+          </a:effectRef>
+          <a:fontRef idx="minor">
+            <a:schemeClr val="lt1"/>
+          </a:fontRef>
+        </p:style>
+        <p:txBody>
+          <a:bodyPr rtlCol="0" anchor="ctr"/>
+          <a:lstStyle/>
+          <a:p>
+            <a:pPr algn="ctr"/>
+          </a:p>
+        </p:txBody>
+      </p:sp>
+      <p:sp>
+        <p:nvSpPr>
+          <p:cNvPr id="9" name="Rounded Rectangle 8"/>
+          <p:cNvSpPr/>
+          <p:nvPr/>
+        </p:nvSpPr>
+        <p:spPr>
+          <a:xfrm>
+            <a:off x="868680" y="4343400"/>
+            <a:ext cx="5029200" cy="1371600"/>
+          </a:xfrm>
+          <a:prstGeom prst="roundRect">
+            <a:avLst>
+              <a:gd name="adj" fmla="val 6000"/>
+            </a:avLst>
+          </a:prstGeom>
+          <a:solidFill>
+            <a:srgbClr val="F4F6F8"/>
+          </a:solidFill>
+          <a:ln>
+            <a:noFill/>
+          </a:ln>
+          <a:effectLst/>
+        </p:spPr>
+        <p:style>
+          <a:lnRef idx="1">
+            <a:schemeClr val="accent1"/>
+          </a:lnRef>
+          <a:fillRef idx="3">
+            <a:schemeClr val="accent1"/>
+          </a:fillRef>
+          <a:effectRef idx="2">
+            <a:schemeClr val="accent1"/>
+          </a:effectRef>
+          <a:fontRef idx="minor">
+            <a:schemeClr val="lt1"/>
+          </a:fontRef>
+        </p:style>
+        <p:txBody>
+          <a:bodyPr rtlCol="0" anchor="ctr" wrap="square" lIns="274320" rIns="182880" tIns="137160"/>
+          <a:lstStyle/>
+          <a:p>
+            <a:pPr algn="ctr">
+              <a:spcAft>
+                <a:spcPts val="300"/>
+              </a:spcAft>
+              <a:defRPr sz="1500" b="1">
+                <a:solidFill>
+                  <a:srgbClr val="18418A"/>
+                </a:solidFill>
+                <a:latin typeface="Arial"/>
+              </a:defRPr>
+            </a:pPr>
+            <a:r>
+              <a:t>Auto-resolved</a:t>
+            </a:r>
+          </a:p>
+          <a:p>
+            <a:pPr>
+              <a:defRPr sz="1300">
+                <a:solidFill>
+                  <a:srgbClr val="2A3442"/>
+                </a:solidFill>
+                <a:latin typeface="Arial"/>
+              </a:defRPr>
+            </a:pPr>
+            <a:r>
+              <a:t>The real project details are attached automatically.</a:t>
+            </a:r>
+          </a:p>
+        </p:txBody>
+      </p:sp>
+      <p:sp>
+        <p:nvSpPr>
+          <p:cNvPr id="10" name="Rectangle 9"/>
+          <p:cNvSpPr/>
+          <p:nvPr/>
+        </p:nvSpPr>
+        <p:spPr>
+          <a:xfrm>
+            <a:off x="868680" y="4416552"/>
             <a:ext cx="82296" cy="1225296"/>
           </a:xfrm>
           <a:prstGeom prst="rect">
@@ -10212,13 +11555,13 @@
       </p:sp>
       <p:sp>
         <p:nvSpPr>
-          <p:cNvPr id="9" name="Rounded Rectangle 8"/>
+          <p:cNvPr id="11" name="Rounded Rectangle 10"/>
           <p:cNvSpPr/>
           <p:nvPr/>
         </p:nvSpPr>
         <p:spPr>
           <a:xfrm>
-            <a:off x="868680" y="4343400"/>
+            <a:off x="6355080" y="4343400"/>
             <a:ext cx="5029200" cy="1371600"/>
           </a:xfrm>
           <a:prstGeom prst="roundRect">
@@ -10264,7 +11607,7 @@
               </a:defRPr>
             </a:pPr>
             <a:r>
-              <a:t>Self-serve</a:t>
+              <a:t>Kept confidential</a:t>
             </a:r>
           </a:p>
           <a:p>
@@ -10277,27 +11620,27 @@
               </a:defRPr>
             </a:pPr>
             <a:r>
-              <a:t>Applicants complete it themselves, correctly, first time.</a:t>
-            </a:r>
-          </a:p>
-        </p:txBody>
-      </p:sp>
-      <p:sp>
-        <p:nvSpPr>
-          <p:cNvPr id="10" name="Rectangle 9"/>
+              <a:t>Name, location, ops manager and clearance level stay hidden.</a:t>
+            </a:r>
+          </a:p>
+        </p:txBody>
+      </p:sp>
+      <p:sp>
+        <p:nvSpPr>
+          <p:cNvPr id="12" name="Rectangle 11"/>
           <p:cNvSpPr/>
           <p:nvPr/>
         </p:nvSpPr>
         <p:spPr>
           <a:xfrm>
-            <a:off x="868680" y="4416552"/>
+            <a:off x="6355080" y="4416552"/>
             <a:ext cx="82296" cy="1225296"/>
           </a:xfrm>
           <a:prstGeom prst="rect">
             <a:avLst/>
           </a:prstGeom>
           <a:solidFill>
-            <a:srgbClr val="F26522"/>
+            <a:srgbClr val="009E73"/>
           </a:solidFill>
           <a:ln>
             <a:noFill/>
@@ -10328,122 +11671,6 @@
       </p:sp>
       <p:sp>
         <p:nvSpPr>
-          <p:cNvPr id="11" name="Rounded Rectangle 10"/>
-          <p:cNvSpPr/>
-          <p:nvPr/>
-        </p:nvSpPr>
-        <p:spPr>
-          <a:xfrm>
-            <a:off x="6355080" y="4343400"/>
-            <a:ext cx="5029200" cy="1371600"/>
-          </a:xfrm>
-          <a:prstGeom prst="roundRect">
-            <a:avLst>
-              <a:gd name="adj" fmla="val 6000"/>
-            </a:avLst>
-          </a:prstGeom>
-          <a:solidFill>
-            <a:srgbClr val="F4F6F8"/>
-          </a:solidFill>
-          <a:ln>
-            <a:noFill/>
-          </a:ln>
-          <a:effectLst/>
-        </p:spPr>
-        <p:style>
-          <a:lnRef idx="1">
-            <a:schemeClr val="accent1"/>
-          </a:lnRef>
-          <a:fillRef idx="3">
-            <a:schemeClr val="accent1"/>
-          </a:fillRef>
-          <a:effectRef idx="2">
-            <a:schemeClr val="accent1"/>
-          </a:effectRef>
-          <a:fontRef idx="minor">
-            <a:schemeClr val="lt1"/>
-          </a:fontRef>
-        </p:style>
-        <p:txBody>
-          <a:bodyPr rtlCol="0" anchor="ctr" wrap="square" lIns="274320" rIns="182880" tIns="137160"/>
-          <a:lstStyle/>
-          <a:p>
-            <a:pPr algn="ctr">
-              <a:spcAft>
-                <a:spcPts val="300"/>
-              </a:spcAft>
-              <a:defRPr sz="1500" b="1">
-                <a:solidFill>
-                  <a:srgbClr val="18418A"/>
-                </a:solidFill>
-                <a:latin typeface="Arial"/>
-              </a:defRPr>
-            </a:pPr>
-            <a:r>
-              <a:t>Standardized</a:t>
-            </a:r>
-          </a:p>
-          <a:p>
-            <a:pPr>
-              <a:defRPr sz="1300">
-                <a:solidFill>
-                  <a:srgbClr val="2A3442"/>
-                </a:solidFill>
-                <a:latin typeface="Arial"/>
-              </a:defRPr>
-            </a:pPr>
-            <a:r>
-              <a:t>Same validated ACRES row for every project and person type.</a:t>
-            </a:r>
-          </a:p>
-        </p:txBody>
-      </p:sp>
-      <p:sp>
-        <p:nvSpPr>
-          <p:cNvPr id="12" name="Rectangle 11"/>
-          <p:cNvSpPr/>
-          <p:nvPr/>
-        </p:nvSpPr>
-        <p:spPr>
-          <a:xfrm>
-            <a:off x="6355080" y="4416552"/>
-            <a:ext cx="82296" cy="1225296"/>
-          </a:xfrm>
-          <a:prstGeom prst="rect">
-            <a:avLst/>
-          </a:prstGeom>
-          <a:solidFill>
-            <a:srgbClr val="18418A"/>
-          </a:solidFill>
-          <a:ln>
-            <a:noFill/>
-          </a:ln>
-          <a:effectLst/>
-        </p:spPr>
-        <p:style>
-          <a:lnRef idx="1">
-            <a:schemeClr val="accent1"/>
-          </a:lnRef>
-          <a:fillRef idx="3">
-            <a:schemeClr val="accent1"/>
-          </a:fillRef>
-          <a:effectRef idx="2">
-            <a:schemeClr val="accent1"/>
-          </a:effectRef>
-          <a:fontRef idx="minor">
-            <a:schemeClr val="lt1"/>
-          </a:fontRef>
-        </p:style>
-        <p:txBody>
-          <a:bodyPr rtlCol="0" anchor="ctr"/>
-          <a:lstStyle/>
-          <a:p>
-            <a:pPr algn="ctr"/>
-          </a:p>
-        </p:txBody>
-      </p:sp>
-      <p:sp>
-        <p:nvSpPr>
           <p:cNvPr id="13" name="TextBox 12"/>
           <p:cNvSpPr txBox="1"/>
           <p:nvPr/>
@@ -10476,7 +11703,7 @@
               </a:defRPr>
             </a:pPr>
             <a:r>
-              <a:t>8 / 14</a:t>
+              <a:t>8 / 16</a:t>
             </a:r>
           </a:p>
         </p:txBody>
@@ -10577,7 +11804,7 @@
               </a:defRPr>
             </a:pPr>
             <a:r>
-              <a:t>WHO IT'S FOR</a:t>
+              <a:t>WHY IT'S DIFFERENT</a:t>
             </a:r>
           </a:p>
         </p:txBody>
@@ -10616,7 +11843,7 @@
               </a:defRPr>
             </a:pPr>
             <a:r>
-              <a:t>Built for everyone in the clearance chain</a:t>
+              <a:t>It removes the middleman — not just digitises the form</a:t>
             </a:r>
           </a:p>
         </p:txBody>
@@ -10629,19 +11856,19 @@
         </p:nvSpPr>
         <p:spPr>
           <a:xfrm>
-            <a:off x="868680" y="2834640"/>
-            <a:ext cx="3474720" cy="502920"/>
+            <a:off x="868680" y="2651760"/>
+            <a:ext cx="5029200" cy="1371600"/>
           </a:xfrm>
           <a:prstGeom prst="roundRect">
-            <a:avLst/>
+            <a:avLst>
+              <a:gd name="adj" fmla="val 6000"/>
+            </a:avLst>
           </a:prstGeom>
           <a:solidFill>
             <a:srgbClr val="F4F6F8"/>
           </a:solidFill>
           <a:ln>
-            <a:solidFill>
-              <a:srgbClr val="DDE3EA"/>
-            </a:solidFill>
+            <a:noFill/>
           </a:ln>
           <a:effectLst/>
         </p:spPr>
@@ -10660,11 +11887,14 @@
           </a:fontRef>
         </p:style>
         <p:txBody>
-          <a:bodyPr rtlCol="0" anchor="ctr" wrap="none"/>
+          <a:bodyPr rtlCol="0" anchor="ctr" wrap="square" lIns="274320" rIns="182880" tIns="137160"/>
           <a:lstStyle/>
           <a:p>
             <a:pPr algn="ctr">
-              <a:defRPr sz="1400" b="1">
+              <a:spcAft>
+                <a:spcPts val="300"/>
+              </a:spcAft>
+              <a:defRPr sz="1500" b="1">
                 <a:solidFill>
                   <a:srgbClr val="18418A"/>
                 </a:solidFill>
@@ -10672,32 +11902,43 @@
               </a:defRPr>
             </a:pPr>
             <a:r>
-              <a:t>Applicants</a:t>
-            </a:r>
-          </a:p>
-        </p:txBody>
-      </p:sp>
-      <p:sp>
-        <p:nvSpPr>
-          <p:cNvPr id="6" name="Rounded Rectangle 5"/>
+              <a:t>Hybrid intelligence</a:t>
+            </a:r>
+          </a:p>
+          <a:p>
+            <a:pPr>
+              <a:defRPr sz="1300">
+                <a:solidFill>
+                  <a:srgbClr val="2A3442"/>
+                </a:solidFill>
+                <a:latin typeface="Arial"/>
+              </a:defRPr>
+            </a:pPr>
+            <a:r>
+              <a:t>LLM for language; deterministic code for critical values.</a:t>
+            </a:r>
+          </a:p>
+        </p:txBody>
+      </p:sp>
+      <p:sp>
+        <p:nvSpPr>
+          <p:cNvPr id="6" name="Rectangle 5"/>
           <p:cNvSpPr/>
           <p:nvPr/>
         </p:nvSpPr>
         <p:spPr>
           <a:xfrm>
-            <a:off x="4617720" y="2834640"/>
-            <a:ext cx="5815583" cy="502920"/>
-          </a:xfrm>
-          <a:prstGeom prst="roundRect">
+            <a:off x="868680" y="2724912"/>
+            <a:ext cx="82296" cy="1225296"/>
+          </a:xfrm>
+          <a:prstGeom prst="rect">
             <a:avLst/>
           </a:prstGeom>
           <a:solidFill>
-            <a:srgbClr val="F4F6F8"/>
+            <a:srgbClr val="18418A"/>
           </a:solidFill>
           <a:ln>
-            <a:solidFill>
-              <a:srgbClr val="DDE3EA"/>
-            </a:solidFill>
+            <a:noFill/>
           </a:ln>
           <a:effectLst/>
         </p:spPr>
@@ -10716,20 +11957,10 @@
           </a:fontRef>
         </p:style>
         <p:txBody>
-          <a:bodyPr rtlCol="0" anchor="ctr" wrap="none"/>
-          <a:lstStyle/>
-          <a:p>
-            <a:pPr algn="ctr">
-              <a:defRPr sz="1400" b="1">
-                <a:solidFill>
-                  <a:srgbClr val="18418A"/>
-                </a:solidFill>
-                <a:latin typeface="Arial"/>
-              </a:defRPr>
-            </a:pPr>
-            <a:r>
-              <a:t>Project executives</a:t>
-            </a:r>
+          <a:bodyPr rtlCol="0" anchor="ctr"/>
+          <a:lstStyle/>
+          <a:p>
+            <a:pPr algn="ctr"/>
           </a:p>
         </p:txBody>
       </p:sp>
@@ -10741,19 +11972,19 @@
         </p:nvSpPr>
         <p:spPr>
           <a:xfrm>
-            <a:off x="10707623" y="2834640"/>
-            <a:ext cx="4059935" cy="502920"/>
+            <a:off x="6355080" y="2651760"/>
+            <a:ext cx="5029200" cy="1371600"/>
           </a:xfrm>
           <a:prstGeom prst="roundRect">
-            <a:avLst/>
+            <a:avLst>
+              <a:gd name="adj" fmla="val 6000"/>
+            </a:avLst>
           </a:prstGeom>
           <a:solidFill>
             <a:srgbClr val="F4F6F8"/>
           </a:solidFill>
           <a:ln>
-            <a:solidFill>
-              <a:srgbClr val="DDE3EA"/>
-            </a:solidFill>
+            <a:noFill/>
           </a:ln>
           <a:effectLst/>
         </p:spPr>
@@ -10772,11 +12003,14 @@
           </a:fontRef>
         </p:style>
         <p:txBody>
-          <a:bodyPr rtlCol="0" anchor="ctr" wrap="none"/>
+          <a:bodyPr rtlCol="0" anchor="ctr" wrap="square" lIns="274320" rIns="182880" tIns="137160"/>
           <a:lstStyle/>
           <a:p>
             <a:pPr algn="ctr">
-              <a:defRPr sz="1400" b="1">
+              <a:spcAft>
+                <a:spcPts val="300"/>
+              </a:spcAft>
+              <a:defRPr sz="1500" b="1">
                 <a:solidFill>
                   <a:srgbClr val="18418A"/>
                 </a:solidFill>
@@ -10784,32 +12018,43 @@
               </a:defRPr>
             </a:pPr>
             <a:r>
-              <a:t>Ops managers</a:t>
-            </a:r>
-          </a:p>
-        </p:txBody>
-      </p:sp>
-      <p:sp>
-        <p:nvSpPr>
-          <p:cNvPr id="8" name="Rounded Rectangle 7"/>
+              <a:t>Privacy options</a:t>
+            </a:r>
+          </a:p>
+          <a:p>
+            <a:pPr>
+              <a:defRPr sz="1300">
+                <a:solidFill>
+                  <a:srgbClr val="2A3442"/>
+                </a:solidFill>
+                <a:latin typeface="Arial"/>
+              </a:defRPr>
+            </a:pPr>
+            <a:r>
+              <a:t>Can run fully local — clearance data never leaves the machine.</a:t>
+            </a:r>
+          </a:p>
+        </p:txBody>
+      </p:sp>
+      <p:sp>
+        <p:nvSpPr>
+          <p:cNvPr id="8" name="Rectangle 7"/>
           <p:cNvSpPr/>
           <p:nvPr/>
         </p:nvSpPr>
         <p:spPr>
           <a:xfrm>
-            <a:off x="15041878" y="2834640"/>
-            <a:ext cx="7571231" cy="502920"/>
-          </a:xfrm>
-          <a:prstGeom prst="roundRect">
+            <a:off x="6355080" y="2724912"/>
+            <a:ext cx="82296" cy="1225296"/>
+          </a:xfrm>
+          <a:prstGeom prst="rect">
             <a:avLst/>
           </a:prstGeom>
           <a:solidFill>
-            <a:srgbClr val="F4F6F8"/>
+            <a:srgbClr val="009E73"/>
           </a:solidFill>
           <a:ln>
-            <a:solidFill>
-              <a:srgbClr val="DDE3EA"/>
-            </a:solidFill>
+            <a:noFill/>
           </a:ln>
           <a:effectLst/>
         </p:spPr>
@@ -10828,11 +12073,60 @@
           </a:fontRef>
         </p:style>
         <p:txBody>
-          <a:bodyPr rtlCol="0" anchor="ctr" wrap="none"/>
+          <a:bodyPr rtlCol="0" anchor="ctr"/>
+          <a:lstStyle/>
+          <a:p>
+            <a:pPr algn="ctr"/>
+          </a:p>
+        </p:txBody>
+      </p:sp>
+      <p:sp>
+        <p:nvSpPr>
+          <p:cNvPr id="9" name="Rounded Rectangle 8"/>
+          <p:cNvSpPr/>
+          <p:nvPr/>
+        </p:nvSpPr>
+        <p:spPr>
+          <a:xfrm>
+            <a:off x="868680" y="4343400"/>
+            <a:ext cx="5029200" cy="1371600"/>
+          </a:xfrm>
+          <a:prstGeom prst="roundRect">
+            <a:avLst>
+              <a:gd name="adj" fmla="val 6000"/>
+            </a:avLst>
+          </a:prstGeom>
+          <a:solidFill>
+            <a:srgbClr val="F4F6F8"/>
+          </a:solidFill>
+          <a:ln>
+            <a:noFill/>
+          </a:ln>
+          <a:effectLst/>
+        </p:spPr>
+        <p:style>
+          <a:lnRef idx="1">
+            <a:schemeClr val="accent1"/>
+          </a:lnRef>
+          <a:fillRef idx="3">
+            <a:schemeClr val="accent1"/>
+          </a:fillRef>
+          <a:effectRef idx="2">
+            <a:schemeClr val="accent1"/>
+          </a:effectRef>
+          <a:fontRef idx="minor">
+            <a:schemeClr val="lt1"/>
+          </a:fontRef>
+        </p:style>
+        <p:txBody>
+          <a:bodyPr rtlCol="0" anchor="ctr" wrap="square" lIns="274320" rIns="182880" tIns="137160"/>
           <a:lstStyle/>
           <a:p>
             <a:pPr algn="ctr">
-              <a:defRPr sz="1400" b="1">
+              <a:spcAft>
+                <a:spcPts val="300"/>
+              </a:spcAft>
+              <a:defRPr sz="1500" b="1">
                 <a:solidFill>
                   <a:srgbClr val="18418A"/>
                 </a:solidFill>
@@ -10840,38 +12134,128 @@
               </a:defRPr>
             </a:pPr>
             <a:r>
-              <a:t>Project / security admin</a:t>
-            </a:r>
-          </a:p>
-        </p:txBody>
-      </p:sp>
-      <p:sp>
-        <p:nvSpPr>
-          <p:cNvPr id="9" name="TextBox 8"/>
-          <p:cNvSpPr txBox="1"/>
-          <p:nvPr/>
-        </p:nvSpPr>
-        <p:spPr>
-          <a:xfrm>
-            <a:off x="868680" y="3931920"/>
-            <a:ext cx="10424160" cy="1280160"/>
+              <a:t>Self-serve</a:t>
+            </a:r>
+          </a:p>
+          <a:p>
+            <a:pPr>
+              <a:defRPr sz="1300">
+                <a:solidFill>
+                  <a:srgbClr val="2A3442"/>
+                </a:solidFill>
+                <a:latin typeface="Arial"/>
+              </a:defRPr>
+            </a:pPr>
+            <a:r>
+              <a:t>Applicants complete it themselves, correctly, first time.</a:t>
+            </a:r>
+          </a:p>
+        </p:txBody>
+      </p:sp>
+      <p:sp>
+        <p:nvSpPr>
+          <p:cNvPr id="10" name="Rectangle 9"/>
+          <p:cNvSpPr/>
+          <p:nvPr/>
+        </p:nvSpPr>
+        <p:spPr>
+          <a:xfrm>
+            <a:off x="868680" y="4416552"/>
+            <a:ext cx="82296" cy="1225296"/>
           </a:xfrm>
           <a:prstGeom prst="rect">
             <a:avLst/>
           </a:prstGeom>
-          <a:noFill/>
-        </p:spPr>
-        <p:txBody>
-          <a:bodyPr wrap="square" anchor="t">
-            <a:normAutofit/>
-          </a:bodyPr>
-          <a:lstStyle/>
-          <a:p>
-            <a:pPr algn="l">
+          <a:solidFill>
+            <a:srgbClr val="F26522"/>
+          </a:solidFill>
+          <a:ln>
+            <a:noFill/>
+          </a:ln>
+          <a:effectLst/>
+        </p:spPr>
+        <p:style>
+          <a:lnRef idx="1">
+            <a:schemeClr val="accent1"/>
+          </a:lnRef>
+          <a:fillRef idx="3">
+            <a:schemeClr val="accent1"/>
+          </a:fillRef>
+          <a:effectRef idx="2">
+            <a:schemeClr val="accent1"/>
+          </a:effectRef>
+          <a:fontRef idx="minor">
+            <a:schemeClr val="lt1"/>
+          </a:fontRef>
+        </p:style>
+        <p:txBody>
+          <a:bodyPr rtlCol="0" anchor="ctr"/>
+          <a:lstStyle/>
+          <a:p>
+            <a:pPr algn="ctr"/>
+          </a:p>
+        </p:txBody>
+      </p:sp>
+      <p:sp>
+        <p:nvSpPr>
+          <p:cNvPr id="11" name="Rounded Rectangle 10"/>
+          <p:cNvSpPr/>
+          <p:nvPr/>
+        </p:nvSpPr>
+        <p:spPr>
+          <a:xfrm>
+            <a:off x="6355080" y="4343400"/>
+            <a:ext cx="5029200" cy="1371600"/>
+          </a:xfrm>
+          <a:prstGeom prst="roundRect">
+            <a:avLst>
+              <a:gd name="adj" fmla="val 6000"/>
+            </a:avLst>
+          </a:prstGeom>
+          <a:solidFill>
+            <a:srgbClr val="F4F6F8"/>
+          </a:solidFill>
+          <a:ln>
+            <a:noFill/>
+          </a:ln>
+          <a:effectLst/>
+        </p:spPr>
+        <p:style>
+          <a:lnRef idx="1">
+            <a:schemeClr val="accent1"/>
+          </a:lnRef>
+          <a:fillRef idx="3">
+            <a:schemeClr val="accent1"/>
+          </a:fillRef>
+          <a:effectRef idx="2">
+            <a:schemeClr val="accent1"/>
+          </a:effectRef>
+          <a:fontRef idx="minor">
+            <a:schemeClr val="lt1"/>
+          </a:fontRef>
+        </p:style>
+        <p:txBody>
+          <a:bodyPr rtlCol="0" anchor="ctr" wrap="square" lIns="274320" rIns="182880" tIns="137160"/>
+          <a:lstStyle/>
+          <a:p>
+            <a:pPr algn="ctr">
               <a:spcAft>
-                <a:spcPts val="0"/>
+                <a:spcPts val="300"/>
               </a:spcAft>
-              <a:defRPr sz="1600" b="0">
+              <a:defRPr sz="1500" b="1">
+                <a:solidFill>
+                  <a:srgbClr val="18418A"/>
+                </a:solidFill>
+                <a:latin typeface="Arial"/>
+              </a:defRPr>
+            </a:pPr>
+            <a:r>
+              <a:t>Standardized</a:t>
+            </a:r>
+          </a:p>
+          <a:p>
+            <a:pPr>
+              <a:defRPr sz="1300">
                 <a:solidFill>
                   <a:srgbClr val="2A3442"/>
                 </a:solidFill>
@@ -10879,14 +12263,58 @@
               </a:defRPr>
             </a:pPr>
             <a:r>
-              <a:t>Applicants complete the form; executives receive a ready package; ops managers endorse; admin teams get consistency and an audit trail.</a:t>
-            </a:r>
-          </a:p>
-        </p:txBody>
-      </p:sp>
-      <p:sp>
-        <p:nvSpPr>
-          <p:cNvPr id="10" name="TextBox 9"/>
+              <a:t>Same validated ACRES row for every project and person type.</a:t>
+            </a:r>
+          </a:p>
+        </p:txBody>
+      </p:sp>
+      <p:sp>
+        <p:nvSpPr>
+          <p:cNvPr id="12" name="Rectangle 11"/>
+          <p:cNvSpPr/>
+          <p:nvPr/>
+        </p:nvSpPr>
+        <p:spPr>
+          <a:xfrm>
+            <a:off x="6355080" y="4416552"/>
+            <a:ext cx="82296" cy="1225296"/>
+          </a:xfrm>
+          <a:prstGeom prst="rect">
+            <a:avLst/>
+          </a:prstGeom>
+          <a:solidFill>
+            <a:srgbClr val="18418A"/>
+          </a:solidFill>
+          <a:ln>
+            <a:noFill/>
+          </a:ln>
+          <a:effectLst/>
+        </p:spPr>
+        <p:style>
+          <a:lnRef idx="1">
+            <a:schemeClr val="accent1"/>
+          </a:lnRef>
+          <a:fillRef idx="3">
+            <a:schemeClr val="accent1"/>
+          </a:fillRef>
+          <a:effectRef idx="2">
+            <a:schemeClr val="accent1"/>
+          </a:effectRef>
+          <a:fontRef idx="minor">
+            <a:schemeClr val="lt1"/>
+          </a:fontRef>
+        </p:style>
+        <p:txBody>
+          <a:bodyPr rtlCol="0" anchor="ctr"/>
+          <a:lstStyle/>
+          <a:p>
+            <a:pPr algn="ctr"/>
+          </a:p>
+        </p:txBody>
+      </p:sp>
+      <p:sp>
+        <p:nvSpPr>
+          <p:cNvPr id="13" name="TextBox 12"/>
           <p:cNvSpPr txBox="1"/>
           <p:nvPr/>
         </p:nvSpPr>
@@ -10918,7 +12346,7 @@
               </a:defRPr>
             </a:pPr>
             <a:r>
-              <a:t>9 / 14</a:t>
+              <a:t>9 / 16</a:t>
             </a:r>
           </a:p>
         </p:txBody>

</xml_diff>

<commit_message>
Demo: generate sample person into AI assistant; MSD upload scoped to MSD-only; robust labelled+multi-pass extraction; deck rebrand to ACRESelerate with ChatGPT Enterprise, prototype notice and Singpass roadmap
</commit_message>
<xml_diff>
--- a/pitch/acres_pitch_deck.pptx
+++ b/pitch/acres_pitch_deck.pptx
@@ -21,6 +21,8 @@
     <p:sldId id="269" r:id="rId20"/>
     <p:sldId id="270" r:id="rId21"/>
     <p:sldId id="271" r:id="rId22"/>
+    <p:sldId id="272" r:id="rId23"/>
+    <p:sldId id="273" r:id="rId24"/>
   </p:sldIdLst>
   <p:sldSz cx="12191695" cy="6858000" type="screen4x3"/>
   <p:notesSz cx="6858000" cy="9144000"/>
@@ -517,7 +519,7 @@
           <a:lstStyle/>
           <a:p>
             <a:r>
-              <a:t>Today, getting ACRES clearance is a manual, multi-step chase. We built a tool that collapses it into one self-serve flow.</a:t>
+              <a:t>Today, getting ACRES clearance is a manual, multi-step chase. ACRESelerate collapses it into one self-serve flow. Note: this is a prototype and security is not addressed yet.</a:t>
             </a:r>
           </a:p>
         </p:txBody>
@@ -797,7 +799,7 @@
           <a:lstStyle/>
           <a:p>
             <a:r>
-              <a:t>Demos use obviously fake data, the AI is ready for the enterprise provider, and a mobile code confirms the submission.</a:t>
+              <a:t>Demos use a fake person, the AI is ready for the enterprise provider, and a mobile code confirms the submission.</a:t>
             </a:r>
           </a:p>
         </p:txBody>
@@ -867,7 +869,7 @@
           <a:lstStyle/>
           <a:p>
             <a:r>
-              <a:t>Next: real email sending, live register + SSO, audit trail and analytics.</a:t>
+              <a:t>ChatGPT Enterprise (via the org's OpenAI API Platform) does the document understanding, structured field extraction and drafting — locked to the approved provider, with no training on our data.</a:t>
             </a:r>
           </a:p>
         </p:txBody>
@@ -937,7 +939,7 @@
           <a:lstStyle/>
           <a:p>
             <a:r>
-              <a:t>Sensitive data and model accuracy are handled with local AI and deterministic parsing.</a:t>
+              <a:t>To be explicit: this is a prototype. Security, data handling and compliance are not addressed yet, and only fake data should be used.</a:t>
             </a:r>
           </a:p>
         </p:txBody>
@@ -963,6 +965,146 @@
 </file>
 
 <file path=ppt/notesSlides/notesSlide16.xml><?xml version="1.0" encoding="utf-8"?>
+<p:notes xmlns:a="http://schemas.openxmlformats.org/drawingml/2006/main" xmlns:p="http://schemas.openxmlformats.org/presentationml/2006/main" xmlns:r="http://schemas.openxmlformats.org/officeDocument/2006/relationships">
+  <p:cSld>
+    <p:spTree>
+      <p:nvGrpSpPr>
+        <p:cNvPr id="1" name=""/>
+        <p:cNvGrpSpPr/>
+        <p:nvPr/>
+      </p:nvGrpSpPr>
+      <p:grpSpPr>
+        <a:xfrm>
+          <a:off x="0" y="0"/>
+          <a:ext cx="0" cy="0"/>
+          <a:chOff x="0" y="0"/>
+          <a:chExt cx="0" cy="0"/>
+        </a:xfrm>
+      </p:grpSpPr>
+      <p:sp>
+        <p:nvSpPr>
+          <p:cNvPr id="2" name="Slide Image Placeholder 1"/>
+          <p:cNvSpPr>
+            <a:spLocks noGrp="1"/>
+          </p:cNvSpPr>
+          <p:nvPr>
+            <p:ph type="sldImg" idx="2"/>
+          </p:nvPr>
+        </p:nvSpPr>
+        <p:spPr/>
+      </p:sp>
+      <p:sp>
+        <p:nvSpPr>
+          <p:cNvPr id="3" name="Notes Placeholder 2"/>
+          <p:cNvSpPr>
+            <a:spLocks noGrp="1"/>
+          </p:cNvSpPr>
+          <p:nvPr>
+            <p:ph type="body" idx="3" sz="quarter"/>
+          </p:nvPr>
+        </p:nvSpPr>
+        <p:spPr/>
+        <p:txBody>
+          <a:bodyPr/>
+          <a:lstStyle/>
+          <a:p>
+            <a:r>
+              <a:t>Next: Singpass login to verify identity and auto-fill personal details, then email sending, register integration and a security review.</a:t>
+            </a:r>
+          </a:p>
+        </p:txBody>
+      </p:sp>
+      <p:sp>
+        <p:nvSpPr>
+          <p:cNvPr id="4" name="Slide Number Placeholder 3"/>
+          <p:cNvSpPr>
+            <a:spLocks noGrp="1"/>
+          </p:cNvSpPr>
+          <p:nvPr>
+            <p:ph type="sldNum" idx="5" sz="quarter"/>
+          </p:nvPr>
+        </p:nvSpPr>
+        <p:spPr/>
+      </p:sp>
+    </p:spTree>
+  </p:cSld>
+  <p:clrMapOvr>
+    <a:masterClrMapping/>
+  </p:clrMapOvr>
+</p:notes>
+</file>
+
+<file path=ppt/notesSlides/notesSlide17.xml><?xml version="1.0" encoding="utf-8"?>
+<p:notes xmlns:a="http://schemas.openxmlformats.org/drawingml/2006/main" xmlns:p="http://schemas.openxmlformats.org/presentationml/2006/main" xmlns:r="http://schemas.openxmlformats.org/officeDocument/2006/relationships">
+  <p:cSld>
+    <p:spTree>
+      <p:nvGrpSpPr>
+        <p:cNvPr id="1" name=""/>
+        <p:cNvGrpSpPr/>
+        <p:nvPr/>
+      </p:nvGrpSpPr>
+      <p:grpSpPr>
+        <a:xfrm>
+          <a:off x="0" y="0"/>
+          <a:ext cx="0" cy="0"/>
+          <a:chOff x="0" y="0"/>
+          <a:chExt cx="0" cy="0"/>
+        </a:xfrm>
+      </p:grpSpPr>
+      <p:sp>
+        <p:nvSpPr>
+          <p:cNvPr id="2" name="Slide Image Placeholder 1"/>
+          <p:cNvSpPr>
+            <a:spLocks noGrp="1"/>
+          </p:cNvSpPr>
+          <p:nvPr>
+            <p:ph type="sldImg" idx="2"/>
+          </p:nvPr>
+        </p:nvSpPr>
+        <p:spPr/>
+      </p:sp>
+      <p:sp>
+        <p:nvSpPr>
+          <p:cNvPr id="3" name="Notes Placeholder 2"/>
+          <p:cNvSpPr>
+            <a:spLocks noGrp="1"/>
+          </p:cNvSpPr>
+          <p:nvPr>
+            <p:ph type="body" idx="3" sz="quarter"/>
+          </p:nvPr>
+        </p:nvSpPr>
+        <p:spPr/>
+        <p:txBody>
+          <a:bodyPr/>
+          <a:lstStyle/>
+          <a:p>
+            <a:r>
+              <a:t>Sensitive data and model accuracy are handled with local AI and deterministic parsing.</a:t>
+            </a:r>
+          </a:p>
+        </p:txBody>
+      </p:sp>
+      <p:sp>
+        <p:nvSpPr>
+          <p:cNvPr id="4" name="Slide Number Placeholder 3"/>
+          <p:cNvSpPr>
+            <a:spLocks noGrp="1"/>
+          </p:cNvSpPr>
+          <p:nvPr>
+            <p:ph type="sldNum" idx="5" sz="quarter"/>
+          </p:nvPr>
+        </p:nvSpPr>
+        <p:spPr/>
+      </p:sp>
+    </p:spTree>
+  </p:cSld>
+  <p:clrMapOvr>
+    <a:masterClrMapping/>
+  </p:clrMapOvr>
+</p:notes>
+</file>
+
+<file path=ppt/notesSlides/notesSlide18.xml><?xml version="1.0" encoding="utf-8"?>
 <p:notes xmlns:a="http://schemas.openxmlformats.org/drawingml/2006/main" xmlns:p="http://schemas.openxmlformats.org/presentationml/2006/main" xmlns:r="http://schemas.openxmlformats.org/officeDocument/2006/relationships">
   <p:cSld>
     <p:spTree>
@@ -4664,7 +4806,7 @@
         </p:nvSpPr>
         <p:spPr>
           <a:xfrm>
-            <a:off x="822960" y="1737360"/>
+            <a:off x="822960" y="1645920"/>
             <a:ext cx="10515600" cy="2011680"/>
           </a:xfrm>
           <a:prstGeom prst="rect">
@@ -4682,7 +4824,7 @@
               <a:spcAft>
                 <a:spcPts val="0"/>
               </a:spcAft>
-              <a:defRPr sz="4600" b="1">
+              <a:defRPr sz="5400" b="1">
                 <a:solidFill>
                   <a:srgbClr val="18418A"/>
                 </a:solidFill>
@@ -4690,7 +4832,7 @@
               </a:defRPr>
             </a:pPr>
             <a:r>
-              <a:t>ACRES Clearance Automated Intake</a:t>
+              <a:t>ACRESelerate</a:t>
             </a:r>
           </a:p>
         </p:txBody>
@@ -4703,7 +4845,7 @@
         </p:nvSpPr>
         <p:spPr>
           <a:xfrm>
-            <a:off x="822960" y="3566160"/>
+            <a:off x="822960" y="3200400"/>
             <a:ext cx="9875520" cy="1463040"/>
           </a:xfrm>
           <a:prstGeom prst="rect">
@@ -4742,7 +4884,7 @@
         </p:nvSpPr>
         <p:spPr>
           <a:xfrm>
-            <a:off x="868680" y="5120640"/>
+            <a:off x="868680" y="4663440"/>
             <a:ext cx="3474720" cy="502920"/>
           </a:xfrm>
           <a:prstGeom prst="roundRect">
@@ -4798,7 +4940,7 @@
         </p:nvSpPr>
         <p:spPr>
           <a:xfrm>
-            <a:off x="4617720" y="5120640"/>
+            <a:off x="4617720" y="4663440"/>
             <a:ext cx="3767328" cy="502920"/>
           </a:xfrm>
           <a:prstGeom prst="roundRect">
@@ -4854,8 +4996,8 @@
         </p:nvSpPr>
         <p:spPr>
           <a:xfrm>
-            <a:off x="8659368" y="5120640"/>
-            <a:ext cx="5522976" cy="502920"/>
+            <a:off x="8659368" y="4663440"/>
+            <a:ext cx="3182112" cy="502920"/>
           </a:xfrm>
           <a:prstGeom prst="roundRect">
             <a:avLst/>
@@ -4897,7 +5039,7 @@
               </a:defRPr>
             </a:pPr>
             <a:r>
-              <a:t>Working prototype</a:t>
+              <a:t>Prototype</a:t>
             </a:r>
           </a:p>
         </p:txBody>
@@ -4905,6 +5047,45 @@
       <p:sp>
         <p:nvSpPr>
           <p:cNvPr id="9" name="TextBox 8"/>
+          <p:cNvSpPr txBox="1"/>
+          <p:nvPr/>
+        </p:nvSpPr>
+        <p:spPr>
+          <a:xfrm>
+            <a:off x="822960" y="5394960"/>
+            <a:ext cx="10515600" cy="548640"/>
+          </a:xfrm>
+          <a:prstGeom prst="rect">
+            <a:avLst/>
+          </a:prstGeom>
+          <a:noFill/>
+        </p:spPr>
+        <p:txBody>
+          <a:bodyPr wrap="square" anchor="t">
+            <a:normAutofit/>
+          </a:bodyPr>
+          <a:lstStyle/>
+          <a:p>
+            <a:pPr algn="l">
+              <a:spcAft>
+                <a:spcPts val="0"/>
+              </a:spcAft>
+              <a:defRPr sz="1400" b="1">
+                <a:solidFill>
+                  <a:srgbClr val="F26522"/>
+                </a:solidFill>
+                <a:latin typeface="Arial"/>
+              </a:defRPr>
+            </a:pPr>
+            <a:r>
+              <a:t>Prototype only — security and data-handling are not addressed at this stage.</a:t>
+            </a:r>
+          </a:p>
+        </p:txBody>
+      </p:sp>
+      <p:sp>
+        <p:nvSpPr>
+          <p:cNvPr id="10" name="TextBox 9"/>
           <p:cNvSpPr txBox="1"/>
           <p:nvPr/>
         </p:nvSpPr>
@@ -4936,7 +5117,7 @@
               </a:defRPr>
             </a:pPr>
             <a:r>
-              <a:t>1 / 16</a:t>
+              <a:t>1 / 18</a:t>
             </a:r>
           </a:p>
         </p:txBody>
@@ -5378,7 +5559,7 @@
               </a:defRPr>
             </a:pPr>
             <a:r>
-              <a:t>10 / 16</a:t>
+              <a:t>10 / 18</a:t>
             </a:r>
           </a:p>
         </p:txBody>
@@ -6021,7 +6202,7 @@
               </a:defRPr>
             </a:pPr>
             <a:r>
-              <a:t>11 / 16</a:t>
+              <a:t>11 / 18</a:t>
             </a:r>
           </a:p>
         </p:txBody>
@@ -6287,7 +6468,7 @@
               </a:defRPr>
             </a:pPr>
             <a:r>
-              <a:t>12 / 16</a:t>
+              <a:t>12 / 18</a:t>
             </a:r>
           </a:p>
         </p:txBody>
@@ -6486,7 +6667,7 @@
               </a:defRPr>
             </a:pPr>
             <a:r>
-              <a:t>Fake demo data</a:t>
+              <a:t>Fake demo person</a:t>
             </a:r>
           </a:p>
           <a:p>
@@ -6499,7 +6680,7 @@
               </a:defRPr>
             </a:pPr>
             <a:r>
-              <a:t>A one-click sample document (Republic of Pineapple) — demos never touch real data.</a:t>
+              <a:t>One click fills a fake person (Pineapple Pete) into the AI assistant — no real data.</a:t>
             </a:r>
           </a:p>
         </p:txBody>
@@ -6930,7 +7111,7 @@
               </a:defRPr>
             </a:pPr>
             <a:r>
-              <a:t>13 / 16</a:t>
+              <a:t>13 / 18</a:t>
             </a:r>
           </a:p>
         </p:txBody>
@@ -7031,7 +7212,7 @@
               </a:defRPr>
             </a:pPr>
             <a:r>
-              <a:t>ROADMAP</a:t>
+              <a:t>POWERED BY CHATGPT ENTERPRISE</a:t>
             </a:r>
           </a:p>
         </p:txBody>
@@ -7070,38 +7251,187 @@
               </a:defRPr>
             </a:pPr>
             <a:r>
-              <a:t>From prototype to production</a:t>
-            </a:r>
-          </a:p>
-        </p:txBody>
-      </p:sp>
-      <p:sp>
-        <p:nvSpPr>
-          <p:cNvPr id="5" name="TextBox 4"/>
-          <p:cNvSpPr txBox="1"/>
+              <a:t>How ChatGPT Enterprise is used</a:t>
+            </a:r>
+          </a:p>
+        </p:txBody>
+      </p:sp>
+      <p:sp>
+        <p:nvSpPr>
+          <p:cNvPr id="5" name="Rounded Rectangle 4"/>
+          <p:cNvSpPr/>
           <p:nvPr/>
         </p:nvSpPr>
         <p:spPr>
           <a:xfrm>
             <a:off x="868680" y="2651760"/>
-            <a:ext cx="10424160" cy="3840480"/>
+            <a:ext cx="5029200" cy="1371600"/>
+          </a:xfrm>
+          <a:prstGeom prst="roundRect">
+            <a:avLst>
+              <a:gd name="adj" fmla="val 6000"/>
+            </a:avLst>
+          </a:prstGeom>
+          <a:solidFill>
+            <a:srgbClr val="F4F6F8"/>
+          </a:solidFill>
+          <a:ln>
+            <a:noFill/>
+          </a:ln>
+          <a:effectLst/>
+        </p:spPr>
+        <p:style>
+          <a:lnRef idx="1">
+            <a:schemeClr val="accent1"/>
+          </a:lnRef>
+          <a:fillRef idx="3">
+            <a:schemeClr val="accent1"/>
+          </a:fillRef>
+          <a:effectRef idx="2">
+            <a:schemeClr val="accent1"/>
+          </a:effectRef>
+          <a:fontRef idx="minor">
+            <a:schemeClr val="lt1"/>
+          </a:fontRef>
+        </p:style>
+        <p:txBody>
+          <a:bodyPr rtlCol="0" anchor="ctr" wrap="square" lIns="274320" rIns="182880" tIns="137160"/>
+          <a:lstStyle/>
+          <a:p>
+            <a:pPr algn="ctr">
+              <a:spcAft>
+                <a:spcPts val="300"/>
+              </a:spcAft>
+              <a:defRPr sz="1500" b="1">
+                <a:solidFill>
+                  <a:srgbClr val="18418A"/>
+                </a:solidFill>
+                <a:latin typeface="Arial"/>
+              </a:defRPr>
+            </a:pPr>
+            <a:r>
+              <a:t>Document understanding</a:t>
+            </a:r>
+          </a:p>
+          <a:p>
+            <a:pPr>
+              <a:defRPr sz="1300">
+                <a:solidFill>
+                  <a:srgbClr val="2A3442"/>
+                </a:solidFill>
+                <a:latin typeface="Arial"/>
+              </a:defRPr>
+            </a:pPr>
+            <a:r>
+              <a:t>Reads the uploaded clearance document (via OCR) and extracts the fields.</a:t>
+            </a:r>
+          </a:p>
+        </p:txBody>
+      </p:sp>
+      <p:sp>
+        <p:nvSpPr>
+          <p:cNvPr id="6" name="Rectangle 5"/>
+          <p:cNvSpPr/>
+          <p:nvPr/>
+        </p:nvSpPr>
+        <p:spPr>
+          <a:xfrm>
+            <a:off x="868680" y="2724912"/>
+            <a:ext cx="82296" cy="1225296"/>
           </a:xfrm>
           <a:prstGeom prst="rect">
             <a:avLst/>
           </a:prstGeom>
-          <a:noFill/>
-        </p:spPr>
-        <p:txBody>
-          <a:bodyPr wrap="square" anchor="t">
-            <a:normAutofit/>
-          </a:bodyPr>
-          <a:lstStyle/>
-          <a:p>
-            <a:pPr algn="l">
+          <a:solidFill>
+            <a:srgbClr val="18418A"/>
+          </a:solidFill>
+          <a:ln>
+            <a:noFill/>
+          </a:ln>
+          <a:effectLst/>
+        </p:spPr>
+        <p:style>
+          <a:lnRef idx="1">
+            <a:schemeClr val="accent1"/>
+          </a:lnRef>
+          <a:fillRef idx="3">
+            <a:schemeClr val="accent1"/>
+          </a:fillRef>
+          <a:effectRef idx="2">
+            <a:schemeClr val="accent1"/>
+          </a:effectRef>
+          <a:fontRef idx="minor">
+            <a:schemeClr val="lt1"/>
+          </a:fontRef>
+        </p:style>
+        <p:txBody>
+          <a:bodyPr rtlCol="0" anchor="ctr"/>
+          <a:lstStyle/>
+          <a:p>
+            <a:pPr algn="ctr"/>
+          </a:p>
+        </p:txBody>
+      </p:sp>
+      <p:sp>
+        <p:nvSpPr>
+          <p:cNvPr id="7" name="Rounded Rectangle 6"/>
+          <p:cNvSpPr/>
+          <p:nvPr/>
+        </p:nvSpPr>
+        <p:spPr>
+          <a:xfrm>
+            <a:off x="6355080" y="2651760"/>
+            <a:ext cx="5029200" cy="1371600"/>
+          </a:xfrm>
+          <a:prstGeom prst="roundRect">
+            <a:avLst>
+              <a:gd name="adj" fmla="val 6000"/>
+            </a:avLst>
+          </a:prstGeom>
+          <a:solidFill>
+            <a:srgbClr val="F4F6F8"/>
+          </a:solidFill>
+          <a:ln>
+            <a:noFill/>
+          </a:ln>
+          <a:effectLst/>
+        </p:spPr>
+        <p:style>
+          <a:lnRef idx="1">
+            <a:schemeClr val="accent1"/>
+          </a:lnRef>
+          <a:fillRef idx="3">
+            <a:schemeClr val="accent1"/>
+          </a:fillRef>
+          <a:effectRef idx="2">
+            <a:schemeClr val="accent1"/>
+          </a:effectRef>
+          <a:fontRef idx="minor">
+            <a:schemeClr val="lt1"/>
+          </a:fontRef>
+        </p:style>
+        <p:txBody>
+          <a:bodyPr rtlCol="0" anchor="ctr" wrap="square" lIns="274320" rIns="182880" tIns="137160"/>
+          <a:lstStyle/>
+          <a:p>
+            <a:pPr algn="ctr">
               <a:spcAft>
-                <a:spcPts val="1000"/>
+                <a:spcPts val="300"/>
               </a:spcAft>
-              <a:defRPr sz="1800" b="0">
+              <a:defRPr sz="1500" b="1">
+                <a:solidFill>
+                  <a:srgbClr val="18418A"/>
+                </a:solidFill>
+                <a:latin typeface="Arial"/>
+              </a:defRPr>
+            </a:pPr>
+            <a:r>
+              <a:t>Structured extraction</a:t>
+            </a:r>
+          </a:p>
+          <a:p>
+            <a:pPr>
+              <a:defRPr sz="1300">
                 <a:solidFill>
                   <a:srgbClr val="2A3442"/>
                 </a:solidFill>
@@ -7109,15 +7439,115 @@
               </a:defRPr>
             </a:pPr>
             <a:r>
-              <a:t>•   Real email sending (SMTP/API) with delivery receipts.</a:t>
-            </a:r>
-          </a:p>
-          <a:p>
-            <a:pPr algn="l">
+              <a:t>Fills the form from a pasted email or message, constrained to a strict schema.</a:t>
+            </a:r>
+          </a:p>
+        </p:txBody>
+      </p:sp>
+      <p:sp>
+        <p:nvSpPr>
+          <p:cNvPr id="8" name="Rectangle 7"/>
+          <p:cNvSpPr/>
+          <p:nvPr/>
+        </p:nvSpPr>
+        <p:spPr>
+          <a:xfrm>
+            <a:off x="6355080" y="2724912"/>
+            <a:ext cx="82296" cy="1225296"/>
+          </a:xfrm>
+          <a:prstGeom prst="rect">
+            <a:avLst/>
+          </a:prstGeom>
+          <a:solidFill>
+            <a:srgbClr val="18418A"/>
+          </a:solidFill>
+          <a:ln>
+            <a:noFill/>
+          </a:ln>
+          <a:effectLst/>
+        </p:spPr>
+        <p:style>
+          <a:lnRef idx="1">
+            <a:schemeClr val="accent1"/>
+          </a:lnRef>
+          <a:fillRef idx="3">
+            <a:schemeClr val="accent1"/>
+          </a:fillRef>
+          <a:effectRef idx="2">
+            <a:schemeClr val="accent1"/>
+          </a:effectRef>
+          <a:fontRef idx="minor">
+            <a:schemeClr val="lt1"/>
+          </a:fontRef>
+        </p:style>
+        <p:txBody>
+          <a:bodyPr rtlCol="0" anchor="ctr"/>
+          <a:lstStyle/>
+          <a:p>
+            <a:pPr algn="ctr"/>
+          </a:p>
+        </p:txBody>
+      </p:sp>
+      <p:sp>
+        <p:nvSpPr>
+          <p:cNvPr id="9" name="Rounded Rectangle 8"/>
+          <p:cNvSpPr/>
+          <p:nvPr/>
+        </p:nvSpPr>
+        <p:spPr>
+          <a:xfrm>
+            <a:off x="868680" y="4343400"/>
+            <a:ext cx="5029200" cy="1371600"/>
+          </a:xfrm>
+          <a:prstGeom prst="roundRect">
+            <a:avLst>
+              <a:gd name="adj" fmla="val 6000"/>
+            </a:avLst>
+          </a:prstGeom>
+          <a:solidFill>
+            <a:srgbClr val="F4F6F8"/>
+          </a:solidFill>
+          <a:ln>
+            <a:noFill/>
+          </a:ln>
+          <a:effectLst/>
+        </p:spPr>
+        <p:style>
+          <a:lnRef idx="1">
+            <a:schemeClr val="accent1"/>
+          </a:lnRef>
+          <a:fillRef idx="3">
+            <a:schemeClr val="accent1"/>
+          </a:fillRef>
+          <a:effectRef idx="2">
+            <a:schemeClr val="accent1"/>
+          </a:effectRef>
+          <a:fontRef idx="minor">
+            <a:schemeClr val="lt1"/>
+          </a:fontRef>
+        </p:style>
+        <p:txBody>
+          <a:bodyPr rtlCol="0" anchor="ctr" wrap="square" lIns="274320" rIns="182880" tIns="137160"/>
+          <a:lstStyle/>
+          <a:p>
+            <a:pPr algn="ctr">
               <a:spcAft>
-                <a:spcPts val="1000"/>
+                <a:spcPts val="300"/>
               </a:spcAft>
-              <a:defRPr sz="1800" b="0">
+              <a:defRPr sz="1500" b="1">
+                <a:solidFill>
+                  <a:srgbClr val="18418A"/>
+                </a:solidFill>
+                <a:latin typeface="Arial"/>
+              </a:defRPr>
+            </a:pPr>
+            <a:r>
+              <a:t>Drafting</a:t>
+            </a:r>
+          </a:p>
+          <a:p>
+            <a:pPr>
+              <a:defRPr sz="1300">
                 <a:solidFill>
                   <a:srgbClr val="2A3442"/>
                 </a:solidFill>
@@ -7125,15 +7555,115 @@
               </a:defRPr>
             </a:pPr>
             <a:r>
-              <a:t>•   Live project-register integration and SSO / role-based access.</a:t>
-            </a:r>
-          </a:p>
-          <a:p>
-            <a:pPr algn="l">
+              <a:t>Turns short notes into a clear 'Nature of Involvement' sentence.</a:t>
+            </a:r>
+          </a:p>
+        </p:txBody>
+      </p:sp>
+      <p:sp>
+        <p:nvSpPr>
+          <p:cNvPr id="10" name="Rectangle 9"/>
+          <p:cNvSpPr/>
+          <p:nvPr/>
+        </p:nvSpPr>
+        <p:spPr>
+          <a:xfrm>
+            <a:off x="868680" y="4416552"/>
+            <a:ext cx="82296" cy="1225296"/>
+          </a:xfrm>
+          <a:prstGeom prst="rect">
+            <a:avLst/>
+          </a:prstGeom>
+          <a:solidFill>
+            <a:srgbClr val="009E73"/>
+          </a:solidFill>
+          <a:ln>
+            <a:noFill/>
+          </a:ln>
+          <a:effectLst/>
+        </p:spPr>
+        <p:style>
+          <a:lnRef idx="1">
+            <a:schemeClr val="accent1"/>
+          </a:lnRef>
+          <a:fillRef idx="3">
+            <a:schemeClr val="accent1"/>
+          </a:fillRef>
+          <a:effectRef idx="2">
+            <a:schemeClr val="accent1"/>
+          </a:effectRef>
+          <a:fontRef idx="minor">
+            <a:schemeClr val="lt1"/>
+          </a:fontRef>
+        </p:style>
+        <p:txBody>
+          <a:bodyPr rtlCol="0" anchor="ctr"/>
+          <a:lstStyle/>
+          <a:p>
+            <a:pPr algn="ctr"/>
+          </a:p>
+        </p:txBody>
+      </p:sp>
+      <p:sp>
+        <p:nvSpPr>
+          <p:cNvPr id="11" name="Rounded Rectangle 10"/>
+          <p:cNvSpPr/>
+          <p:nvPr/>
+        </p:nvSpPr>
+        <p:spPr>
+          <a:xfrm>
+            <a:off x="6355080" y="4343400"/>
+            <a:ext cx="5029200" cy="1371600"/>
+          </a:xfrm>
+          <a:prstGeom prst="roundRect">
+            <a:avLst>
+              <a:gd name="adj" fmla="val 6000"/>
+            </a:avLst>
+          </a:prstGeom>
+          <a:solidFill>
+            <a:srgbClr val="F4F6F8"/>
+          </a:solidFill>
+          <a:ln>
+            <a:noFill/>
+          </a:ln>
+          <a:effectLst/>
+        </p:spPr>
+        <p:style>
+          <a:lnRef idx="1">
+            <a:schemeClr val="accent1"/>
+          </a:lnRef>
+          <a:fillRef idx="3">
+            <a:schemeClr val="accent1"/>
+          </a:fillRef>
+          <a:effectRef idx="2">
+            <a:schemeClr val="accent1"/>
+          </a:effectRef>
+          <a:fontRef idx="minor">
+            <a:schemeClr val="lt1"/>
+          </a:fontRef>
+        </p:style>
+        <p:txBody>
+          <a:bodyPr rtlCol="0" anchor="ctr" wrap="square" lIns="274320" rIns="182880" tIns="137160"/>
+          <a:lstStyle/>
+          <a:p>
+            <a:pPr algn="ctr">
               <a:spcAft>
-                <a:spcPts val="1000"/>
+                <a:spcPts val="300"/>
               </a:spcAft>
-              <a:defRPr sz="1800" b="0">
+              <a:defRPr sz="1500" b="1">
+                <a:solidFill>
+                  <a:srgbClr val="18418A"/>
+                </a:solidFill>
+                <a:latin typeface="Arial"/>
+              </a:defRPr>
+            </a:pPr>
+            <a:r>
+              <a:t>Access &amp; governance</a:t>
+            </a:r>
+          </a:p>
+          <a:p>
+            <a:pPr>
+              <a:defRPr sz="1300">
                 <a:solidFill>
                   <a:srgbClr val="2A3442"/>
                 </a:solidFill>
@@ -7141,46 +7671,58 @@
               </a:defRPr>
             </a:pPr>
             <a:r>
-              <a:t>•   Audit trail and submission tracking.</a:t>
-            </a:r>
-          </a:p>
-          <a:p>
-            <a:pPr algn="l">
-              <a:spcAft>
-                <a:spcPts val="1000"/>
-              </a:spcAft>
-              <a:defRPr sz="1800" b="0">
-                <a:solidFill>
-                  <a:srgbClr val="2A3442"/>
-                </a:solidFill>
-                <a:latin typeface="Arial"/>
-              </a:defRPr>
-            </a:pPr>
-            <a:r>
-              <a:t>•   Multiple clearance rows per applicant; category-aware routing.</a:t>
-            </a:r>
-          </a:p>
-          <a:p>
-            <a:pPr algn="l">
-              <a:spcAft>
-                <a:spcPts val="1000"/>
-              </a:spcAft>
-              <a:defRPr sz="1800" b="0">
-                <a:solidFill>
-                  <a:srgbClr val="2A3442"/>
-                </a:solidFill>
-                <a:latin typeface="Arial"/>
-              </a:defRPr>
-            </a:pPr>
-            <a:r>
-              <a:t>•   Analytics: time-to-clearance, error rates, bottlenecks.</a:t>
-            </a:r>
-          </a:p>
-        </p:txBody>
-      </p:sp>
-      <p:sp>
-        <p:nvSpPr>
-          <p:cNvPr id="6" name="TextBox 5"/>
+              <a:t>Called through the org's OpenAI API Platform (org/project), locked to the approved provider. No training on our data.</a:t>
+            </a:r>
+          </a:p>
+        </p:txBody>
+      </p:sp>
+      <p:sp>
+        <p:nvSpPr>
+          <p:cNvPr id="12" name="Rectangle 11"/>
+          <p:cNvSpPr/>
+          <p:nvPr/>
+        </p:nvSpPr>
+        <p:spPr>
+          <a:xfrm>
+            <a:off x="6355080" y="4416552"/>
+            <a:ext cx="82296" cy="1225296"/>
+          </a:xfrm>
+          <a:prstGeom prst="rect">
+            <a:avLst/>
+          </a:prstGeom>
+          <a:solidFill>
+            <a:srgbClr val="F26522"/>
+          </a:solidFill>
+          <a:ln>
+            <a:noFill/>
+          </a:ln>
+          <a:effectLst/>
+        </p:spPr>
+        <p:style>
+          <a:lnRef idx="1">
+            <a:schemeClr val="accent1"/>
+          </a:lnRef>
+          <a:fillRef idx="3">
+            <a:schemeClr val="accent1"/>
+          </a:fillRef>
+          <a:effectRef idx="2">
+            <a:schemeClr val="accent1"/>
+          </a:effectRef>
+          <a:fontRef idx="minor">
+            <a:schemeClr val="lt1"/>
+          </a:fontRef>
+        </p:style>
+        <p:txBody>
+          <a:bodyPr rtlCol="0" anchor="ctr"/>
+          <a:lstStyle/>
+          <a:p>
+            <a:pPr algn="ctr"/>
+          </a:p>
+        </p:txBody>
+      </p:sp>
+      <p:sp>
+        <p:nvSpPr>
+          <p:cNvPr id="13" name="TextBox 12"/>
           <p:cNvSpPr txBox="1"/>
           <p:nvPr/>
         </p:nvSpPr>
@@ -7212,7 +7754,7 @@
               </a:defRPr>
             </a:pPr>
             <a:r>
-              <a:t>14 / 16</a:t>
+              <a:t>14 / 18</a:t>
             </a:r>
           </a:p>
         </p:txBody>
@@ -7313,7 +7855,7 @@
               </a:defRPr>
             </a:pPr>
             <a:r>
-              <a:t>RISKS &amp; MITIGATIONS</a:t>
+              <a:t>IMPORTANT</a:t>
             </a:r>
           </a:p>
         </p:txBody>
@@ -7352,187 +7894,38 @@
               </a:defRPr>
             </a:pPr>
             <a:r>
-              <a:t>Handled deliberately</a:t>
-            </a:r>
-          </a:p>
-        </p:txBody>
-      </p:sp>
-      <p:sp>
-        <p:nvSpPr>
-          <p:cNvPr id="5" name="Rounded Rectangle 4"/>
-          <p:cNvSpPr/>
+              <a:t>This is a prototype</a:t>
+            </a:r>
+          </a:p>
+        </p:txBody>
+      </p:sp>
+      <p:sp>
+        <p:nvSpPr>
+          <p:cNvPr id="5" name="TextBox 4"/>
+          <p:cNvSpPr txBox="1"/>
           <p:nvPr/>
         </p:nvSpPr>
         <p:spPr>
           <a:xfrm>
             <a:off x="868680" y="2651760"/>
-            <a:ext cx="5029200" cy="1371600"/>
-          </a:xfrm>
-          <a:prstGeom prst="roundRect">
-            <a:avLst>
-              <a:gd name="adj" fmla="val 6000"/>
-            </a:avLst>
-          </a:prstGeom>
-          <a:solidFill>
-            <a:srgbClr val="F4F6F8"/>
-          </a:solidFill>
-          <a:ln>
-            <a:noFill/>
-          </a:ln>
-          <a:effectLst/>
-        </p:spPr>
-        <p:style>
-          <a:lnRef idx="1">
-            <a:schemeClr val="accent1"/>
-          </a:lnRef>
-          <a:fillRef idx="3">
-            <a:schemeClr val="accent1"/>
-          </a:fillRef>
-          <a:effectRef idx="2">
-            <a:schemeClr val="accent1"/>
-          </a:effectRef>
-          <a:fontRef idx="minor">
-            <a:schemeClr val="lt1"/>
-          </a:fontRef>
-        </p:style>
-        <p:txBody>
-          <a:bodyPr rtlCol="0" anchor="ctr" wrap="square" lIns="274320" rIns="182880" tIns="137160"/>
-          <a:lstStyle/>
-          <a:p>
-            <a:pPr algn="ctr">
-              <a:spcAft>
-                <a:spcPts val="300"/>
-              </a:spcAft>
-              <a:defRPr sz="1500" b="1">
-                <a:solidFill>
-                  <a:srgbClr val="18418A"/>
-                </a:solidFill>
-                <a:latin typeface="Arial"/>
-              </a:defRPr>
-            </a:pPr>
-            <a:r>
-              <a:t>Sensitive data</a:t>
-            </a:r>
-          </a:p>
-          <a:p>
-            <a:pPr>
-              <a:defRPr sz="1300">
-                <a:solidFill>
-                  <a:srgbClr val="2A3442"/>
-                </a:solidFill>
-                <a:latin typeface="Arial"/>
-              </a:defRPr>
-            </a:pPr>
-            <a:r>
-              <a:t>Local model option; access codes; minimal retention.</a:t>
-            </a:r>
-          </a:p>
-        </p:txBody>
-      </p:sp>
-      <p:sp>
-        <p:nvSpPr>
-          <p:cNvPr id="6" name="Rectangle 5"/>
-          <p:cNvSpPr/>
-          <p:nvPr/>
-        </p:nvSpPr>
-        <p:spPr>
-          <a:xfrm>
-            <a:off x="868680" y="2724912"/>
-            <a:ext cx="82296" cy="1225296"/>
+            <a:ext cx="10424160" cy="3840480"/>
           </a:xfrm>
           <a:prstGeom prst="rect">
             <a:avLst/>
           </a:prstGeom>
-          <a:solidFill>
-            <a:srgbClr val="F26522"/>
-          </a:solidFill>
-          <a:ln>
-            <a:noFill/>
-          </a:ln>
-          <a:effectLst/>
-        </p:spPr>
-        <p:style>
-          <a:lnRef idx="1">
-            <a:schemeClr val="accent1"/>
-          </a:lnRef>
-          <a:fillRef idx="3">
-            <a:schemeClr val="accent1"/>
-          </a:fillRef>
-          <a:effectRef idx="2">
-            <a:schemeClr val="accent1"/>
-          </a:effectRef>
-          <a:fontRef idx="minor">
-            <a:schemeClr val="lt1"/>
-          </a:fontRef>
-        </p:style>
-        <p:txBody>
-          <a:bodyPr rtlCol="0" anchor="ctr"/>
-          <a:lstStyle/>
-          <a:p>
-            <a:pPr algn="ctr"/>
-          </a:p>
-        </p:txBody>
-      </p:sp>
-      <p:sp>
-        <p:nvSpPr>
-          <p:cNvPr id="7" name="Rounded Rectangle 6"/>
-          <p:cNvSpPr/>
-          <p:nvPr/>
-        </p:nvSpPr>
-        <p:spPr>
-          <a:xfrm>
-            <a:off x="6355080" y="2651760"/>
-            <a:ext cx="5029200" cy="1371600"/>
-          </a:xfrm>
-          <a:prstGeom prst="roundRect">
-            <a:avLst>
-              <a:gd name="adj" fmla="val 6000"/>
-            </a:avLst>
-          </a:prstGeom>
-          <a:solidFill>
-            <a:srgbClr val="F4F6F8"/>
-          </a:solidFill>
-          <a:ln>
-            <a:noFill/>
-          </a:ln>
-          <a:effectLst/>
-        </p:spPr>
-        <p:style>
-          <a:lnRef idx="1">
-            <a:schemeClr val="accent1"/>
-          </a:lnRef>
-          <a:fillRef idx="3">
-            <a:schemeClr val="accent1"/>
-          </a:fillRef>
-          <a:effectRef idx="2">
-            <a:schemeClr val="accent1"/>
-          </a:effectRef>
-          <a:fontRef idx="minor">
-            <a:schemeClr val="lt1"/>
-          </a:fontRef>
-        </p:style>
-        <p:txBody>
-          <a:bodyPr rtlCol="0" anchor="ctr" wrap="square" lIns="274320" rIns="182880" tIns="137160"/>
-          <a:lstStyle/>
-          <a:p>
-            <a:pPr algn="ctr">
+          <a:noFill/>
+        </p:spPr>
+        <p:txBody>
+          <a:bodyPr wrap="square" anchor="t">
+            <a:normAutofit/>
+          </a:bodyPr>
+          <a:lstStyle/>
+          <a:p>
+            <a:pPr algn="l">
               <a:spcAft>
-                <a:spcPts val="300"/>
+                <a:spcPts val="1000"/>
               </a:spcAft>
-              <a:defRPr sz="1500" b="1">
-                <a:solidFill>
-                  <a:srgbClr val="18418A"/>
-                </a:solidFill>
-                <a:latin typeface="Arial"/>
-              </a:defRPr>
-            </a:pPr>
-            <a:r>
-              <a:t>Model accuracy</a:t>
-            </a:r>
-          </a:p>
-          <a:p>
-            <a:pPr>
-              <a:defRPr sz="1300">
+              <a:defRPr sz="1800" b="0">
                 <a:solidFill>
                   <a:srgbClr val="2A3442"/>
                 </a:solidFill>
@@ -7540,115 +7933,15 @@
               </a:defRPr>
             </a:pPr>
             <a:r>
-              <a:t>Schema constraints + deterministic parsing + human review.</a:t>
-            </a:r>
-          </a:p>
-        </p:txBody>
-      </p:sp>
-      <p:sp>
-        <p:nvSpPr>
-          <p:cNvPr id="8" name="Rectangle 7"/>
-          <p:cNvSpPr/>
-          <p:nvPr/>
-        </p:nvSpPr>
-        <p:spPr>
-          <a:xfrm>
-            <a:off x="6355080" y="2724912"/>
-            <a:ext cx="82296" cy="1225296"/>
-          </a:xfrm>
-          <a:prstGeom prst="rect">
-            <a:avLst/>
-          </a:prstGeom>
-          <a:solidFill>
-            <a:srgbClr val="F26522"/>
-          </a:solidFill>
-          <a:ln>
-            <a:noFill/>
-          </a:ln>
-          <a:effectLst/>
-        </p:spPr>
-        <p:style>
-          <a:lnRef idx="1">
-            <a:schemeClr val="accent1"/>
-          </a:lnRef>
-          <a:fillRef idx="3">
-            <a:schemeClr val="accent1"/>
-          </a:fillRef>
-          <a:effectRef idx="2">
-            <a:schemeClr val="accent1"/>
-          </a:effectRef>
-          <a:fontRef idx="minor">
-            <a:schemeClr val="lt1"/>
-          </a:fontRef>
-        </p:style>
-        <p:txBody>
-          <a:bodyPr rtlCol="0" anchor="ctr"/>
-          <a:lstStyle/>
-          <a:p>
-            <a:pPr algn="ctr"/>
-          </a:p>
-        </p:txBody>
-      </p:sp>
-      <p:sp>
-        <p:nvSpPr>
-          <p:cNvPr id="9" name="Rounded Rectangle 8"/>
-          <p:cNvSpPr/>
-          <p:nvPr/>
-        </p:nvSpPr>
-        <p:spPr>
-          <a:xfrm>
-            <a:off x="868680" y="4343400"/>
-            <a:ext cx="5029200" cy="1371600"/>
-          </a:xfrm>
-          <a:prstGeom prst="roundRect">
-            <a:avLst>
-              <a:gd name="adj" fmla="val 6000"/>
-            </a:avLst>
-          </a:prstGeom>
-          <a:solidFill>
-            <a:srgbClr val="F4F6F8"/>
-          </a:solidFill>
-          <a:ln>
-            <a:noFill/>
-          </a:ln>
-          <a:effectLst/>
-        </p:spPr>
-        <p:style>
-          <a:lnRef idx="1">
-            <a:schemeClr val="accent1"/>
-          </a:lnRef>
-          <a:fillRef idx="3">
-            <a:schemeClr val="accent1"/>
-          </a:fillRef>
-          <a:effectRef idx="2">
-            <a:schemeClr val="accent1"/>
-          </a:effectRef>
-          <a:fontRef idx="minor">
-            <a:schemeClr val="lt1"/>
-          </a:fontRef>
-        </p:style>
-        <p:txBody>
-          <a:bodyPr rtlCol="0" anchor="ctr" wrap="square" lIns="274320" rIns="182880" tIns="137160"/>
-          <a:lstStyle/>
-          <a:p>
-            <a:pPr algn="ctr">
+              <a:t>•   A proof of concept to show what is possible — not a production system.</a:t>
+            </a:r>
+          </a:p>
+          <a:p>
+            <a:pPr algn="l">
               <a:spcAft>
-                <a:spcPts val="300"/>
+                <a:spcPts val="1000"/>
               </a:spcAft>
-              <a:defRPr sz="1500" b="1">
-                <a:solidFill>
-                  <a:srgbClr val="18418A"/>
-                </a:solidFill>
-                <a:latin typeface="Arial"/>
-              </a:defRPr>
-            </a:pPr>
-            <a:r>
-              <a:t>Adoption</a:t>
-            </a:r>
-          </a:p>
-          <a:p>
-            <a:pPr>
-              <a:defRPr sz="1300">
+              <a:defRPr sz="1800" b="0">
                 <a:solidFill>
                   <a:srgbClr val="2A3442"/>
                 </a:solidFill>
@@ -7656,115 +7949,15 @@
               </a:defRPr>
             </a:pPr>
             <a:r>
-              <a:t>Works alongside the existing Excel template; low training.</a:t>
-            </a:r>
-          </a:p>
-        </p:txBody>
-      </p:sp>
-      <p:sp>
-        <p:nvSpPr>
-          <p:cNvPr id="10" name="Rectangle 9"/>
-          <p:cNvSpPr/>
-          <p:nvPr/>
-        </p:nvSpPr>
-        <p:spPr>
-          <a:xfrm>
-            <a:off x="868680" y="4416552"/>
-            <a:ext cx="82296" cy="1225296"/>
-          </a:xfrm>
-          <a:prstGeom prst="rect">
-            <a:avLst/>
-          </a:prstGeom>
-          <a:solidFill>
-            <a:srgbClr val="18418A"/>
-          </a:solidFill>
-          <a:ln>
-            <a:noFill/>
-          </a:ln>
-          <a:effectLst/>
-        </p:spPr>
-        <p:style>
-          <a:lnRef idx="1">
-            <a:schemeClr val="accent1"/>
-          </a:lnRef>
-          <a:fillRef idx="3">
-            <a:schemeClr val="accent1"/>
-          </a:fillRef>
-          <a:effectRef idx="2">
-            <a:schemeClr val="accent1"/>
-          </a:effectRef>
-          <a:fontRef idx="minor">
-            <a:schemeClr val="lt1"/>
-          </a:fontRef>
-        </p:style>
-        <p:txBody>
-          <a:bodyPr rtlCol="0" anchor="ctr"/>
-          <a:lstStyle/>
-          <a:p>
-            <a:pPr algn="ctr"/>
-          </a:p>
-        </p:txBody>
-      </p:sp>
-      <p:sp>
-        <p:nvSpPr>
-          <p:cNvPr id="11" name="Rounded Rectangle 10"/>
-          <p:cNvSpPr/>
-          <p:nvPr/>
-        </p:nvSpPr>
-        <p:spPr>
-          <a:xfrm>
-            <a:off x="6355080" y="4343400"/>
-            <a:ext cx="5029200" cy="1371600"/>
-          </a:xfrm>
-          <a:prstGeom prst="roundRect">
-            <a:avLst>
-              <a:gd name="adj" fmla="val 6000"/>
-            </a:avLst>
-          </a:prstGeom>
-          <a:solidFill>
-            <a:srgbClr val="F4F6F8"/>
-          </a:solidFill>
-          <a:ln>
-            <a:noFill/>
-          </a:ln>
-          <a:effectLst/>
-        </p:spPr>
-        <p:style>
-          <a:lnRef idx="1">
-            <a:schemeClr val="accent1"/>
-          </a:lnRef>
-          <a:fillRef idx="3">
-            <a:schemeClr val="accent1"/>
-          </a:fillRef>
-          <a:effectRef idx="2">
-            <a:schemeClr val="accent1"/>
-          </a:effectRef>
-          <a:fontRef idx="minor">
-            <a:schemeClr val="lt1"/>
-          </a:fontRef>
-        </p:style>
-        <p:txBody>
-          <a:bodyPr rtlCol="0" anchor="ctr" wrap="square" lIns="274320" rIns="182880" tIns="137160"/>
-          <a:lstStyle/>
-          <a:p>
-            <a:pPr algn="ctr">
+              <a:t>•   Security, data-handling and compliance are deliberately NOT addressed at this stage.</a:t>
+            </a:r>
+          </a:p>
+          <a:p>
+            <a:pPr algn="l">
               <a:spcAft>
-                <a:spcPts val="300"/>
+                <a:spcPts val="1000"/>
               </a:spcAft>
-              <a:defRPr sz="1500" b="1">
-                <a:solidFill>
-                  <a:srgbClr val="18418A"/>
-                </a:solidFill>
-                <a:latin typeface="Arial"/>
-              </a:defRPr>
-            </a:pPr>
-            <a:r>
-              <a:t>Process variation</a:t>
-            </a:r>
-          </a:p>
-          <a:p>
-            <a:pPr>
-              <a:defRPr sz="1300">
+              <a:defRPr sz="1800" b="0">
                 <a:solidFill>
                   <a:srgbClr val="2A3442"/>
                 </a:solidFill>
@@ -7772,58 +7965,30 @@
               </a:defRPr>
             </a:pPr>
             <a:r>
-              <a:t>Routing is configurable per project.</a:t>
-            </a:r>
-          </a:p>
-        </p:txBody>
-      </p:sp>
-      <p:sp>
-        <p:nvSpPr>
-          <p:cNvPr id="12" name="Rectangle 11"/>
-          <p:cNvSpPr/>
-          <p:nvPr/>
-        </p:nvSpPr>
-        <p:spPr>
-          <a:xfrm>
-            <a:off x="6355080" y="4416552"/>
-            <a:ext cx="82296" cy="1225296"/>
-          </a:xfrm>
-          <a:prstGeom prst="rect">
-            <a:avLst/>
-          </a:prstGeom>
-          <a:solidFill>
-            <a:srgbClr val="18418A"/>
-          </a:solidFill>
-          <a:ln>
-            <a:noFill/>
-          </a:ln>
-          <a:effectLst/>
-        </p:spPr>
-        <p:style>
-          <a:lnRef idx="1">
-            <a:schemeClr val="accent1"/>
-          </a:lnRef>
-          <a:fillRef idx="3">
-            <a:schemeClr val="accent1"/>
-          </a:fillRef>
-          <a:effectRef idx="2">
-            <a:schemeClr val="accent1"/>
-          </a:effectRef>
-          <a:fontRef idx="minor">
-            <a:schemeClr val="lt1"/>
-          </a:fontRef>
-        </p:style>
-        <p:txBody>
-          <a:bodyPr rtlCol="0" anchor="ctr"/>
-          <a:lstStyle/>
-          <a:p>
-            <a:pPr algn="ctr"/>
-          </a:p>
-        </p:txBody>
-      </p:sp>
-      <p:sp>
-        <p:nvSpPr>
-          <p:cNvPr id="13" name="TextBox 12"/>
+              <a:t>•   Demos use fake data only; no real clearance information should be entered.</a:t>
+            </a:r>
+          </a:p>
+          <a:p>
+            <a:pPr algn="l">
+              <a:spcAft>
+                <a:spcPts val="1000"/>
+              </a:spcAft>
+              <a:defRPr sz="1800" b="0">
+                <a:solidFill>
+                  <a:srgbClr val="2A3442"/>
+                </a:solidFill>
+                <a:latin typeface="Arial"/>
+              </a:defRPr>
+            </a:pPr>
+            <a:r>
+              <a:t>•   Any real rollout would require security review, access control and data governance first.</a:t>
+            </a:r>
+          </a:p>
+        </p:txBody>
+      </p:sp>
+      <p:sp>
+        <p:nvSpPr>
+          <p:cNvPr id="6" name="TextBox 5"/>
           <p:cNvSpPr txBox="1"/>
           <p:nvPr/>
         </p:nvSpPr>
@@ -7855,7 +8020,7 @@
               </a:defRPr>
             </a:pPr>
             <a:r>
-              <a:t>15 / 16</a:t>
+              <a:t>15 / 18</a:t>
             </a:r>
           </a:p>
         </p:txBody>
@@ -7956,6 +8121,931 @@
               </a:defRPr>
             </a:pPr>
             <a:r>
+              <a:t>ROADMAP</a:t>
+            </a:r>
+          </a:p>
+        </p:txBody>
+      </p:sp>
+      <p:sp>
+        <p:nvSpPr>
+          <p:cNvPr id="4" name="TextBox 3"/>
+          <p:cNvSpPr txBox="1"/>
+          <p:nvPr/>
+        </p:nvSpPr>
+        <p:spPr>
+          <a:xfrm>
+            <a:off x="822960" y="1051560"/>
+            <a:ext cx="10607040" cy="1280160"/>
+          </a:xfrm>
+          <a:prstGeom prst="rect">
+            <a:avLst/>
+          </a:prstGeom>
+          <a:noFill/>
+        </p:spPr>
+        <p:txBody>
+          <a:bodyPr wrap="square" anchor="t">
+            <a:normAutofit/>
+          </a:bodyPr>
+          <a:lstStyle/>
+          <a:p>
+            <a:pPr algn="l">
+              <a:spcAft>
+                <a:spcPts val="0"/>
+              </a:spcAft>
+              <a:defRPr sz="3400" b="1">
+                <a:solidFill>
+                  <a:srgbClr val="18418A"/>
+                </a:solidFill>
+                <a:latin typeface="Arial"/>
+              </a:defRPr>
+            </a:pPr>
+            <a:r>
+              <a:t>From prototype to production</a:t>
+            </a:r>
+          </a:p>
+        </p:txBody>
+      </p:sp>
+      <p:sp>
+        <p:nvSpPr>
+          <p:cNvPr id="5" name="TextBox 4"/>
+          <p:cNvSpPr txBox="1"/>
+          <p:nvPr/>
+        </p:nvSpPr>
+        <p:spPr>
+          <a:xfrm>
+            <a:off x="868680" y="2651760"/>
+            <a:ext cx="10424160" cy="3840480"/>
+          </a:xfrm>
+          <a:prstGeom prst="rect">
+            <a:avLst/>
+          </a:prstGeom>
+          <a:noFill/>
+        </p:spPr>
+        <p:txBody>
+          <a:bodyPr wrap="square" anchor="t">
+            <a:normAutofit/>
+          </a:bodyPr>
+          <a:lstStyle/>
+          <a:p>
+            <a:pPr algn="l">
+              <a:spcAft>
+                <a:spcPts val="1000"/>
+              </a:spcAft>
+              <a:defRPr sz="1700" b="0">
+                <a:solidFill>
+                  <a:srgbClr val="2A3442"/>
+                </a:solidFill>
+                <a:latin typeface="Arial"/>
+              </a:defRPr>
+            </a:pPr>
+            <a:r>
+              <a:t>•   Singpass login — verify identity and auto-fill personal details instantly.</a:t>
+            </a:r>
+          </a:p>
+          <a:p>
+            <a:pPr algn="l">
+              <a:spcAft>
+                <a:spcPts val="1000"/>
+              </a:spcAft>
+              <a:defRPr sz="1700" b="0">
+                <a:solidFill>
+                  <a:srgbClr val="2A3442"/>
+                </a:solidFill>
+                <a:latin typeface="Arial"/>
+              </a:defRPr>
+            </a:pPr>
+            <a:r>
+              <a:t>•   Real email sending (SMTP/API) with delivery receipts.</a:t>
+            </a:r>
+          </a:p>
+          <a:p>
+            <a:pPr algn="l">
+              <a:spcAft>
+                <a:spcPts val="1000"/>
+              </a:spcAft>
+              <a:defRPr sz="1700" b="0">
+                <a:solidFill>
+                  <a:srgbClr val="2A3442"/>
+                </a:solidFill>
+                <a:latin typeface="Arial"/>
+              </a:defRPr>
+            </a:pPr>
+            <a:r>
+              <a:t>•   Live project-register integration and role-based access.</a:t>
+            </a:r>
+          </a:p>
+          <a:p>
+            <a:pPr algn="l">
+              <a:spcAft>
+                <a:spcPts val="1000"/>
+              </a:spcAft>
+              <a:defRPr sz="1700" b="0">
+                <a:solidFill>
+                  <a:srgbClr val="2A3442"/>
+                </a:solidFill>
+                <a:latin typeface="Arial"/>
+              </a:defRPr>
+            </a:pPr>
+            <a:r>
+              <a:t>•   Security, data-handling and compliance review.</a:t>
+            </a:r>
+          </a:p>
+          <a:p>
+            <a:pPr algn="l">
+              <a:spcAft>
+                <a:spcPts val="1000"/>
+              </a:spcAft>
+              <a:defRPr sz="1700" b="0">
+                <a:solidFill>
+                  <a:srgbClr val="2A3442"/>
+                </a:solidFill>
+                <a:latin typeface="Arial"/>
+              </a:defRPr>
+            </a:pPr>
+            <a:r>
+              <a:t>•   Audit trail, submission tracking and analytics.</a:t>
+            </a:r>
+          </a:p>
+        </p:txBody>
+      </p:sp>
+      <p:sp>
+        <p:nvSpPr>
+          <p:cNvPr id="6" name="TextBox 5"/>
+          <p:cNvSpPr txBox="1"/>
+          <p:nvPr/>
+        </p:nvSpPr>
+        <p:spPr>
+          <a:xfrm>
+            <a:off x="10607040" y="6355080"/>
+            <a:ext cx="1188720" cy="365760"/>
+          </a:xfrm>
+          <a:prstGeom prst="rect">
+            <a:avLst/>
+          </a:prstGeom>
+          <a:noFill/>
+        </p:spPr>
+        <p:txBody>
+          <a:bodyPr wrap="square" anchor="t">
+            <a:normAutofit/>
+          </a:bodyPr>
+          <a:lstStyle/>
+          <a:p>
+            <a:pPr algn="r">
+              <a:spcAft>
+                <a:spcPts val="0"/>
+              </a:spcAft>
+              <a:defRPr sz="1000" b="0">
+                <a:solidFill>
+                  <a:srgbClr val="5A6472"/>
+                </a:solidFill>
+                <a:latin typeface="Arial"/>
+              </a:defRPr>
+            </a:pPr>
+            <a:r>
+              <a:t>16 / 18</a:t>
+            </a:r>
+          </a:p>
+        </p:txBody>
+      </p:sp>
+    </p:spTree>
+  </p:cSld>
+  <p:clrMapOvr>
+    <a:masterClrMapping/>
+  </p:clrMapOvr>
+</p:sld>
+</file>
+
+<file path=ppt/slides/slide17.xml><?xml version="1.0" encoding="utf-8"?>
+<p:sld xmlns:a="http://schemas.openxmlformats.org/drawingml/2006/main" xmlns:p="http://schemas.openxmlformats.org/presentationml/2006/main" xmlns:r="http://schemas.openxmlformats.org/officeDocument/2006/relationships">
+  <p:cSld>
+    <p:spTree>
+      <p:nvGrpSpPr>
+        <p:cNvPr id="1" name=""/>
+        <p:cNvGrpSpPr/>
+        <p:nvPr/>
+      </p:nvGrpSpPr>
+      <p:grpSpPr/>
+      <p:sp>
+        <p:nvSpPr>
+          <p:cNvPr id="2" name="Rectangle 1"/>
+          <p:cNvSpPr/>
+          <p:nvPr/>
+        </p:nvSpPr>
+        <p:spPr>
+          <a:xfrm>
+            <a:off x="0" y="0"/>
+            <a:ext cx="164592" cy="6858000"/>
+          </a:xfrm>
+          <a:prstGeom prst="rect">
+            <a:avLst/>
+          </a:prstGeom>
+          <a:solidFill>
+            <a:srgbClr val="18418A"/>
+          </a:solidFill>
+          <a:ln>
+            <a:noFill/>
+          </a:ln>
+          <a:effectLst/>
+        </p:spPr>
+        <p:style>
+          <a:lnRef idx="1">
+            <a:schemeClr val="accent1"/>
+          </a:lnRef>
+          <a:fillRef idx="3">
+            <a:schemeClr val="accent1"/>
+          </a:fillRef>
+          <a:effectRef idx="2">
+            <a:schemeClr val="accent1"/>
+          </a:effectRef>
+          <a:fontRef idx="minor">
+            <a:schemeClr val="lt1"/>
+          </a:fontRef>
+        </p:style>
+        <p:txBody>
+          <a:bodyPr rtlCol="0" anchor="ctr"/>
+          <a:lstStyle/>
+          <a:p>
+            <a:pPr algn="ctr"/>
+          </a:p>
+        </p:txBody>
+      </p:sp>
+      <p:sp>
+        <p:nvSpPr>
+          <p:cNvPr id="3" name="TextBox 2"/>
+          <p:cNvSpPr txBox="1"/>
+          <p:nvPr/>
+        </p:nvSpPr>
+        <p:spPr>
+          <a:xfrm>
+            <a:off x="822960" y="640080"/>
+            <a:ext cx="10515600" cy="457200"/>
+          </a:xfrm>
+          <a:prstGeom prst="rect">
+            <a:avLst/>
+          </a:prstGeom>
+          <a:noFill/>
+        </p:spPr>
+        <p:txBody>
+          <a:bodyPr wrap="square" anchor="t">
+            <a:normAutofit/>
+          </a:bodyPr>
+          <a:lstStyle/>
+          <a:p>
+            <a:pPr algn="l">
+              <a:spcAft>
+                <a:spcPts val="0"/>
+              </a:spcAft>
+              <a:defRPr sz="1400" b="1">
+                <a:solidFill>
+                  <a:srgbClr val="F26522"/>
+                </a:solidFill>
+                <a:latin typeface="Arial"/>
+              </a:defRPr>
+            </a:pPr>
+            <a:r>
+              <a:t>RISKS &amp; MITIGATIONS</a:t>
+            </a:r>
+          </a:p>
+        </p:txBody>
+      </p:sp>
+      <p:sp>
+        <p:nvSpPr>
+          <p:cNvPr id="4" name="TextBox 3"/>
+          <p:cNvSpPr txBox="1"/>
+          <p:nvPr/>
+        </p:nvSpPr>
+        <p:spPr>
+          <a:xfrm>
+            <a:off x="822960" y="1051560"/>
+            <a:ext cx="10607040" cy="1280160"/>
+          </a:xfrm>
+          <a:prstGeom prst="rect">
+            <a:avLst/>
+          </a:prstGeom>
+          <a:noFill/>
+        </p:spPr>
+        <p:txBody>
+          <a:bodyPr wrap="square" anchor="t">
+            <a:normAutofit/>
+          </a:bodyPr>
+          <a:lstStyle/>
+          <a:p>
+            <a:pPr algn="l">
+              <a:spcAft>
+                <a:spcPts val="0"/>
+              </a:spcAft>
+              <a:defRPr sz="3400" b="1">
+                <a:solidFill>
+                  <a:srgbClr val="18418A"/>
+                </a:solidFill>
+                <a:latin typeface="Arial"/>
+              </a:defRPr>
+            </a:pPr>
+            <a:r>
+              <a:t>Handled deliberately</a:t>
+            </a:r>
+          </a:p>
+        </p:txBody>
+      </p:sp>
+      <p:sp>
+        <p:nvSpPr>
+          <p:cNvPr id="5" name="Rounded Rectangle 4"/>
+          <p:cNvSpPr/>
+          <p:nvPr/>
+        </p:nvSpPr>
+        <p:spPr>
+          <a:xfrm>
+            <a:off x="868680" y="2651760"/>
+            <a:ext cx="5029200" cy="1371600"/>
+          </a:xfrm>
+          <a:prstGeom prst="roundRect">
+            <a:avLst>
+              <a:gd name="adj" fmla="val 6000"/>
+            </a:avLst>
+          </a:prstGeom>
+          <a:solidFill>
+            <a:srgbClr val="F4F6F8"/>
+          </a:solidFill>
+          <a:ln>
+            <a:noFill/>
+          </a:ln>
+          <a:effectLst/>
+        </p:spPr>
+        <p:style>
+          <a:lnRef idx="1">
+            <a:schemeClr val="accent1"/>
+          </a:lnRef>
+          <a:fillRef idx="3">
+            <a:schemeClr val="accent1"/>
+          </a:fillRef>
+          <a:effectRef idx="2">
+            <a:schemeClr val="accent1"/>
+          </a:effectRef>
+          <a:fontRef idx="minor">
+            <a:schemeClr val="lt1"/>
+          </a:fontRef>
+        </p:style>
+        <p:txBody>
+          <a:bodyPr rtlCol="0" anchor="ctr" wrap="square" lIns="274320" rIns="182880" tIns="137160"/>
+          <a:lstStyle/>
+          <a:p>
+            <a:pPr algn="ctr">
+              <a:spcAft>
+                <a:spcPts val="300"/>
+              </a:spcAft>
+              <a:defRPr sz="1500" b="1">
+                <a:solidFill>
+                  <a:srgbClr val="18418A"/>
+                </a:solidFill>
+                <a:latin typeface="Arial"/>
+              </a:defRPr>
+            </a:pPr>
+            <a:r>
+              <a:t>Sensitive data</a:t>
+            </a:r>
+          </a:p>
+          <a:p>
+            <a:pPr>
+              <a:defRPr sz="1300">
+                <a:solidFill>
+                  <a:srgbClr val="2A3442"/>
+                </a:solidFill>
+                <a:latin typeface="Arial"/>
+              </a:defRPr>
+            </a:pPr>
+            <a:r>
+              <a:t>Local model option; access codes; minimal retention.</a:t>
+            </a:r>
+          </a:p>
+        </p:txBody>
+      </p:sp>
+      <p:sp>
+        <p:nvSpPr>
+          <p:cNvPr id="6" name="Rectangle 5"/>
+          <p:cNvSpPr/>
+          <p:nvPr/>
+        </p:nvSpPr>
+        <p:spPr>
+          <a:xfrm>
+            <a:off x="868680" y="2724912"/>
+            <a:ext cx="82296" cy="1225296"/>
+          </a:xfrm>
+          <a:prstGeom prst="rect">
+            <a:avLst/>
+          </a:prstGeom>
+          <a:solidFill>
+            <a:srgbClr val="F26522"/>
+          </a:solidFill>
+          <a:ln>
+            <a:noFill/>
+          </a:ln>
+          <a:effectLst/>
+        </p:spPr>
+        <p:style>
+          <a:lnRef idx="1">
+            <a:schemeClr val="accent1"/>
+          </a:lnRef>
+          <a:fillRef idx="3">
+            <a:schemeClr val="accent1"/>
+          </a:fillRef>
+          <a:effectRef idx="2">
+            <a:schemeClr val="accent1"/>
+          </a:effectRef>
+          <a:fontRef idx="minor">
+            <a:schemeClr val="lt1"/>
+          </a:fontRef>
+        </p:style>
+        <p:txBody>
+          <a:bodyPr rtlCol="0" anchor="ctr"/>
+          <a:lstStyle/>
+          <a:p>
+            <a:pPr algn="ctr"/>
+          </a:p>
+        </p:txBody>
+      </p:sp>
+      <p:sp>
+        <p:nvSpPr>
+          <p:cNvPr id="7" name="Rounded Rectangle 6"/>
+          <p:cNvSpPr/>
+          <p:nvPr/>
+        </p:nvSpPr>
+        <p:spPr>
+          <a:xfrm>
+            <a:off x="6355080" y="2651760"/>
+            <a:ext cx="5029200" cy="1371600"/>
+          </a:xfrm>
+          <a:prstGeom prst="roundRect">
+            <a:avLst>
+              <a:gd name="adj" fmla="val 6000"/>
+            </a:avLst>
+          </a:prstGeom>
+          <a:solidFill>
+            <a:srgbClr val="F4F6F8"/>
+          </a:solidFill>
+          <a:ln>
+            <a:noFill/>
+          </a:ln>
+          <a:effectLst/>
+        </p:spPr>
+        <p:style>
+          <a:lnRef idx="1">
+            <a:schemeClr val="accent1"/>
+          </a:lnRef>
+          <a:fillRef idx="3">
+            <a:schemeClr val="accent1"/>
+          </a:fillRef>
+          <a:effectRef idx="2">
+            <a:schemeClr val="accent1"/>
+          </a:effectRef>
+          <a:fontRef idx="minor">
+            <a:schemeClr val="lt1"/>
+          </a:fontRef>
+        </p:style>
+        <p:txBody>
+          <a:bodyPr rtlCol="0" anchor="ctr" wrap="square" lIns="274320" rIns="182880" tIns="137160"/>
+          <a:lstStyle/>
+          <a:p>
+            <a:pPr algn="ctr">
+              <a:spcAft>
+                <a:spcPts val="300"/>
+              </a:spcAft>
+              <a:defRPr sz="1500" b="1">
+                <a:solidFill>
+                  <a:srgbClr val="18418A"/>
+                </a:solidFill>
+                <a:latin typeface="Arial"/>
+              </a:defRPr>
+            </a:pPr>
+            <a:r>
+              <a:t>Model accuracy</a:t>
+            </a:r>
+          </a:p>
+          <a:p>
+            <a:pPr>
+              <a:defRPr sz="1300">
+                <a:solidFill>
+                  <a:srgbClr val="2A3442"/>
+                </a:solidFill>
+                <a:latin typeface="Arial"/>
+              </a:defRPr>
+            </a:pPr>
+            <a:r>
+              <a:t>Schema constraints + deterministic parsing + human review.</a:t>
+            </a:r>
+          </a:p>
+        </p:txBody>
+      </p:sp>
+      <p:sp>
+        <p:nvSpPr>
+          <p:cNvPr id="8" name="Rectangle 7"/>
+          <p:cNvSpPr/>
+          <p:nvPr/>
+        </p:nvSpPr>
+        <p:spPr>
+          <a:xfrm>
+            <a:off x="6355080" y="2724912"/>
+            <a:ext cx="82296" cy="1225296"/>
+          </a:xfrm>
+          <a:prstGeom prst="rect">
+            <a:avLst/>
+          </a:prstGeom>
+          <a:solidFill>
+            <a:srgbClr val="F26522"/>
+          </a:solidFill>
+          <a:ln>
+            <a:noFill/>
+          </a:ln>
+          <a:effectLst/>
+        </p:spPr>
+        <p:style>
+          <a:lnRef idx="1">
+            <a:schemeClr val="accent1"/>
+          </a:lnRef>
+          <a:fillRef idx="3">
+            <a:schemeClr val="accent1"/>
+          </a:fillRef>
+          <a:effectRef idx="2">
+            <a:schemeClr val="accent1"/>
+          </a:effectRef>
+          <a:fontRef idx="minor">
+            <a:schemeClr val="lt1"/>
+          </a:fontRef>
+        </p:style>
+        <p:txBody>
+          <a:bodyPr rtlCol="0" anchor="ctr"/>
+          <a:lstStyle/>
+          <a:p>
+            <a:pPr algn="ctr"/>
+          </a:p>
+        </p:txBody>
+      </p:sp>
+      <p:sp>
+        <p:nvSpPr>
+          <p:cNvPr id="9" name="Rounded Rectangle 8"/>
+          <p:cNvSpPr/>
+          <p:nvPr/>
+        </p:nvSpPr>
+        <p:spPr>
+          <a:xfrm>
+            <a:off x="868680" y="4343400"/>
+            <a:ext cx="5029200" cy="1371600"/>
+          </a:xfrm>
+          <a:prstGeom prst="roundRect">
+            <a:avLst>
+              <a:gd name="adj" fmla="val 6000"/>
+            </a:avLst>
+          </a:prstGeom>
+          <a:solidFill>
+            <a:srgbClr val="F4F6F8"/>
+          </a:solidFill>
+          <a:ln>
+            <a:noFill/>
+          </a:ln>
+          <a:effectLst/>
+        </p:spPr>
+        <p:style>
+          <a:lnRef idx="1">
+            <a:schemeClr val="accent1"/>
+          </a:lnRef>
+          <a:fillRef idx="3">
+            <a:schemeClr val="accent1"/>
+          </a:fillRef>
+          <a:effectRef idx="2">
+            <a:schemeClr val="accent1"/>
+          </a:effectRef>
+          <a:fontRef idx="minor">
+            <a:schemeClr val="lt1"/>
+          </a:fontRef>
+        </p:style>
+        <p:txBody>
+          <a:bodyPr rtlCol="0" anchor="ctr" wrap="square" lIns="274320" rIns="182880" tIns="137160"/>
+          <a:lstStyle/>
+          <a:p>
+            <a:pPr algn="ctr">
+              <a:spcAft>
+                <a:spcPts val="300"/>
+              </a:spcAft>
+              <a:defRPr sz="1500" b="1">
+                <a:solidFill>
+                  <a:srgbClr val="18418A"/>
+                </a:solidFill>
+                <a:latin typeface="Arial"/>
+              </a:defRPr>
+            </a:pPr>
+            <a:r>
+              <a:t>Adoption</a:t>
+            </a:r>
+          </a:p>
+          <a:p>
+            <a:pPr>
+              <a:defRPr sz="1300">
+                <a:solidFill>
+                  <a:srgbClr val="2A3442"/>
+                </a:solidFill>
+                <a:latin typeface="Arial"/>
+              </a:defRPr>
+            </a:pPr>
+            <a:r>
+              <a:t>Works alongside the existing Excel template; low training.</a:t>
+            </a:r>
+          </a:p>
+        </p:txBody>
+      </p:sp>
+      <p:sp>
+        <p:nvSpPr>
+          <p:cNvPr id="10" name="Rectangle 9"/>
+          <p:cNvSpPr/>
+          <p:nvPr/>
+        </p:nvSpPr>
+        <p:spPr>
+          <a:xfrm>
+            <a:off x="868680" y="4416552"/>
+            <a:ext cx="82296" cy="1225296"/>
+          </a:xfrm>
+          <a:prstGeom prst="rect">
+            <a:avLst/>
+          </a:prstGeom>
+          <a:solidFill>
+            <a:srgbClr val="18418A"/>
+          </a:solidFill>
+          <a:ln>
+            <a:noFill/>
+          </a:ln>
+          <a:effectLst/>
+        </p:spPr>
+        <p:style>
+          <a:lnRef idx="1">
+            <a:schemeClr val="accent1"/>
+          </a:lnRef>
+          <a:fillRef idx="3">
+            <a:schemeClr val="accent1"/>
+          </a:fillRef>
+          <a:effectRef idx="2">
+            <a:schemeClr val="accent1"/>
+          </a:effectRef>
+          <a:fontRef idx="minor">
+            <a:schemeClr val="lt1"/>
+          </a:fontRef>
+        </p:style>
+        <p:txBody>
+          <a:bodyPr rtlCol="0" anchor="ctr"/>
+          <a:lstStyle/>
+          <a:p>
+            <a:pPr algn="ctr"/>
+          </a:p>
+        </p:txBody>
+      </p:sp>
+      <p:sp>
+        <p:nvSpPr>
+          <p:cNvPr id="11" name="Rounded Rectangle 10"/>
+          <p:cNvSpPr/>
+          <p:nvPr/>
+        </p:nvSpPr>
+        <p:spPr>
+          <a:xfrm>
+            <a:off x="6355080" y="4343400"/>
+            <a:ext cx="5029200" cy="1371600"/>
+          </a:xfrm>
+          <a:prstGeom prst="roundRect">
+            <a:avLst>
+              <a:gd name="adj" fmla="val 6000"/>
+            </a:avLst>
+          </a:prstGeom>
+          <a:solidFill>
+            <a:srgbClr val="F4F6F8"/>
+          </a:solidFill>
+          <a:ln>
+            <a:noFill/>
+          </a:ln>
+          <a:effectLst/>
+        </p:spPr>
+        <p:style>
+          <a:lnRef idx="1">
+            <a:schemeClr val="accent1"/>
+          </a:lnRef>
+          <a:fillRef idx="3">
+            <a:schemeClr val="accent1"/>
+          </a:fillRef>
+          <a:effectRef idx="2">
+            <a:schemeClr val="accent1"/>
+          </a:effectRef>
+          <a:fontRef idx="minor">
+            <a:schemeClr val="lt1"/>
+          </a:fontRef>
+        </p:style>
+        <p:txBody>
+          <a:bodyPr rtlCol="0" anchor="ctr" wrap="square" lIns="274320" rIns="182880" tIns="137160"/>
+          <a:lstStyle/>
+          <a:p>
+            <a:pPr algn="ctr">
+              <a:spcAft>
+                <a:spcPts val="300"/>
+              </a:spcAft>
+              <a:defRPr sz="1500" b="1">
+                <a:solidFill>
+                  <a:srgbClr val="18418A"/>
+                </a:solidFill>
+                <a:latin typeface="Arial"/>
+              </a:defRPr>
+            </a:pPr>
+            <a:r>
+              <a:t>Process variation</a:t>
+            </a:r>
+          </a:p>
+          <a:p>
+            <a:pPr>
+              <a:defRPr sz="1300">
+                <a:solidFill>
+                  <a:srgbClr val="2A3442"/>
+                </a:solidFill>
+                <a:latin typeface="Arial"/>
+              </a:defRPr>
+            </a:pPr>
+            <a:r>
+              <a:t>Routing is configurable per project.</a:t>
+            </a:r>
+          </a:p>
+        </p:txBody>
+      </p:sp>
+      <p:sp>
+        <p:nvSpPr>
+          <p:cNvPr id="12" name="Rectangle 11"/>
+          <p:cNvSpPr/>
+          <p:nvPr/>
+        </p:nvSpPr>
+        <p:spPr>
+          <a:xfrm>
+            <a:off x="6355080" y="4416552"/>
+            <a:ext cx="82296" cy="1225296"/>
+          </a:xfrm>
+          <a:prstGeom prst="rect">
+            <a:avLst/>
+          </a:prstGeom>
+          <a:solidFill>
+            <a:srgbClr val="18418A"/>
+          </a:solidFill>
+          <a:ln>
+            <a:noFill/>
+          </a:ln>
+          <a:effectLst/>
+        </p:spPr>
+        <p:style>
+          <a:lnRef idx="1">
+            <a:schemeClr val="accent1"/>
+          </a:lnRef>
+          <a:fillRef idx="3">
+            <a:schemeClr val="accent1"/>
+          </a:fillRef>
+          <a:effectRef idx="2">
+            <a:schemeClr val="accent1"/>
+          </a:effectRef>
+          <a:fontRef idx="minor">
+            <a:schemeClr val="lt1"/>
+          </a:fontRef>
+        </p:style>
+        <p:txBody>
+          <a:bodyPr rtlCol="0" anchor="ctr"/>
+          <a:lstStyle/>
+          <a:p>
+            <a:pPr algn="ctr"/>
+          </a:p>
+        </p:txBody>
+      </p:sp>
+      <p:sp>
+        <p:nvSpPr>
+          <p:cNvPr id="13" name="TextBox 12"/>
+          <p:cNvSpPr txBox="1"/>
+          <p:nvPr/>
+        </p:nvSpPr>
+        <p:spPr>
+          <a:xfrm>
+            <a:off x="10607040" y="6355080"/>
+            <a:ext cx="1188720" cy="365760"/>
+          </a:xfrm>
+          <a:prstGeom prst="rect">
+            <a:avLst/>
+          </a:prstGeom>
+          <a:noFill/>
+        </p:spPr>
+        <p:txBody>
+          <a:bodyPr wrap="square" anchor="t">
+            <a:normAutofit/>
+          </a:bodyPr>
+          <a:lstStyle/>
+          <a:p>
+            <a:pPr algn="r">
+              <a:spcAft>
+                <a:spcPts val="0"/>
+              </a:spcAft>
+              <a:defRPr sz="1000" b="0">
+                <a:solidFill>
+                  <a:srgbClr val="5A6472"/>
+                </a:solidFill>
+                <a:latin typeface="Arial"/>
+              </a:defRPr>
+            </a:pPr>
+            <a:r>
+              <a:t>17 / 18</a:t>
+            </a:r>
+          </a:p>
+        </p:txBody>
+      </p:sp>
+    </p:spTree>
+  </p:cSld>
+  <p:clrMapOvr>
+    <a:masterClrMapping/>
+  </p:clrMapOvr>
+</p:sld>
+</file>
+
+<file path=ppt/slides/slide18.xml><?xml version="1.0" encoding="utf-8"?>
+<p:sld xmlns:a="http://schemas.openxmlformats.org/drawingml/2006/main" xmlns:p="http://schemas.openxmlformats.org/presentationml/2006/main" xmlns:r="http://schemas.openxmlformats.org/officeDocument/2006/relationships">
+  <p:cSld>
+    <p:spTree>
+      <p:nvGrpSpPr>
+        <p:cNvPr id="1" name=""/>
+        <p:cNvGrpSpPr/>
+        <p:nvPr/>
+      </p:nvGrpSpPr>
+      <p:grpSpPr/>
+      <p:sp>
+        <p:nvSpPr>
+          <p:cNvPr id="2" name="Rectangle 1"/>
+          <p:cNvSpPr/>
+          <p:nvPr/>
+        </p:nvSpPr>
+        <p:spPr>
+          <a:xfrm>
+            <a:off x="0" y="0"/>
+            <a:ext cx="164592" cy="6858000"/>
+          </a:xfrm>
+          <a:prstGeom prst="rect">
+            <a:avLst/>
+          </a:prstGeom>
+          <a:solidFill>
+            <a:srgbClr val="18418A"/>
+          </a:solidFill>
+          <a:ln>
+            <a:noFill/>
+          </a:ln>
+          <a:effectLst/>
+        </p:spPr>
+        <p:style>
+          <a:lnRef idx="1">
+            <a:schemeClr val="accent1"/>
+          </a:lnRef>
+          <a:fillRef idx="3">
+            <a:schemeClr val="accent1"/>
+          </a:fillRef>
+          <a:effectRef idx="2">
+            <a:schemeClr val="accent1"/>
+          </a:effectRef>
+          <a:fontRef idx="minor">
+            <a:schemeClr val="lt1"/>
+          </a:fontRef>
+        </p:style>
+        <p:txBody>
+          <a:bodyPr rtlCol="0" anchor="ctr"/>
+          <a:lstStyle/>
+          <a:p>
+            <a:pPr algn="ctr"/>
+          </a:p>
+        </p:txBody>
+      </p:sp>
+      <p:sp>
+        <p:nvSpPr>
+          <p:cNvPr id="3" name="TextBox 2"/>
+          <p:cNvSpPr txBox="1"/>
+          <p:nvPr/>
+        </p:nvSpPr>
+        <p:spPr>
+          <a:xfrm>
+            <a:off x="822960" y="640080"/>
+            <a:ext cx="10515600" cy="457200"/>
+          </a:xfrm>
+          <a:prstGeom prst="rect">
+            <a:avLst/>
+          </a:prstGeom>
+          <a:noFill/>
+        </p:spPr>
+        <p:txBody>
+          <a:bodyPr wrap="square" anchor="t">
+            <a:normAutofit/>
+          </a:bodyPr>
+          <a:lstStyle/>
+          <a:p>
+            <a:pPr algn="l">
+              <a:spcAft>
+                <a:spcPts val="0"/>
+              </a:spcAft>
+              <a:defRPr sz="1400" b="1">
+                <a:solidFill>
+                  <a:srgbClr val="F26522"/>
+                </a:solidFill>
+                <a:latin typeface="Arial"/>
+              </a:defRPr>
+            </a:pPr>
+            <a:r>
               <a:t>THE ASK</a:t>
             </a:r>
           </a:p>
@@ -8121,7 +9211,7 @@
               </a:defRPr>
             </a:pPr>
             <a:r>
-              <a:t>16 / 16</a:t>
+              <a:t>18 / 18</a:t>
             </a:r>
           </a:p>
         </p:txBody>
@@ -8419,7 +9509,7 @@
               </a:defRPr>
             </a:pPr>
             <a:r>
-              <a:t>2 / 16</a:t>
+              <a:t>2 / 18</a:t>
             </a:r>
           </a:p>
         </p:txBody>
@@ -9062,7 +10152,7 @@
               </a:defRPr>
             </a:pPr>
             <a:r>
-              <a:t>3 / 16</a:t>
+              <a:t>3 / 18</a:t>
             </a:r>
           </a:p>
         </p:txBody>
@@ -9344,7 +10434,7 @@
               </a:defRPr>
             </a:pPr>
             <a:r>
-              <a:t>4 / 16</a:t>
+              <a:t>4 / 18</a:t>
             </a:r>
           </a:p>
         </p:txBody>
@@ -10219,7 +11309,7 @@
               </a:defRPr>
             </a:pPr>
             <a:r>
-              <a:t>5 / 16</a:t>
+              <a:t>5 / 18</a:t>
             </a:r>
           </a:p>
         </p:txBody>
@@ -10746,7 +11836,7 @@
               </a:defRPr>
             </a:pPr>
             <a:r>
-              <a:t>6 / 16</a:t>
+              <a:t>6 / 18</a:t>
             </a:r>
           </a:p>
         </p:txBody>
@@ -11060,7 +12150,7 @@
               </a:defRPr>
             </a:pPr>
             <a:r>
-              <a:t>7 / 16</a:t>
+              <a:t>7 / 18</a:t>
             </a:r>
           </a:p>
         </p:txBody>
@@ -11703,7 +12793,7 @@
               </a:defRPr>
             </a:pPr>
             <a:r>
-              <a:t>8 / 16</a:t>
+              <a:t>8 / 18</a:t>
             </a:r>
           </a:p>
         </p:txBody>
@@ -12346,7 +13436,7 @@
               </a:defRPr>
             </a:pPr>
             <a:r>
-              <a:t>9 / 16</a:t>
+              <a:t>9 / 18</a:t>
             </a:r>
           </a:p>
         </p:txBody>

</xml_diff>

<commit_message>
Remove ChatGPT Enterprise references; document actual AI stack (OpenCode Go / Gemini / Ollama + Tesseract) in deck, README and secrets
</commit_message>
<xml_diff>
--- a/pitch/acres_pitch_deck.pptx
+++ b/pitch/acres_pitch_deck.pptx
@@ -799,7 +799,7 @@
           <a:lstStyle/>
           <a:p>
             <a:r>
-              <a:t>Demos use a fake person, the AI is ready for the enterprise provider, and a mobile code confirms the submission.</a:t>
+              <a:t>Demos use a fake person, and a mobile code confirms the submission.</a:t>
             </a:r>
           </a:p>
         </p:txBody>
@@ -869,7 +869,7 @@
           <a:lstStyle/>
           <a:p>
             <a:r>
-              <a:t>ChatGPT Enterprise (via the org's OpenAI API Platform) does the document understanding, structured field extraction and drafting — locked to the approved provider, with no training on our data.</a:t>
+              <a:t>The AI runs on OpenCode Go (default), Google Gemini, or fully local Ollama, with Tesseract OCR for scanned documents.</a:t>
             </a:r>
           </a:p>
         </p:txBody>
@@ -6569,7 +6569,7 @@
               </a:defRPr>
             </a:pPr>
             <a:r>
-              <a:t>SAFE TO DEMO, READY FOR ENTERPRISE</a:t>
+              <a:t>SAFE TO DEMO</a:t>
             </a:r>
           </a:p>
         </p:txBody>
@@ -6608,7 +6608,7 @@
               </a:defRPr>
             </a:pPr>
             <a:r>
-              <a:t>No real data, no lock-in</a:t>
+              <a:t>No real data</a:t>
             </a:r>
           </a:p>
         </p:txBody>
@@ -6783,7 +6783,7 @@
               </a:defRPr>
             </a:pPr>
             <a:r>
-              <a:t>Enterprise AI</a:t>
+              <a:t>Flexible AI</a:t>
             </a:r>
           </a:p>
           <a:p>
@@ -6796,7 +6796,7 @@
               </a:defRPr>
             </a:pPr>
             <a:r>
-              <a:t>Ready for the OpenAI API Platform; lock the app to one approved provider.</a:t>
+              <a:t>Works with OpenCode Go, Google Gemini, or fully local Ollama.</a:t>
             </a:r>
           </a:p>
         </p:txBody>
@@ -7212,7 +7212,7 @@
               </a:defRPr>
             </a:pPr>
             <a:r>
-              <a:t>POWERED BY CHATGPT ENTERPRISE</a:t>
+              <a:t>AI TOOLS USED</a:t>
             </a:r>
           </a:p>
         </p:txBody>
@@ -7251,7 +7251,7 @@
               </a:defRPr>
             </a:pPr>
             <a:r>
-              <a:t>How ChatGPT Enterprise is used</a:t>
+              <a:t>The AI stack</a:t>
             </a:r>
           </a:p>
         </p:txBody>
@@ -7310,7 +7310,7 @@
               </a:defRPr>
             </a:pPr>
             <a:r>
-              <a:t>Document understanding</a:t>
+              <a:t>LLM — OpenCode Go</a:t>
             </a:r>
           </a:p>
           <a:p>
@@ -7323,7 +7323,7 @@
               </a:defRPr>
             </a:pPr>
             <a:r>
-              <a:t>Reads the uploaded clearance document (via OCR) and extracts the fields.</a:t>
+              <a:t>OpenAI-compatible API (default model deepseek-v4-flash) for understanding and drafting.</a:t>
             </a:r>
           </a:p>
         </p:txBody>
@@ -7426,7 +7426,7 @@
               </a:defRPr>
             </a:pPr>
             <a:r>
-              <a:t>Structured extraction</a:t>
+              <a:t>LLM — Google Gemini</a:t>
             </a:r>
           </a:p>
           <a:p>
@@ -7439,7 +7439,7 @@
               </a:defRPr>
             </a:pPr>
             <a:r>
-              <a:t>Fills the form from a pasted email or message, constrained to a strict schema.</a:t>
+              <a:t>Free-tier model (gemini-2.0-flash) as an alternative provider.</a:t>
             </a:r>
           </a:p>
         </p:txBody>
@@ -7542,7 +7542,7 @@
               </a:defRPr>
             </a:pPr>
             <a:r>
-              <a:t>Drafting</a:t>
+              <a:t>LLM — local Ollama</a:t>
             </a:r>
           </a:p>
           <a:p>
@@ -7555,7 +7555,7 @@
               </a:defRPr>
             </a:pPr>
             <a:r>
-              <a:t>Turns short notes into a clear 'Nature of Involvement' sentence.</a:t>
+              <a:t>Runs fully offline with llama3.1 when no cloud key is set.</a:t>
             </a:r>
           </a:p>
         </p:txBody>
@@ -7658,7 +7658,7 @@
               </a:defRPr>
             </a:pPr>
             <a:r>
-              <a:t>Access &amp; governance</a:t>
+              <a:t>OCR — Tesseract</a:t>
             </a:r>
           </a:p>
           <a:p>
@@ -7671,7 +7671,7 @@
               </a:defRPr>
             </a:pPr>
             <a:r>
-              <a:t>Called through the org's OpenAI API Platform (org/project), locked to the approved provider. No training on our data.</a:t>
+              <a:t>Reads scanned PDFs and images (via PyMuPDF + pytesseract).</a:t>
             </a:r>
           </a:p>
         </p:txBody>

</xml_diff>